<commit_message>
Reconciled Strategy with Product Plan
</commit_message>
<xml_diff>
--- a/docs/1_Integration/1b_Strategy/AccelRR8 Consortium Non-Profit Organization Strategy.pptx
+++ b/docs/1_Integration/1b_Strategy/AccelRR8 Consortium Non-Profit Organization Strategy.pptx
@@ -5,7 +5,7 @@
     <p:sldMasterId id="2147483648" r:id="rId1"/>
   </p:sldMasterIdLst>
   <p:notesMasterIdLst>
-    <p:notesMasterId r:id="rId17"/>
+    <p:notesMasterId r:id="rId16"/>
   </p:notesMasterIdLst>
   <p:sldIdLst>
     <p:sldId id="256" r:id="rId2"/>
@@ -22,7 +22,6 @@
     <p:sldId id="406" r:id="rId13"/>
     <p:sldId id="274" r:id="rId14"/>
     <p:sldId id="417" r:id="rId15"/>
-    <p:sldId id="409" r:id="rId16"/>
   </p:sldIdLst>
   <p:sldSz cx="12192000" cy="6858000"/>
   <p:notesSz cx="6858000" cy="9144000"/>
@@ -290,7 +289,6 @@
             <p14:sldId id="406"/>
             <p14:sldId id="274"/>
             <p14:sldId id="417"/>
-            <p14:sldId id="409"/>
           </p14:sldIdLst>
         </p14:section>
       </p14:sectionLst>
@@ -299,7 +297,7 @@
       <p15:sldGuideLst xmlns:p15="http://schemas.microsoft.com/office/powerpoint/2012/main"/>
     </p:ext>
     <p:ext uri="GoogleSlidesCustomDataVersion2">
-      <go:slidesCustomData xmlns:mc="http://schemas.openxmlformats.org/markup-compatibility/2006" xmlns:mv="urn:schemas-microsoft-com:mac:vml" xmlns:c="http://schemas.openxmlformats.org/drawingml/2006/chart" xmlns:dgm="http://schemas.openxmlformats.org/drawingml/2006/diagram" xmlns:o="urn:schemas-microsoft-com:office:office" xmlns:v="urn:schemas-microsoft-com:vml" xmlns:pvml="urn:schemas-microsoft-com:office:powerpoint" xmlns:com="http://schemas.openxmlformats.org/drawingml/2006/compatibility" xmlns:p14="http://schemas.microsoft.com/office/powerpoint/2010/main" xmlns:p15="http://schemas.microsoft.com/office/powerpoint/2012/main" xmlns:ahyp="http://schemas.microsoft.com/office/drawing/2018/hyperlinkcolor" xmlns:go="http://customooxmlschemas.google.com/" xmlns="" r:id="rId35" roundtripDataSignature="AMtx7mhwEp+Eio5qReXqYqUwMP31HB0A8A=="/>
+      <go:slidesCustomData xmlns="" xmlns:go="http://customooxmlschemas.google.com/" xmlns:ahyp="http://schemas.microsoft.com/office/drawing/2018/hyperlinkcolor" xmlns:p15="http://schemas.microsoft.com/office/powerpoint/2012/main" xmlns:p14="http://schemas.microsoft.com/office/powerpoint/2010/main" xmlns:com="http://schemas.openxmlformats.org/drawingml/2006/compatibility" xmlns:pvml="urn:schemas-microsoft-com:office:powerpoint" xmlns:v="urn:schemas-microsoft-com:vml" xmlns:o="urn:schemas-microsoft-com:office:office" xmlns:dgm="http://schemas.openxmlformats.org/drawingml/2006/diagram" xmlns:c="http://schemas.openxmlformats.org/drawingml/2006/chart" xmlns:mv="urn:schemas-microsoft-com:mac:vml" xmlns:mc="http://schemas.openxmlformats.org/markup-compatibility/2006" r:id="rId35" roundtripDataSignature="AMtx7mhwEp+Eio5qReXqYqUwMP31HB0A8A=="/>
     </p:ext>
   </p:extLst>
 </p:presentation>
@@ -318,7 +316,7 @@
   <pc:docChgLst>
     <pc:chgData name="Rich Reba" userId="55db41ab6eb3f845" providerId="LiveId" clId="{0E19DA16-244C-5B50-BE0F-52911DD4CA7E}"/>
     <pc:docChg chg="undo redo custSel addSld delSld modSld sldOrd delMainMaster delSection modSection">
-      <pc:chgData name="Rich Reba" userId="55db41ab6eb3f845" providerId="LiveId" clId="{0E19DA16-244C-5B50-BE0F-52911DD4CA7E}" dt="2026-08-06T19:44:12.954" v="1286" actId="17851"/>
+      <pc:chgData name="Rich Reba" userId="55db41ab6eb3f845" providerId="LiveId" clId="{0E19DA16-244C-5B50-BE0F-52911DD4CA7E}" dt="2026-08-06T20:42:45.418" v="1287" actId="2696"/>
       <pc:docMkLst>
         <pc:docMk/>
       </pc:docMkLst>
@@ -822,8 +820,8 @@
           </ac:spMkLst>
         </pc:spChg>
       </pc:sldChg>
-      <pc:sldChg chg="delSp modSp mod ord">
-        <pc:chgData name="Rich Reba" userId="55db41ab6eb3f845" providerId="LiveId" clId="{0E19DA16-244C-5B50-BE0F-52911DD4CA7E}" dt="2026-08-06T19:13:37.974" v="1258" actId="20578"/>
+      <pc:sldChg chg="delSp modSp del mod ord">
+        <pc:chgData name="Rich Reba" userId="55db41ab6eb3f845" providerId="LiveId" clId="{0E19DA16-244C-5B50-BE0F-52911DD4CA7E}" dt="2026-08-06T20:42:45.418" v="1287" actId="2696"/>
         <pc:sldMkLst>
           <pc:docMk/>
           <pc:sldMk cId="401125609" sldId="409"/>
@@ -2000,133 +1998,6 @@
     <p:extLst>
       <p:ext uri="{BB962C8B-B14F-4D97-AF65-F5344CB8AC3E}">
         <p14:creationId xmlns:p14="http://schemas.microsoft.com/office/powerpoint/2010/main" val="2298562985"/>
-      </p:ext>
-    </p:extLst>
-  </p:cSld>
-  <p:clrMapOvr>
-    <a:masterClrMapping/>
-  </p:clrMapOvr>
-</p:notes>
-</file>
-
-<file path=ppt/notesSlides/notesSlide14.xml><?xml version="1.0" encoding="utf-8"?>
-<p:notes xmlns:a="http://schemas.openxmlformats.org/drawingml/2006/main" xmlns:r="http://schemas.openxmlformats.org/officeDocument/2006/relationships" xmlns:p="http://schemas.openxmlformats.org/presentationml/2006/main" showMasterSp="0" showMasterPhAnim="0">
-  <p:cSld>
-    <p:spTree>
-      <p:nvGrpSpPr>
-        <p:cNvPr id="1" name="Shape 92">
-          <a:extLst>
-            <a:ext uri="{FF2B5EF4-FFF2-40B4-BE49-F238E27FC236}">
-              <a16:creationId xmlns:a16="http://schemas.microsoft.com/office/drawing/2014/main" id="{FEE2389B-20BC-28BE-17DD-C7442B7B6342}"/>
-            </a:ext>
-          </a:extLst>
-        </p:cNvPr>
-        <p:cNvGrpSpPr/>
-        <p:nvPr/>
-      </p:nvGrpSpPr>
-      <p:grpSpPr>
-        <a:xfrm>
-          <a:off x="0" y="0"/>
-          <a:ext cx="0" cy="0"/>
-          <a:chOff x="0" y="0"/>
-          <a:chExt cx="0" cy="0"/>
-        </a:xfrm>
-      </p:grpSpPr>
-      <p:sp>
-        <p:nvSpPr>
-          <p:cNvPr id="93" name="Google Shape;93;p2:notes">
-            <a:extLst>
-              <a:ext uri="{FF2B5EF4-FFF2-40B4-BE49-F238E27FC236}">
-                <a16:creationId xmlns:a16="http://schemas.microsoft.com/office/drawing/2014/main" id="{5901D355-D9B0-4941-6DE8-D42A33FD2712}"/>
-              </a:ext>
-            </a:extLst>
-          </p:cNvPr>
-          <p:cNvSpPr txBox="1">
-            <a:spLocks noGrp="1"/>
-          </p:cNvSpPr>
-          <p:nvPr>
-            <p:ph type="body" idx="1"/>
-          </p:nvPr>
-        </p:nvSpPr>
-        <p:spPr>
-          <a:xfrm>
-            <a:off x="685800" y="4343400"/>
-            <a:ext cx="5486400" cy="4114800"/>
-          </a:xfrm>
-          <a:prstGeom prst="rect">
-            <a:avLst/>
-          </a:prstGeom>
-        </p:spPr>
-        <p:txBody>
-          <a:bodyPr spcFirstLastPara="1" wrap="square" lIns="91425" tIns="91425" rIns="91425" bIns="91425" anchor="t" anchorCtr="0">
-            <a:noAutofit/>
-          </a:bodyPr>
-          <a:lstStyle/>
-          <a:p>
-            <a:pPr marL="0" lvl="0" indent="0" algn="l" rtl="0">
-              <a:spcBef>
-                <a:spcPts val="0"/>
-              </a:spcBef>
-              <a:spcAft>
-                <a:spcPts val="0"/>
-              </a:spcAft>
-              <a:buNone/>
-            </a:pPr>
-            <a:endParaRPr/>
-          </a:p>
-        </p:txBody>
-      </p:sp>
-      <p:sp>
-        <p:nvSpPr>
-          <p:cNvPr id="94" name="Google Shape;94;p2:notes">
-            <a:extLst>
-              <a:ext uri="{FF2B5EF4-FFF2-40B4-BE49-F238E27FC236}">
-                <a16:creationId xmlns:a16="http://schemas.microsoft.com/office/drawing/2014/main" id="{6A26A731-D905-CACD-CC70-0AAAFAC15857}"/>
-              </a:ext>
-            </a:extLst>
-          </p:cNvPr>
-          <p:cNvSpPr>
-            <a:spLocks noGrp="1" noRot="1" noChangeAspect="1"/>
-          </p:cNvSpPr>
-          <p:nvPr>
-            <p:ph type="sldImg" idx="2"/>
-          </p:nvPr>
-        </p:nvSpPr>
-        <p:spPr>
-          <a:xfrm>
-            <a:off x="381000" y="685800"/>
-            <a:ext cx="6096000" cy="3429000"/>
-          </a:xfrm>
-          <a:custGeom>
-            <a:avLst/>
-            <a:gdLst/>
-            <a:ahLst/>
-            <a:cxnLst/>
-            <a:rect l="l" t="t" r="r" b="b"/>
-            <a:pathLst>
-              <a:path w="120000" h="120000" extrusionOk="0">
-                <a:moveTo>
-                  <a:pt x="0" y="0"/>
-                </a:moveTo>
-                <a:lnTo>
-                  <a:pt x="120000" y="0"/>
-                </a:lnTo>
-                <a:lnTo>
-                  <a:pt x="120000" y="120000"/>
-                </a:lnTo>
-                <a:lnTo>
-                  <a:pt x="0" y="120000"/>
-                </a:lnTo>
-                <a:close/>
-              </a:path>
-            </a:pathLst>
-          </a:custGeom>
-        </p:spPr>
-      </p:sp>
-    </p:spTree>
-    <p:extLst>
-      <p:ext uri="{BB962C8B-B14F-4D97-AF65-F5344CB8AC3E}">
-        <p14:creationId xmlns:p14="http://schemas.microsoft.com/office/powerpoint/2010/main" val="175047040"/>
       </p:ext>
     </p:extLst>
   </p:cSld>
@@ -17916,1571 +17787,6 @@
 </p:sld>
 </file>
 
-<file path=ppt/slides/slide15.xml><?xml version="1.0" encoding="utf-8"?>
-<p:sld xmlns:a="http://schemas.openxmlformats.org/drawingml/2006/main" xmlns:r="http://schemas.openxmlformats.org/officeDocument/2006/relationships" xmlns:p="http://schemas.openxmlformats.org/presentationml/2006/main">
-  <p:cSld>
-    <p:spTree>
-      <p:nvGrpSpPr>
-        <p:cNvPr id="1" name="Shape 95">
-          <a:extLst>
-            <a:ext uri="{FF2B5EF4-FFF2-40B4-BE49-F238E27FC236}">
-              <a16:creationId xmlns:a16="http://schemas.microsoft.com/office/drawing/2014/main" id="{9CF0030E-C778-6057-7F00-D64497814302}"/>
-            </a:ext>
-          </a:extLst>
-        </p:cNvPr>
-        <p:cNvGrpSpPr/>
-        <p:nvPr/>
-      </p:nvGrpSpPr>
-      <p:grpSpPr>
-        <a:xfrm>
-          <a:off x="0" y="0"/>
-          <a:ext cx="0" cy="0"/>
-          <a:chOff x="0" y="0"/>
-          <a:chExt cx="0" cy="0"/>
-        </a:xfrm>
-      </p:grpSpPr>
-      <p:sp>
-        <p:nvSpPr>
-          <p:cNvPr id="96" name="Google Shape;96;p2">
-            <a:extLst>
-              <a:ext uri="{FF2B5EF4-FFF2-40B4-BE49-F238E27FC236}">
-                <a16:creationId xmlns:a16="http://schemas.microsoft.com/office/drawing/2014/main" id="{213A3A61-4044-D39A-7839-F3AEFE0C296B}"/>
-              </a:ext>
-            </a:extLst>
-          </p:cNvPr>
-          <p:cNvSpPr txBox="1">
-            <a:spLocks noGrp="1"/>
-          </p:cNvSpPr>
-          <p:nvPr>
-            <p:ph type="title"/>
-          </p:nvPr>
-        </p:nvSpPr>
-        <p:spPr>
-          <a:prstGeom prst="rect">
-            <a:avLst/>
-          </a:prstGeom>
-          <a:noFill/>
-          <a:ln>
-            <a:noFill/>
-          </a:ln>
-        </p:spPr>
-        <p:txBody>
-          <a:bodyPr spcFirstLastPara="1" wrap="square" lIns="91425" tIns="45700" rIns="91425" bIns="45700" anchor="ctr" anchorCtr="0">
-            <a:normAutofit/>
-          </a:bodyPr>
-          <a:lstStyle/>
-          <a:p>
-            <a:pPr marL="0" lvl="0" indent="0" algn="l" rtl="0">
-              <a:lnSpc>
-                <a:spcPct val="90000"/>
-              </a:lnSpc>
-              <a:spcBef>
-                <a:spcPts val="0"/>
-              </a:spcBef>
-              <a:spcAft>
-                <a:spcPts val="0"/>
-              </a:spcAft>
-              <a:buClr>
-                <a:schemeClr val="dk1"/>
-              </a:buClr>
-              <a:buSzPts val="4400"/>
-              <a:buFont typeface="Calibri"/>
-              <a:buNone/>
-            </a:pPr>
-            <a:r>
-              <a:rPr lang="en-US" dirty="0"/>
-              <a:t>Horizon 1 Roadmap</a:t>
-            </a:r>
-            <a:endParaRPr dirty="0"/>
-          </a:p>
-        </p:txBody>
-      </p:sp>
-      <p:graphicFrame>
-        <p:nvGraphicFramePr>
-          <p:cNvPr id="5" name="Table 4">
-            <a:extLst>
-              <a:ext uri="{FF2B5EF4-FFF2-40B4-BE49-F238E27FC236}">
-                <a16:creationId xmlns:a16="http://schemas.microsoft.com/office/drawing/2014/main" id="{5855B0BF-5869-4C17-DDB9-4330FF90D640}"/>
-              </a:ext>
-            </a:extLst>
-          </p:cNvPr>
-          <p:cNvGraphicFramePr>
-            <a:graphicFrameLocks noGrp="1"/>
-          </p:cNvGraphicFramePr>
-          <p:nvPr>
-            <p:extLst>
-              <p:ext uri="{D42A27DB-BD31-4B8C-83A1-F6EECF244321}">
-                <p14:modId xmlns:p14="http://schemas.microsoft.com/office/powerpoint/2010/main" val="4119274897"/>
-              </p:ext>
-            </p:extLst>
-          </p:nvPr>
-        </p:nvGraphicFramePr>
-        <p:xfrm>
-          <a:off x="410934" y="1560399"/>
-          <a:ext cx="11370132" cy="4851554"/>
-        </p:xfrm>
-        <a:graphic>
-          <a:graphicData uri="http://schemas.openxmlformats.org/drawingml/2006/table">
-            <a:tbl>
-              <a:tblPr firstRow="1" bandRow="1">
-                <a:tableStyleId>{5940675A-B579-460E-94D1-54222C63F5DA}</a:tableStyleId>
-              </a:tblPr>
-              <a:tblGrid>
-                <a:gridCol w="2079172">
-                  <a:extLst>
-                    <a:ext uri="{9D8B030D-6E8A-4147-A177-3AD203B41FA5}">
-                      <a16:colId xmlns:a16="http://schemas.microsoft.com/office/drawing/2014/main" val="533583650"/>
-                    </a:ext>
-                  </a:extLst>
-                </a:gridCol>
-                <a:gridCol w="5856515">
-                  <a:extLst>
-                    <a:ext uri="{9D8B030D-6E8A-4147-A177-3AD203B41FA5}">
-                      <a16:colId xmlns:a16="http://schemas.microsoft.com/office/drawing/2014/main" val="766325045"/>
-                    </a:ext>
-                  </a:extLst>
-                </a:gridCol>
-                <a:gridCol w="3434445">
-                  <a:extLst>
-                    <a:ext uri="{9D8B030D-6E8A-4147-A177-3AD203B41FA5}">
-                      <a16:colId xmlns:a16="http://schemas.microsoft.com/office/drawing/2014/main" val="133755"/>
-                    </a:ext>
-                  </a:extLst>
-                </a:gridCol>
-              </a:tblGrid>
-              <a:tr h="315537">
-                <a:tc>
-                  <a:txBody>
-                    <a:bodyPr/>
-                    <a:lstStyle/>
-                    <a:p>
-                      <a:r>
-                        <a:rPr lang="en-US" sz="1400" b="1" dirty="0"/>
-                        <a:t>Service</a:t>
-                      </a:r>
-                    </a:p>
-                  </a:txBody>
-                  <a:tcPr>
-                    <a:lnL w="12700" cmpd="sng">
-                      <a:noFill/>
-                    </a:lnL>
-                    <a:lnR w="12700" cmpd="sng">
-                      <a:noFill/>
-                    </a:lnR>
-                    <a:lnT w="12700" cmpd="sng">
-                      <a:noFill/>
-                    </a:lnT>
-                    <a:lnB w="12700" cap="flat" cmpd="sng" algn="ctr">
-                      <a:solidFill>
-                        <a:schemeClr val="tx1"/>
-                      </a:solidFill>
-                      <a:prstDash val="solid"/>
-                      <a:round/>
-                      <a:headEnd type="none" w="med" len="med"/>
-                      <a:tailEnd type="none" w="med" len="med"/>
-                    </a:lnB>
-                    <a:lnTlToBr w="12700" cmpd="sng">
-                      <a:noFill/>
-                      <a:prstDash val="solid"/>
-                    </a:lnTlToBr>
-                    <a:lnBlToTr w="12700" cmpd="sng">
-                      <a:noFill/>
-                      <a:prstDash val="solid"/>
-                    </a:lnBlToTr>
-                  </a:tcPr>
-                </a:tc>
-                <a:tc>
-                  <a:txBody>
-                    <a:bodyPr/>
-                    <a:lstStyle/>
-                    <a:p>
-                      <a:r>
-                        <a:rPr lang="en-US" b="1" dirty="0"/>
-                        <a:t>Soon</a:t>
-                      </a:r>
-                    </a:p>
-                  </a:txBody>
-                  <a:tcPr>
-                    <a:lnL w="12700" cmpd="sng">
-                      <a:noFill/>
-                    </a:lnL>
-                    <a:lnR w="12700" cmpd="sng">
-                      <a:noFill/>
-                    </a:lnR>
-                    <a:lnT w="12700" cmpd="sng">
-                      <a:noFill/>
-                    </a:lnT>
-                    <a:lnB w="12700" cap="flat" cmpd="sng" algn="ctr">
-                      <a:solidFill>
-                        <a:schemeClr val="tx1"/>
-                      </a:solidFill>
-                      <a:prstDash val="solid"/>
-                      <a:round/>
-                      <a:headEnd type="none" w="med" len="med"/>
-                      <a:tailEnd type="none" w="med" len="med"/>
-                    </a:lnB>
-                    <a:lnTlToBr w="12700" cmpd="sng">
-                      <a:noFill/>
-                      <a:prstDash val="solid"/>
-                    </a:lnTlToBr>
-                    <a:lnBlToTr w="12700" cmpd="sng">
-                      <a:noFill/>
-                      <a:prstDash val="solid"/>
-                    </a:lnBlToTr>
-                  </a:tcPr>
-                </a:tc>
-                <a:tc>
-                  <a:txBody>
-                    <a:bodyPr/>
-                    <a:lstStyle/>
-                    <a:p>
-                      <a:r>
-                        <a:rPr lang="en-US" b="1" dirty="0"/>
-                        <a:t>When Feasible</a:t>
-                      </a:r>
-                    </a:p>
-                  </a:txBody>
-                  <a:tcPr>
-                    <a:lnL w="12700" cmpd="sng">
-                      <a:noFill/>
-                    </a:lnL>
-                    <a:lnR w="12700" cmpd="sng">
-                      <a:noFill/>
-                    </a:lnR>
-                    <a:lnT w="12700" cmpd="sng">
-                      <a:noFill/>
-                    </a:lnT>
-                    <a:lnB w="12700" cap="flat" cmpd="sng" algn="ctr">
-                      <a:solidFill>
-                        <a:schemeClr val="tx1"/>
-                      </a:solidFill>
-                      <a:prstDash val="solid"/>
-                      <a:round/>
-                      <a:headEnd type="none" w="med" len="med"/>
-                      <a:tailEnd type="none" w="med" len="med"/>
-                    </a:lnB>
-                    <a:lnTlToBr w="12700" cmpd="sng">
-                      <a:noFill/>
-                      <a:prstDash val="solid"/>
-                    </a:lnTlToBr>
-                    <a:lnBlToTr w="12700" cmpd="sng">
-                      <a:noFill/>
-                      <a:prstDash val="solid"/>
-                    </a:lnBlToTr>
-                  </a:tcPr>
-                </a:tc>
-                <a:extLst>
-                  <a:ext uri="{0D108BD9-81ED-4DB2-BD59-A6C34878D82A}">
-                    <a16:rowId xmlns:a16="http://schemas.microsoft.com/office/drawing/2014/main" val="1454970526"/>
-                  </a:ext>
-                </a:extLst>
-              </a:tr>
-              <a:tr h="900682">
-                <a:tc>
-                  <a:txBody>
-                    <a:bodyPr/>
-                    <a:lstStyle/>
-                    <a:p>
-                      <a:r>
-                        <a:rPr lang="en-US" sz="2000" b="1" dirty="0"/>
-                        <a:t>All Services</a:t>
-                      </a:r>
-                    </a:p>
-                  </a:txBody>
-                  <a:tcPr>
-                    <a:lnL w="12700" cap="flat" cmpd="sng" algn="ctr">
-                      <a:noFill/>
-                      <a:prstDash val="solid"/>
-                      <a:round/>
-                      <a:headEnd type="none" w="med" len="med"/>
-                      <a:tailEnd type="none" w="med" len="med"/>
-                    </a:lnL>
-                    <a:lnR w="12700" cmpd="sng">
-                      <a:noFill/>
-                    </a:lnR>
-                    <a:lnT w="12700" cap="flat" cmpd="sng" algn="ctr">
-                      <a:solidFill>
-                        <a:schemeClr val="tx1"/>
-                      </a:solidFill>
-                      <a:prstDash val="solid"/>
-                      <a:round/>
-                      <a:headEnd type="none" w="med" len="med"/>
-                      <a:tailEnd type="none" w="med" len="med"/>
-                    </a:lnT>
-                    <a:lnB w="12700" cap="flat" cmpd="sng" algn="ctr">
-                      <a:solidFill>
-                        <a:schemeClr val="tx1"/>
-                      </a:solidFill>
-                      <a:prstDash val="solid"/>
-                      <a:round/>
-                      <a:headEnd type="none" w="med" len="med"/>
-                      <a:tailEnd type="none" w="med" len="med"/>
-                    </a:lnB>
-                    <a:lnTlToBr w="12700" cmpd="sng">
-                      <a:noFill/>
-                      <a:prstDash val="solid"/>
-                    </a:lnTlToBr>
-                    <a:lnBlToTr w="12700" cmpd="sng">
-                      <a:noFill/>
-                      <a:prstDash val="solid"/>
-                    </a:lnBlToTr>
-                  </a:tcPr>
-                </a:tc>
-                <a:tc>
-                  <a:txBody>
-                    <a:bodyPr/>
-                    <a:lstStyle/>
-                    <a:p>
-                      <a:pPr marL="119063" lvl="2" indent="-119063">
-                        <a:buFont typeface="Arial" panose="020B0604020202020204" pitchFamily="34" charset="0"/>
-                        <a:buChar char="•"/>
-                        <a:tabLst/>
-                      </a:pPr>
-                      <a:r>
-                        <a:rPr lang="en-US" sz="1200" b="0" dirty="0">
-                          <a:solidFill>
-                            <a:schemeClr val="tx1"/>
-                          </a:solidFill>
-                        </a:rPr>
-                        <a:t>Use Lean Product Management to publish Services info on our LinkedIn page</a:t>
-                      </a:r>
-                    </a:p>
-                    <a:p>
-                      <a:pPr marL="119063" lvl="2" indent="-119063">
-                        <a:buFont typeface="Arial" panose="020B0604020202020204" pitchFamily="34" charset="0"/>
-                        <a:buChar char="•"/>
-                        <a:tabLst/>
-                      </a:pPr>
-                      <a:r>
-                        <a:rPr lang="en-US" sz="1200" b="0" dirty="0">
-                          <a:solidFill>
-                            <a:schemeClr val="tx1"/>
-                          </a:solidFill>
-                        </a:rPr>
-                        <a:t>Explore low-cost options for setting up a website</a:t>
-                      </a:r>
-                    </a:p>
-                    <a:p>
-                      <a:pPr marL="119063" lvl="2" indent="-119063">
-                        <a:buFont typeface="Arial" panose="020B0604020202020204" pitchFamily="34" charset="0"/>
-                        <a:buChar char="•"/>
-                        <a:tabLst/>
-                      </a:pPr>
-                      <a:r>
-                        <a:rPr lang="en-US" sz="1200" b="0" dirty="0">
-                          <a:solidFill>
-                            <a:schemeClr val="tx1"/>
-                          </a:solidFill>
-                        </a:rPr>
-                        <a:t>Experiment with and practice using AI to help our Consortium scale</a:t>
-                      </a:r>
-                    </a:p>
-                    <a:p>
-                      <a:pPr marL="119063" lvl="2" indent="-119063">
-                        <a:buFont typeface="Arial" panose="020B0604020202020204" pitchFamily="34" charset="0"/>
-                        <a:buChar char="•"/>
-                        <a:tabLst/>
-                      </a:pPr>
-                      <a:r>
-                        <a:rPr lang="en-US" sz="1200" b="0" dirty="0">
-                          <a:solidFill>
-                            <a:schemeClr val="tx1"/>
-                          </a:solidFill>
-                        </a:rPr>
-                        <a:t>Explore ideas for raising seed money (donations and grants)</a:t>
-                      </a:r>
-                    </a:p>
-                  </a:txBody>
-                  <a:tcPr>
-                    <a:lnL w="12700" cmpd="sng">
-                      <a:noFill/>
-                    </a:lnL>
-                    <a:lnR w="12700" cap="flat" cmpd="sng" algn="ctr">
-                      <a:noFill/>
-                      <a:prstDash val="solid"/>
-                      <a:round/>
-                      <a:headEnd type="none" w="med" len="med"/>
-                      <a:tailEnd type="none" w="med" len="med"/>
-                    </a:lnR>
-                    <a:lnT w="12700" cap="flat" cmpd="sng" algn="ctr">
-                      <a:solidFill>
-                        <a:schemeClr val="tx1"/>
-                      </a:solidFill>
-                      <a:prstDash val="solid"/>
-                      <a:round/>
-                      <a:headEnd type="none" w="med" len="med"/>
-                      <a:tailEnd type="none" w="med" len="med"/>
-                    </a:lnT>
-                    <a:lnB w="12700" cap="flat" cmpd="sng" algn="ctr">
-                      <a:solidFill>
-                        <a:schemeClr val="tx1"/>
-                      </a:solidFill>
-                      <a:prstDash val="solid"/>
-                      <a:round/>
-                      <a:headEnd type="none" w="med" len="med"/>
-                      <a:tailEnd type="none" w="med" len="med"/>
-                    </a:lnB>
-                    <a:lnTlToBr w="12700" cmpd="sng">
-                      <a:noFill/>
-                      <a:prstDash val="solid"/>
-                    </a:lnTlToBr>
-                    <a:lnBlToTr w="12700" cmpd="sng">
-                      <a:noFill/>
-                      <a:prstDash val="solid"/>
-                    </a:lnBlToTr>
-                  </a:tcPr>
-                </a:tc>
-                <a:tc>
-                  <a:txBody>
-                    <a:bodyPr/>
-                    <a:lstStyle/>
-                    <a:p>
-                      <a:pPr marL="119063" marR="0" lvl="2" indent="-119063" algn="l" rtl="0">
-                        <a:lnSpc>
-                          <a:spcPct val="100000"/>
-                        </a:lnSpc>
-                        <a:spcBef>
-                          <a:spcPts val="0"/>
-                        </a:spcBef>
-                        <a:spcAft>
-                          <a:spcPts val="0"/>
-                        </a:spcAft>
-                        <a:buClr>
-                          <a:srgbClr val="000000"/>
-                        </a:buClr>
-                        <a:buFont typeface="Arial" panose="020B0604020202020204" pitchFamily="34" charset="0"/>
-                        <a:buChar char="•"/>
-                        <a:tabLst/>
-                      </a:pPr>
-                      <a:r>
-                        <a:rPr lang="en-US" sz="1200" b="0" i="0" u="none" strike="noStrike" cap="none" dirty="0">
-                          <a:solidFill>
-                            <a:schemeClr val="tx1"/>
-                          </a:solidFill>
-                          <a:latin typeface="+mn-lt"/>
-                          <a:ea typeface="+mn-ea"/>
-                          <a:cs typeface="+mn-cs"/>
-                          <a:sym typeface="Arial"/>
-                        </a:rPr>
-                        <a:t>Set up a website</a:t>
-                      </a:r>
-                    </a:p>
-                    <a:p>
-                      <a:pPr marL="119063" marR="0" lvl="2" indent="-119063" algn="l" rtl="0">
-                        <a:lnSpc>
-                          <a:spcPct val="100000"/>
-                        </a:lnSpc>
-                        <a:spcBef>
-                          <a:spcPts val="0"/>
-                        </a:spcBef>
-                        <a:spcAft>
-                          <a:spcPts val="0"/>
-                        </a:spcAft>
-                        <a:buClr>
-                          <a:srgbClr val="000000"/>
-                        </a:buClr>
-                        <a:buFont typeface="Arial" panose="020B0604020202020204" pitchFamily="34" charset="0"/>
-                        <a:buChar char="•"/>
-                        <a:tabLst/>
-                      </a:pPr>
-                      <a:r>
-                        <a:rPr lang="en-US" sz="1200" b="0" i="0" u="none" strike="noStrike" cap="none" dirty="0">
-                          <a:solidFill>
-                            <a:schemeClr val="tx1"/>
-                          </a:solidFill>
-                          <a:latin typeface="+mn-lt"/>
-                          <a:ea typeface="+mn-ea"/>
-                          <a:cs typeface="+mn-cs"/>
-                          <a:sym typeface="Arial"/>
-                        </a:rPr>
-                        <a:t>Publish learnings (e.g., how we’re using AI) in the AccelRR8 Body of Knowledge</a:t>
-                      </a:r>
-                    </a:p>
-                  </a:txBody>
-                  <a:tcPr>
-                    <a:lnL w="12700" cmpd="sng">
-                      <a:noFill/>
-                    </a:lnL>
-                    <a:lnR w="12700" cap="flat" cmpd="sng" algn="ctr">
-                      <a:noFill/>
-                      <a:prstDash val="solid"/>
-                      <a:round/>
-                      <a:headEnd type="none" w="med" len="med"/>
-                      <a:tailEnd type="none" w="med" len="med"/>
-                    </a:lnR>
-                    <a:lnT w="12700" cap="flat" cmpd="sng" algn="ctr">
-                      <a:solidFill>
-                        <a:schemeClr val="tx1"/>
-                      </a:solidFill>
-                      <a:prstDash val="solid"/>
-                      <a:round/>
-                      <a:headEnd type="none" w="med" len="med"/>
-                      <a:tailEnd type="none" w="med" len="med"/>
-                    </a:lnT>
-                    <a:lnB w="12700" cap="flat" cmpd="sng" algn="ctr">
-                      <a:solidFill>
-                        <a:schemeClr val="tx1"/>
-                      </a:solidFill>
-                      <a:prstDash val="solid"/>
-                      <a:round/>
-                      <a:headEnd type="none" w="med" len="med"/>
-                      <a:tailEnd type="none" w="med" len="med"/>
-                    </a:lnB>
-                    <a:lnTlToBr w="12700" cmpd="sng">
-                      <a:noFill/>
-                      <a:prstDash val="solid"/>
-                    </a:lnTlToBr>
-                    <a:lnBlToTr w="12700" cmpd="sng">
-                      <a:noFill/>
-                      <a:prstDash val="solid"/>
-                    </a:lnBlToTr>
-                  </a:tcPr>
-                </a:tc>
-                <a:extLst>
-                  <a:ext uri="{0D108BD9-81ED-4DB2-BD59-A6C34878D82A}">
-                    <a16:rowId xmlns:a16="http://schemas.microsoft.com/office/drawing/2014/main" val="901597007"/>
-                  </a:ext>
-                </a:extLst>
-              </a:tr>
-              <a:tr h="723820">
-                <a:tc>
-                  <a:txBody>
-                    <a:bodyPr/>
-                    <a:lstStyle/>
-                    <a:p>
-                      <a:r>
-                        <a:rPr lang="en-US" sz="2000" b="1" dirty="0"/>
-                        <a:t>Professional Networking</a:t>
-                      </a:r>
-                    </a:p>
-                  </a:txBody>
-                  <a:tcPr>
-                    <a:lnL w="12700" cap="flat" cmpd="sng" algn="ctr">
-                      <a:noFill/>
-                      <a:prstDash val="solid"/>
-                      <a:round/>
-                      <a:headEnd type="none" w="med" len="med"/>
-                      <a:tailEnd type="none" w="med" len="med"/>
-                    </a:lnL>
-                    <a:lnR w="12700" cmpd="sng">
-                      <a:noFill/>
-                    </a:lnR>
-                    <a:lnT w="12700" cap="flat" cmpd="sng" algn="ctr">
-                      <a:solidFill>
-                        <a:schemeClr val="tx1"/>
-                      </a:solidFill>
-                      <a:prstDash val="solid"/>
-                      <a:round/>
-                      <a:headEnd type="none" w="med" len="med"/>
-                      <a:tailEnd type="none" w="med" len="med"/>
-                    </a:lnT>
-                    <a:lnB w="12700" cap="flat" cmpd="sng" algn="ctr">
-                      <a:solidFill>
-                        <a:schemeClr val="tx1"/>
-                      </a:solidFill>
-                      <a:prstDash val="solid"/>
-                      <a:round/>
-                      <a:headEnd type="none" w="med" len="med"/>
-                      <a:tailEnd type="none" w="med" len="med"/>
-                    </a:lnB>
-                    <a:lnTlToBr w="12700" cmpd="sng">
-                      <a:noFill/>
-                      <a:prstDash val="solid"/>
-                    </a:lnTlToBr>
-                    <a:lnBlToTr w="12700" cmpd="sng">
-                      <a:noFill/>
-                      <a:prstDash val="solid"/>
-                    </a:lnBlToTr>
-                  </a:tcPr>
-                </a:tc>
-                <a:tc>
-                  <a:txBody>
-                    <a:bodyPr/>
-                    <a:lstStyle/>
-                    <a:p>
-                      <a:pPr marL="119063" lvl="2" indent="-119063">
-                        <a:buFont typeface="Arial" panose="020B0604020202020204" pitchFamily="34" charset="0"/>
-                        <a:buChar char="•"/>
-                        <a:tabLst/>
-                      </a:pPr>
-                      <a:r>
-                        <a:rPr lang="en-US" sz="1200" b="0" i="0" u="none" strike="noStrike" cap="none" dirty="0">
-                          <a:solidFill>
-                            <a:schemeClr val="tx1"/>
-                          </a:solidFill>
-                          <a:effectLst/>
-                          <a:latin typeface="+mn-lt"/>
-                          <a:ea typeface="+mn-ea"/>
-                          <a:cs typeface="+mn-cs"/>
-                          <a:sym typeface="Arial"/>
-                        </a:rPr>
-                        <a:t>Learn from ASUG, Toastmasters, and PMI leaders how they grew their networks</a:t>
-                      </a:r>
-                    </a:p>
-                    <a:p>
-                      <a:pPr marL="119063" lvl="2" indent="-119063">
-                        <a:buFont typeface="Arial" panose="020B0604020202020204" pitchFamily="34" charset="0"/>
-                        <a:buChar char="•"/>
-                        <a:tabLst/>
-                      </a:pPr>
-                      <a:r>
-                        <a:rPr lang="en-US" sz="1200" b="0" i="0" u="none" strike="noStrike" cap="none" dirty="0">
-                          <a:solidFill>
-                            <a:schemeClr val="tx1"/>
-                          </a:solidFill>
-                          <a:effectLst/>
-                          <a:latin typeface="+mn-lt"/>
-                          <a:ea typeface="+mn-ea"/>
-                          <a:cs typeface="+mn-cs"/>
-                          <a:sym typeface="Arial"/>
-                        </a:rPr>
-                        <a:t>Grow the number of Collaborators to 100 via the Board of Directors</a:t>
-                      </a:r>
-                    </a:p>
-                    <a:p>
-                      <a:pPr marL="119063" lvl="2" indent="-119063">
-                        <a:buFont typeface="Arial" panose="020B0604020202020204" pitchFamily="34" charset="0"/>
-                        <a:buChar char="•"/>
-                        <a:tabLst/>
-                      </a:pPr>
-                      <a:r>
-                        <a:rPr lang="en-US" sz="1200" b="0" i="0" u="none" strike="noStrike" cap="none" dirty="0">
-                          <a:solidFill>
-                            <a:schemeClr val="tx1"/>
-                          </a:solidFill>
-                          <a:effectLst/>
-                          <a:latin typeface="+mn-lt"/>
-                          <a:ea typeface="+mn-ea"/>
-                          <a:cs typeface="+mn-cs"/>
-                          <a:sym typeface="Arial"/>
-                        </a:rPr>
-                        <a:t>Explore platforms to enhance collaboration (e.g., LinkedIn Groups)</a:t>
-                      </a:r>
-                    </a:p>
-                    <a:p>
-                      <a:pPr marL="119063" lvl="2" indent="-119063">
-                        <a:buFont typeface="Arial" panose="020B0604020202020204" pitchFamily="34" charset="0"/>
-                        <a:buChar char="•"/>
-                        <a:tabLst/>
-                      </a:pPr>
-                      <a:r>
-                        <a:rPr lang="en-US" sz="1200" b="0" i="0" u="none" strike="noStrike" cap="none" dirty="0">
-                          <a:solidFill>
-                            <a:schemeClr val="tx1"/>
-                          </a:solidFill>
-                          <a:effectLst/>
-                          <a:latin typeface="+mn-lt"/>
-                          <a:ea typeface="+mn-ea"/>
-                          <a:cs typeface="+mn-cs"/>
-                          <a:sym typeface="Arial"/>
-                        </a:rPr>
-                        <a:t>Prepare a campaign to grow the number of Collaborators to 300</a:t>
-                      </a:r>
-                    </a:p>
-                    <a:p>
-                      <a:pPr marL="119063" lvl="2" indent="-119063">
-                        <a:buFont typeface="Arial" panose="020B0604020202020204" pitchFamily="34" charset="0"/>
-                        <a:buChar char="•"/>
-                        <a:tabLst/>
-                      </a:pPr>
-                      <a:r>
-                        <a:rPr lang="en-US" sz="1200" b="0" i="0" u="none" strike="noStrike" cap="none" dirty="0">
-                          <a:solidFill>
-                            <a:schemeClr val="tx1"/>
-                          </a:solidFill>
-                          <a:effectLst/>
-                          <a:latin typeface="+mn-lt"/>
-                          <a:ea typeface="+mn-ea"/>
-                          <a:cs typeface="+mn-cs"/>
-                          <a:sym typeface="Arial"/>
-                        </a:rPr>
-                        <a:t>Explore Freemium options for generating revenues (e.g., local chapters)</a:t>
-                      </a:r>
-                      <a:endParaRPr lang="en-US" sz="1200" b="0" dirty="0">
-                        <a:solidFill>
-                          <a:schemeClr val="tx1"/>
-                        </a:solidFill>
-                      </a:endParaRPr>
-                    </a:p>
-                  </a:txBody>
-                  <a:tcPr>
-                    <a:lnL w="12700" cmpd="sng">
-                      <a:noFill/>
-                    </a:lnL>
-                    <a:lnR w="12700" cap="flat" cmpd="sng" algn="ctr">
-                      <a:noFill/>
-                      <a:prstDash val="solid"/>
-                      <a:round/>
-                      <a:headEnd type="none" w="med" len="med"/>
-                      <a:tailEnd type="none" w="med" len="med"/>
-                    </a:lnR>
-                    <a:lnT w="12700" cap="flat" cmpd="sng" algn="ctr">
-                      <a:solidFill>
-                        <a:schemeClr val="tx1"/>
-                      </a:solidFill>
-                      <a:prstDash val="solid"/>
-                      <a:round/>
-                      <a:headEnd type="none" w="med" len="med"/>
-                      <a:tailEnd type="none" w="med" len="med"/>
-                    </a:lnT>
-                    <a:lnB w="12700" cap="flat" cmpd="sng" algn="ctr">
-                      <a:solidFill>
-                        <a:schemeClr val="tx1"/>
-                      </a:solidFill>
-                      <a:prstDash val="solid"/>
-                      <a:round/>
-                      <a:headEnd type="none" w="med" len="med"/>
-                      <a:tailEnd type="none" w="med" len="med"/>
-                    </a:lnB>
-                    <a:lnTlToBr w="12700" cmpd="sng">
-                      <a:noFill/>
-                      <a:prstDash val="solid"/>
-                    </a:lnTlToBr>
-                    <a:lnBlToTr w="12700" cmpd="sng">
-                      <a:noFill/>
-                      <a:prstDash val="solid"/>
-                    </a:lnBlToTr>
-                  </a:tcPr>
-                </a:tc>
-                <a:tc>
-                  <a:txBody>
-                    <a:bodyPr/>
-                    <a:lstStyle/>
-                    <a:p>
-                      <a:pPr marL="119063" marR="0" lvl="2" indent="-119063" algn="l" rtl="0">
-                        <a:lnSpc>
-                          <a:spcPct val="100000"/>
-                        </a:lnSpc>
-                        <a:spcBef>
-                          <a:spcPts val="0"/>
-                        </a:spcBef>
-                        <a:spcAft>
-                          <a:spcPts val="0"/>
-                        </a:spcAft>
-                        <a:buClr>
-                          <a:srgbClr val="000000"/>
-                        </a:buClr>
-                        <a:buFont typeface="Arial" panose="020B0604020202020204" pitchFamily="34" charset="0"/>
-                        <a:buChar char="•"/>
-                        <a:tabLst/>
-                      </a:pPr>
-                      <a:r>
-                        <a:rPr lang="en-US" sz="1200" b="0" i="0" u="none" strike="noStrike" cap="none" dirty="0">
-                          <a:solidFill>
-                            <a:schemeClr val="tx1"/>
-                          </a:solidFill>
-                          <a:latin typeface="+mn-lt"/>
-                          <a:ea typeface="+mn-ea"/>
-                          <a:cs typeface="+mn-cs"/>
-                          <a:sym typeface="Arial"/>
-                        </a:rPr>
-                        <a:t>Identify Leader for Professional Network Service</a:t>
-                      </a:r>
-                    </a:p>
-                    <a:p>
-                      <a:pPr marL="119063" marR="0" lvl="2" indent="-119063" algn="l" rtl="0">
-                        <a:lnSpc>
-                          <a:spcPct val="100000"/>
-                        </a:lnSpc>
-                        <a:spcBef>
-                          <a:spcPts val="0"/>
-                        </a:spcBef>
-                        <a:spcAft>
-                          <a:spcPts val="0"/>
-                        </a:spcAft>
-                        <a:buClr>
-                          <a:srgbClr val="000000"/>
-                        </a:buClr>
-                        <a:buFont typeface="Arial" panose="020B0604020202020204" pitchFamily="34" charset="0"/>
-                        <a:buChar char="•"/>
-                        <a:tabLst/>
-                      </a:pPr>
-                      <a:r>
-                        <a:rPr lang="en-US" sz="1200" b="0" i="0" u="none" strike="noStrike" cap="none" dirty="0">
-                          <a:solidFill>
-                            <a:schemeClr val="tx1"/>
-                          </a:solidFill>
-                          <a:latin typeface="+mn-lt"/>
-                          <a:ea typeface="+mn-ea"/>
-                          <a:cs typeface="+mn-cs"/>
-                          <a:sym typeface="Arial"/>
-                        </a:rPr>
-                        <a:t>Run campaigns to grow the number of Collaborators to 300 and then to 1,000</a:t>
-                      </a:r>
-                    </a:p>
-                    <a:p>
-                      <a:pPr marL="119063" marR="0" lvl="2" indent="-119063" algn="l" rtl="0">
-                        <a:lnSpc>
-                          <a:spcPct val="100000"/>
-                        </a:lnSpc>
-                        <a:spcBef>
-                          <a:spcPts val="0"/>
-                        </a:spcBef>
-                        <a:spcAft>
-                          <a:spcPts val="0"/>
-                        </a:spcAft>
-                        <a:buClr>
-                          <a:srgbClr val="000000"/>
-                        </a:buClr>
-                        <a:buFont typeface="Arial" panose="020B0604020202020204" pitchFamily="34" charset="0"/>
-                        <a:buChar char="•"/>
-                        <a:tabLst/>
-                      </a:pPr>
-                      <a:r>
-                        <a:rPr lang="en-US" sz="1200" b="0" i="0" u="none" strike="noStrike" cap="none" dirty="0">
-                          <a:solidFill>
-                            <a:schemeClr val="tx1"/>
-                          </a:solidFill>
-                          <a:latin typeface="+mn-lt"/>
-                          <a:ea typeface="+mn-ea"/>
-                          <a:cs typeface="+mn-cs"/>
-                          <a:sym typeface="Arial"/>
-                        </a:rPr>
-                        <a:t>Run MVP for collaboration platform</a:t>
-                      </a:r>
-                    </a:p>
-                    <a:p>
-                      <a:pPr marL="119063" marR="0" lvl="2" indent="-119063" algn="l" rtl="0">
-                        <a:lnSpc>
-                          <a:spcPct val="100000"/>
-                        </a:lnSpc>
-                        <a:spcBef>
-                          <a:spcPts val="0"/>
-                        </a:spcBef>
-                        <a:spcAft>
-                          <a:spcPts val="0"/>
-                        </a:spcAft>
-                        <a:buClr>
-                          <a:srgbClr val="000000"/>
-                        </a:buClr>
-                        <a:buFont typeface="Arial" panose="020B0604020202020204" pitchFamily="34" charset="0"/>
-                        <a:buChar char="•"/>
-                        <a:tabLst/>
-                      </a:pPr>
-                      <a:r>
-                        <a:rPr lang="en-US" sz="1200" b="0" i="0" u="none" strike="noStrike" cap="none" dirty="0">
-                          <a:solidFill>
-                            <a:schemeClr val="tx1"/>
-                          </a:solidFill>
-                          <a:latin typeface="+mn-lt"/>
-                          <a:ea typeface="+mn-ea"/>
-                          <a:cs typeface="+mn-cs"/>
-                          <a:sym typeface="Arial"/>
-                        </a:rPr>
-                        <a:t>Run MVPs for Freemium options</a:t>
-                      </a:r>
-                    </a:p>
-                  </a:txBody>
-                  <a:tcPr>
-                    <a:lnL w="12700" cmpd="sng">
-                      <a:noFill/>
-                    </a:lnL>
-                    <a:lnR w="12700" cap="flat" cmpd="sng" algn="ctr">
-                      <a:noFill/>
-                      <a:prstDash val="solid"/>
-                      <a:round/>
-                      <a:headEnd type="none" w="med" len="med"/>
-                      <a:tailEnd type="none" w="med" len="med"/>
-                    </a:lnR>
-                    <a:lnT w="12700" cap="flat" cmpd="sng" algn="ctr">
-                      <a:solidFill>
-                        <a:schemeClr val="tx1"/>
-                      </a:solidFill>
-                      <a:prstDash val="solid"/>
-                      <a:round/>
-                      <a:headEnd type="none" w="med" len="med"/>
-                      <a:tailEnd type="none" w="med" len="med"/>
-                    </a:lnT>
-                    <a:lnB w="12700" cap="flat" cmpd="sng" algn="ctr">
-                      <a:solidFill>
-                        <a:schemeClr val="tx1"/>
-                      </a:solidFill>
-                      <a:prstDash val="solid"/>
-                      <a:round/>
-                      <a:headEnd type="none" w="med" len="med"/>
-                      <a:tailEnd type="none" w="med" len="med"/>
-                    </a:lnB>
-                    <a:lnTlToBr w="12700" cmpd="sng">
-                      <a:noFill/>
-                      <a:prstDash val="solid"/>
-                    </a:lnTlToBr>
-                    <a:lnBlToTr w="12700" cmpd="sng">
-                      <a:noFill/>
-                      <a:prstDash val="solid"/>
-                    </a:lnBlToTr>
-                  </a:tcPr>
-                </a:tc>
-                <a:extLst>
-                  <a:ext uri="{0D108BD9-81ED-4DB2-BD59-A6C34878D82A}">
-                    <a16:rowId xmlns:a16="http://schemas.microsoft.com/office/drawing/2014/main" val="872717509"/>
-                  </a:ext>
-                </a:extLst>
-              </a:tr>
-              <a:tr h="1128631">
-                <a:tc>
-                  <a:txBody>
-                    <a:bodyPr/>
-                    <a:lstStyle/>
-                    <a:p>
-                      <a:r>
-                        <a:rPr lang="en-US" sz="2000" b="1" dirty="0"/>
-                        <a:t>Open Knowledge Sharing</a:t>
-                      </a:r>
-                    </a:p>
-                  </a:txBody>
-                  <a:tcPr>
-                    <a:lnL w="12700" cmpd="sng">
-                      <a:noFill/>
-                    </a:lnL>
-                    <a:lnR w="12700" cmpd="sng">
-                      <a:noFill/>
-                    </a:lnR>
-                    <a:lnT w="12700" cap="flat" cmpd="sng" algn="ctr">
-                      <a:solidFill>
-                        <a:schemeClr val="tx1"/>
-                      </a:solidFill>
-                      <a:prstDash val="solid"/>
-                      <a:round/>
-                      <a:headEnd type="none" w="med" len="med"/>
-                      <a:tailEnd type="none" w="med" len="med"/>
-                    </a:lnT>
-                    <a:lnB w="12700" cap="flat" cmpd="sng" algn="ctr">
-                      <a:solidFill>
-                        <a:schemeClr val="tx1"/>
-                      </a:solidFill>
-                      <a:prstDash val="solid"/>
-                      <a:round/>
-                      <a:headEnd type="none" w="med" len="med"/>
-                      <a:tailEnd type="none" w="med" len="med"/>
-                    </a:lnB>
-                    <a:lnTlToBr w="12700" cmpd="sng">
-                      <a:noFill/>
-                      <a:prstDash val="solid"/>
-                    </a:lnTlToBr>
-                    <a:lnBlToTr w="12700" cmpd="sng">
-                      <a:noFill/>
-                      <a:prstDash val="solid"/>
-                    </a:lnBlToTr>
-                  </a:tcPr>
-                </a:tc>
-                <a:tc>
-                  <a:txBody>
-                    <a:bodyPr/>
-                    <a:lstStyle/>
-                    <a:p>
-                      <a:pPr marL="119063" lvl="2" indent="-119063">
-                        <a:buFont typeface="Arial" panose="020B0604020202020204" pitchFamily="34" charset="0"/>
-                        <a:buChar char="•"/>
-                        <a:tabLst/>
-                      </a:pPr>
-                      <a:r>
-                        <a:rPr lang="en-US" sz="1200" b="0" i="0" u="none" strike="noStrike" cap="none" dirty="0">
-                          <a:solidFill>
-                            <a:schemeClr val="tx1"/>
-                          </a:solidFill>
-                          <a:effectLst/>
-                          <a:latin typeface="+mn-lt"/>
-                          <a:ea typeface="+mn-ea"/>
-                          <a:cs typeface="+mn-cs"/>
-                          <a:sym typeface="Arial"/>
-                        </a:rPr>
-                        <a:t>Learn from ASUG and PMI leaders how they developed and curate their BOKs</a:t>
-                      </a:r>
-                    </a:p>
-                    <a:p>
-                      <a:pPr marL="119063" lvl="2" indent="-119063">
-                        <a:buFont typeface="Arial" panose="020B0604020202020204" pitchFamily="34" charset="0"/>
-                        <a:buChar char="•"/>
-                        <a:tabLst/>
-                      </a:pPr>
-                      <a:r>
-                        <a:rPr lang="en-US" sz="1200" b="0" i="0" u="none" strike="noStrike" cap="none" dirty="0">
-                          <a:solidFill>
-                            <a:schemeClr val="tx1"/>
-                          </a:solidFill>
-                          <a:effectLst/>
-                          <a:latin typeface="+mn-lt"/>
-                          <a:ea typeface="+mn-ea"/>
-                          <a:cs typeface="+mn-cs"/>
-                          <a:sym typeface="Arial"/>
-                        </a:rPr>
-                        <a:t>Explore platforms for publishing and curating the AccelRR8 Framework and AccelRR8 Body of Knowledge </a:t>
-                      </a:r>
-                    </a:p>
-                    <a:p>
-                      <a:pPr marL="119063" lvl="2" indent="-119063">
-                        <a:buFont typeface="Arial" panose="020B0604020202020204" pitchFamily="34" charset="0"/>
-                        <a:buChar char="•"/>
-                        <a:tabLst/>
-                      </a:pPr>
-                      <a:r>
-                        <a:rPr lang="en-US" sz="1200" b="0" i="0" u="none" strike="noStrike" cap="none" dirty="0">
-                          <a:solidFill>
-                            <a:schemeClr val="tx1"/>
-                          </a:solidFill>
-                          <a:effectLst/>
-                          <a:latin typeface="+mn-lt"/>
-                          <a:ea typeface="+mn-ea"/>
-                          <a:cs typeface="+mn-cs"/>
-                          <a:sym typeface="Arial"/>
-                        </a:rPr>
-                        <a:t>Identify advisory board leaders for various topics</a:t>
-                      </a:r>
-                    </a:p>
-                    <a:p>
-                      <a:pPr marL="119063" lvl="2" indent="-119063">
-                        <a:buFont typeface="Arial" panose="020B0604020202020204" pitchFamily="34" charset="0"/>
-                        <a:buChar char="•"/>
-                        <a:tabLst/>
-                      </a:pPr>
-                      <a:r>
-                        <a:rPr lang="en-US" sz="1200" b="0" i="0" u="none" strike="noStrike" cap="none" dirty="0">
-                          <a:solidFill>
-                            <a:schemeClr val="tx1"/>
-                          </a:solidFill>
-                          <a:effectLst/>
-                          <a:latin typeface="+mn-lt"/>
-                          <a:ea typeface="+mn-ea"/>
-                          <a:cs typeface="+mn-cs"/>
-                          <a:sym typeface="Arial"/>
-                        </a:rPr>
-                        <a:t>Explore ways to enhance our credibility with Tech Services leaders, e.g., influencer endorsements and webinars</a:t>
-                      </a:r>
-                    </a:p>
-                    <a:p>
-                      <a:pPr marL="119063" lvl="2" indent="-119063">
-                        <a:buFont typeface="Arial" panose="020B0604020202020204" pitchFamily="34" charset="0"/>
-                        <a:buChar char="•"/>
-                        <a:tabLst/>
-                      </a:pPr>
-                      <a:r>
-                        <a:rPr lang="en-US" sz="1200" b="0" i="0" u="none" strike="noStrike" cap="none" dirty="0">
-                          <a:solidFill>
-                            <a:schemeClr val="tx1"/>
-                          </a:solidFill>
-                          <a:effectLst/>
-                          <a:latin typeface="+mn-lt"/>
-                          <a:ea typeface="+mn-ea"/>
-                          <a:cs typeface="+mn-cs"/>
-                          <a:sym typeface="Arial"/>
-                        </a:rPr>
-                        <a:t>Explore Freemium options for generating revenues (e.g., contributors)</a:t>
-                      </a:r>
-                      <a:endParaRPr lang="en-US" sz="1200" b="0" dirty="0">
-                        <a:solidFill>
-                          <a:schemeClr val="tx1"/>
-                        </a:solidFill>
-                      </a:endParaRPr>
-                    </a:p>
-                  </a:txBody>
-                  <a:tcPr>
-                    <a:lnL w="12700" cmpd="sng">
-                      <a:noFill/>
-                    </a:lnL>
-                    <a:lnR w="12700" cmpd="sng">
-                      <a:noFill/>
-                    </a:lnR>
-                    <a:lnT w="12700" cap="flat" cmpd="sng" algn="ctr">
-                      <a:solidFill>
-                        <a:schemeClr val="tx1"/>
-                      </a:solidFill>
-                      <a:prstDash val="solid"/>
-                      <a:round/>
-                      <a:headEnd type="none" w="med" len="med"/>
-                      <a:tailEnd type="none" w="med" len="med"/>
-                    </a:lnT>
-                    <a:lnB w="12700" cap="flat" cmpd="sng" algn="ctr">
-                      <a:solidFill>
-                        <a:schemeClr val="tx1"/>
-                      </a:solidFill>
-                      <a:prstDash val="solid"/>
-                      <a:round/>
-                      <a:headEnd type="none" w="med" len="med"/>
-                      <a:tailEnd type="none" w="med" len="med"/>
-                    </a:lnB>
-                    <a:lnTlToBr w="12700" cmpd="sng">
-                      <a:noFill/>
-                      <a:prstDash val="solid"/>
-                    </a:lnTlToBr>
-                    <a:lnBlToTr w="12700" cmpd="sng">
-                      <a:noFill/>
-                      <a:prstDash val="solid"/>
-                    </a:lnBlToTr>
-                  </a:tcPr>
-                </a:tc>
-                <a:tc>
-                  <a:txBody>
-                    <a:bodyPr/>
-                    <a:lstStyle/>
-                    <a:p>
-                      <a:pPr marL="119063" marR="0" lvl="2" indent="-119063" algn="l" rtl="0">
-                        <a:lnSpc>
-                          <a:spcPct val="100000"/>
-                        </a:lnSpc>
-                        <a:spcBef>
-                          <a:spcPts val="0"/>
-                        </a:spcBef>
-                        <a:spcAft>
-                          <a:spcPts val="0"/>
-                        </a:spcAft>
-                        <a:buClr>
-                          <a:srgbClr val="000000"/>
-                        </a:buClr>
-                        <a:buFont typeface="Arial" panose="020B0604020202020204" pitchFamily="34" charset="0"/>
-                        <a:buChar char="•"/>
-                        <a:tabLst/>
-                      </a:pPr>
-                      <a:r>
-                        <a:rPr lang="en-US" sz="1200" b="0" i="0" u="none" strike="noStrike" cap="none" dirty="0">
-                          <a:solidFill>
-                            <a:schemeClr val="tx1"/>
-                          </a:solidFill>
-                          <a:latin typeface="+mn-lt"/>
-                          <a:ea typeface="+mn-ea"/>
-                          <a:cs typeface="+mn-cs"/>
-                          <a:sym typeface="Arial"/>
-                        </a:rPr>
-                        <a:t>Identify Leader for Open Knowledge Sharing Service</a:t>
-                      </a:r>
-                    </a:p>
-                    <a:p>
-                      <a:pPr marL="119063" marR="0" lvl="2" indent="-119063" algn="l" rtl="0">
-                        <a:lnSpc>
-                          <a:spcPct val="100000"/>
-                        </a:lnSpc>
-                        <a:spcBef>
-                          <a:spcPts val="0"/>
-                        </a:spcBef>
-                        <a:spcAft>
-                          <a:spcPts val="0"/>
-                        </a:spcAft>
-                        <a:buClr>
-                          <a:srgbClr val="000000"/>
-                        </a:buClr>
-                        <a:buFont typeface="Arial" panose="020B0604020202020204" pitchFamily="34" charset="0"/>
-                        <a:buChar char="•"/>
-                        <a:tabLst/>
-                      </a:pPr>
-                      <a:r>
-                        <a:rPr lang="en-US" sz="1200" b="0" i="0" u="none" strike="noStrike" cap="none" dirty="0">
-                          <a:solidFill>
-                            <a:schemeClr val="tx1"/>
-                          </a:solidFill>
-                          <a:latin typeface="+mn-lt"/>
-                          <a:ea typeface="+mn-ea"/>
-                          <a:cs typeface="+mn-cs"/>
-                          <a:sym typeface="Arial"/>
-                        </a:rPr>
-                        <a:t>Publish the AccelRR8 Framework v2 on KM platform with help from Advisory board</a:t>
-                      </a:r>
-                    </a:p>
-                    <a:p>
-                      <a:pPr marL="119063" marR="0" lvl="2" indent="-119063" algn="l" rtl="0">
-                        <a:lnSpc>
-                          <a:spcPct val="100000"/>
-                        </a:lnSpc>
-                        <a:spcBef>
-                          <a:spcPts val="0"/>
-                        </a:spcBef>
-                        <a:spcAft>
-                          <a:spcPts val="0"/>
-                        </a:spcAft>
-                        <a:buClr>
-                          <a:srgbClr val="000000"/>
-                        </a:buClr>
-                        <a:buFont typeface="Arial" panose="020B0604020202020204" pitchFamily="34" charset="0"/>
-                        <a:buChar char="•"/>
-                        <a:tabLst/>
-                      </a:pPr>
-                      <a:r>
-                        <a:rPr lang="en-US" sz="1200" b="0" i="0" u="none" strike="noStrike" cap="none" dirty="0">
-                          <a:solidFill>
-                            <a:schemeClr val="tx1"/>
-                          </a:solidFill>
-                          <a:latin typeface="+mn-lt"/>
-                          <a:ea typeface="+mn-ea"/>
-                          <a:cs typeface="+mn-cs"/>
-                          <a:sym typeface="Arial"/>
-                        </a:rPr>
-                        <a:t>Run MVPs for webinars with influencers</a:t>
-                      </a:r>
-                    </a:p>
-                    <a:p>
-                      <a:pPr marL="119063" marR="0" lvl="2" indent="-119063" algn="l" rtl="0">
-                        <a:lnSpc>
-                          <a:spcPct val="100000"/>
-                        </a:lnSpc>
-                        <a:spcBef>
-                          <a:spcPts val="0"/>
-                        </a:spcBef>
-                        <a:spcAft>
-                          <a:spcPts val="0"/>
-                        </a:spcAft>
-                        <a:buClr>
-                          <a:srgbClr val="000000"/>
-                        </a:buClr>
-                        <a:buFont typeface="Arial" panose="020B0604020202020204" pitchFamily="34" charset="0"/>
-                        <a:buChar char="•"/>
-                        <a:tabLst/>
-                      </a:pPr>
-                      <a:r>
-                        <a:rPr lang="en-US" sz="1200" b="0" i="0" u="none" strike="noStrike" cap="none" dirty="0">
-                          <a:solidFill>
-                            <a:schemeClr val="tx1"/>
-                          </a:solidFill>
-                          <a:latin typeface="+mn-lt"/>
-                          <a:ea typeface="+mn-ea"/>
-                          <a:cs typeface="+mn-cs"/>
-                          <a:sym typeface="Arial"/>
-                        </a:rPr>
-                        <a:t>Run MVPs for Freemium options</a:t>
-                      </a:r>
-                    </a:p>
-                  </a:txBody>
-                  <a:tcPr>
-                    <a:lnL w="12700" cmpd="sng">
-                      <a:noFill/>
-                    </a:lnL>
-                    <a:lnR w="12700" cmpd="sng">
-                      <a:noFill/>
-                    </a:lnR>
-                    <a:lnT w="12700" cap="flat" cmpd="sng" algn="ctr">
-                      <a:solidFill>
-                        <a:schemeClr val="tx1"/>
-                      </a:solidFill>
-                      <a:prstDash val="solid"/>
-                      <a:round/>
-                      <a:headEnd type="none" w="med" len="med"/>
-                      <a:tailEnd type="none" w="med" len="med"/>
-                    </a:lnT>
-                    <a:lnB w="12700" cap="flat" cmpd="sng" algn="ctr">
-                      <a:solidFill>
-                        <a:schemeClr val="tx1"/>
-                      </a:solidFill>
-                      <a:prstDash val="solid"/>
-                      <a:round/>
-                      <a:headEnd type="none" w="med" len="med"/>
-                      <a:tailEnd type="none" w="med" len="med"/>
-                    </a:lnB>
-                    <a:lnTlToBr w="12700" cmpd="sng">
-                      <a:noFill/>
-                      <a:prstDash val="solid"/>
-                    </a:lnTlToBr>
-                    <a:lnBlToTr w="12700" cmpd="sng">
-                      <a:noFill/>
-                      <a:prstDash val="solid"/>
-                    </a:lnBlToTr>
-                  </a:tcPr>
-                </a:tc>
-                <a:extLst>
-                  <a:ext uri="{0D108BD9-81ED-4DB2-BD59-A6C34878D82A}">
-                    <a16:rowId xmlns:a16="http://schemas.microsoft.com/office/drawing/2014/main" val="3089640372"/>
-                  </a:ext>
-                </a:extLst>
-              </a:tr>
-              <a:tr h="1075015">
-                <a:tc>
-                  <a:txBody>
-                    <a:bodyPr/>
-                    <a:lstStyle/>
-                    <a:p>
-                      <a:r>
-                        <a:rPr lang="en-US" sz="2000" b="1" dirty="0"/>
-                        <a:t>Industry</a:t>
-                      </a:r>
-                    </a:p>
-                    <a:p>
-                      <a:r>
-                        <a:rPr lang="en-US" sz="2000" b="1" dirty="0"/>
-                        <a:t>Innovation</a:t>
-                      </a:r>
-                    </a:p>
-                  </a:txBody>
-                  <a:tcPr>
-                    <a:lnL w="12700" cmpd="sng">
-                      <a:noFill/>
-                    </a:lnL>
-                    <a:lnR w="12700" cmpd="sng">
-                      <a:noFill/>
-                    </a:lnR>
-                    <a:lnT w="12700" cap="flat" cmpd="sng" algn="ctr">
-                      <a:solidFill>
-                        <a:schemeClr val="tx1"/>
-                      </a:solidFill>
-                      <a:prstDash val="solid"/>
-                      <a:round/>
-                      <a:headEnd type="none" w="med" len="med"/>
-                      <a:tailEnd type="none" w="med" len="med"/>
-                    </a:lnT>
-                    <a:lnB w="12700" cap="flat" cmpd="sng" algn="ctr">
-                      <a:solidFill>
-                        <a:schemeClr val="tx1"/>
-                      </a:solidFill>
-                      <a:prstDash val="solid"/>
-                      <a:round/>
-                      <a:headEnd type="none" w="med" len="med"/>
-                      <a:tailEnd type="none" w="med" len="med"/>
-                    </a:lnB>
-                    <a:lnTlToBr w="12700" cmpd="sng">
-                      <a:noFill/>
-                      <a:prstDash val="solid"/>
-                    </a:lnTlToBr>
-                    <a:lnBlToTr w="12700" cmpd="sng">
-                      <a:noFill/>
-                      <a:prstDash val="solid"/>
-                    </a:lnBlToTr>
-                  </a:tcPr>
-                </a:tc>
-                <a:tc>
-                  <a:txBody>
-                    <a:bodyPr/>
-                    <a:lstStyle/>
-                    <a:p>
-                      <a:pPr marL="119063" lvl="2" indent="-119063">
-                        <a:buFont typeface="Arial" panose="020B0604020202020204" pitchFamily="34" charset="0"/>
-                        <a:buChar char="•"/>
-                        <a:tabLst/>
-                      </a:pPr>
-                      <a:r>
-                        <a:rPr lang="en-US" sz="1200" b="0" i="0" u="none" strike="noStrike" cap="none" dirty="0">
-                          <a:solidFill>
-                            <a:schemeClr val="tx1"/>
-                          </a:solidFill>
-                          <a:effectLst/>
-                          <a:latin typeface="+mn-lt"/>
-                          <a:ea typeface="+mn-ea"/>
-                          <a:cs typeface="+mn-cs"/>
-                          <a:sym typeface="Arial"/>
-                        </a:rPr>
-                        <a:t>Learn from ASUG and PMI leaders how they generate revenues from patron organizations</a:t>
-                      </a:r>
-                    </a:p>
-                    <a:p>
-                      <a:pPr marL="119063" lvl="2" indent="-119063">
-                        <a:buFont typeface="Arial" panose="020B0604020202020204" pitchFamily="34" charset="0"/>
-                        <a:buChar char="•"/>
-                        <a:tabLst/>
-                      </a:pPr>
-                      <a:r>
-                        <a:rPr lang="en-US" sz="1200" b="0" i="0" u="none" strike="noStrike" cap="none" dirty="0">
-                          <a:solidFill>
-                            <a:schemeClr val="tx1"/>
-                          </a:solidFill>
-                          <a:effectLst/>
-                          <a:latin typeface="+mn-lt"/>
-                          <a:ea typeface="+mn-ea"/>
-                          <a:cs typeface="+mn-cs"/>
-                          <a:sym typeface="Arial"/>
-                        </a:rPr>
-                        <a:t>Learn from AI for Good leaders how they use technology to help humanity</a:t>
-                      </a:r>
-                    </a:p>
-                    <a:p>
-                      <a:pPr marL="119063" lvl="2" indent="-119063">
-                        <a:buFont typeface="Arial" panose="020B0604020202020204" pitchFamily="34" charset="0"/>
-                        <a:buChar char="•"/>
-                        <a:tabLst/>
-                      </a:pPr>
-                      <a:r>
-                        <a:rPr lang="en-US" sz="1200" b="0" i="0" u="none" strike="noStrike" cap="none" dirty="0">
-                          <a:solidFill>
-                            <a:schemeClr val="tx1"/>
-                          </a:solidFill>
-                          <a:effectLst/>
-                          <a:latin typeface="+mn-lt"/>
-                          <a:ea typeface="+mn-ea"/>
-                          <a:cs typeface="+mn-cs"/>
-                          <a:sym typeface="Arial"/>
-                        </a:rPr>
-                        <a:t>Learn from TSIA leaders how they help the Tech Services industry</a:t>
-                      </a:r>
-                    </a:p>
-                    <a:p>
-                      <a:pPr marL="119063" lvl="2" indent="-119063">
-                        <a:buFont typeface="Arial" panose="020B0604020202020204" pitchFamily="34" charset="0"/>
-                        <a:buChar char="•"/>
-                        <a:tabLst/>
-                      </a:pPr>
-                      <a:r>
-                        <a:rPr lang="en-US" sz="1200" b="0" i="0" u="none" strike="noStrike" cap="none" dirty="0">
-                          <a:solidFill>
-                            <a:schemeClr val="tx1"/>
-                          </a:solidFill>
-                          <a:effectLst/>
-                          <a:latin typeface="+mn-lt"/>
-                          <a:ea typeface="+mn-ea"/>
-                          <a:cs typeface="+mn-cs"/>
-                          <a:sym typeface="Arial"/>
-                        </a:rPr>
-                        <a:t>Explore Freemium options for generating revenues (e.g., patron organizations)</a:t>
-                      </a:r>
-                      <a:endParaRPr lang="en-US" sz="1200" b="0" dirty="0">
-                        <a:solidFill>
-                          <a:srgbClr val="00B050"/>
-                        </a:solidFill>
-                      </a:endParaRPr>
-                    </a:p>
-                  </a:txBody>
-                  <a:tcPr>
-                    <a:lnL w="12700" cmpd="sng">
-                      <a:noFill/>
-                    </a:lnL>
-                    <a:lnR w="12700" cmpd="sng">
-                      <a:noFill/>
-                    </a:lnR>
-                    <a:lnT w="12700" cap="flat" cmpd="sng" algn="ctr">
-                      <a:solidFill>
-                        <a:schemeClr val="tx1"/>
-                      </a:solidFill>
-                      <a:prstDash val="solid"/>
-                      <a:round/>
-                      <a:headEnd type="none" w="med" len="med"/>
-                      <a:tailEnd type="none" w="med" len="med"/>
-                    </a:lnT>
-                    <a:lnB w="12700" cap="flat" cmpd="sng" algn="ctr">
-                      <a:solidFill>
-                        <a:schemeClr val="tx1"/>
-                      </a:solidFill>
-                      <a:prstDash val="solid"/>
-                      <a:round/>
-                      <a:headEnd type="none" w="med" len="med"/>
-                      <a:tailEnd type="none" w="med" len="med"/>
-                    </a:lnB>
-                    <a:lnTlToBr w="12700" cmpd="sng">
-                      <a:noFill/>
-                      <a:prstDash val="solid"/>
-                    </a:lnTlToBr>
-                    <a:lnBlToTr w="12700" cmpd="sng">
-                      <a:noFill/>
-                      <a:prstDash val="solid"/>
-                    </a:lnBlToTr>
-                  </a:tcPr>
-                </a:tc>
-                <a:tc>
-                  <a:txBody>
-                    <a:bodyPr/>
-                    <a:lstStyle/>
-                    <a:p>
-                      <a:pPr marL="119063" marR="0" lvl="2" indent="-119063" algn="l" rtl="0">
-                        <a:lnSpc>
-                          <a:spcPct val="100000"/>
-                        </a:lnSpc>
-                        <a:spcBef>
-                          <a:spcPts val="0"/>
-                        </a:spcBef>
-                        <a:spcAft>
-                          <a:spcPts val="0"/>
-                        </a:spcAft>
-                        <a:buClr>
-                          <a:srgbClr val="000000"/>
-                        </a:buClr>
-                        <a:buFont typeface="Arial" panose="020B0604020202020204" pitchFamily="34" charset="0"/>
-                        <a:buChar char="•"/>
-                        <a:tabLst/>
-                      </a:pPr>
-                      <a:r>
-                        <a:rPr lang="en-US" sz="1200" b="0" i="0" u="none" strike="noStrike" cap="none" dirty="0">
-                          <a:solidFill>
-                            <a:schemeClr val="tx1"/>
-                          </a:solidFill>
-                          <a:latin typeface="+mn-lt"/>
-                          <a:ea typeface="+mn-ea"/>
-                          <a:cs typeface="+mn-cs"/>
-                          <a:sym typeface="Arial"/>
-                        </a:rPr>
-                        <a:t>Identify Leader for Industry Innovation Service</a:t>
-                      </a:r>
-                    </a:p>
-                    <a:p>
-                      <a:pPr marL="119063" marR="0" lvl="2" indent="-119063" algn="l" rtl="0">
-                        <a:lnSpc>
-                          <a:spcPct val="100000"/>
-                        </a:lnSpc>
-                        <a:spcBef>
-                          <a:spcPts val="0"/>
-                        </a:spcBef>
-                        <a:spcAft>
-                          <a:spcPts val="0"/>
-                        </a:spcAft>
-                        <a:buClr>
-                          <a:srgbClr val="000000"/>
-                        </a:buClr>
-                        <a:buFont typeface="Arial" panose="020B0604020202020204" pitchFamily="34" charset="0"/>
-                        <a:buChar char="•"/>
-                        <a:tabLst/>
-                      </a:pPr>
-                      <a:r>
-                        <a:rPr lang="en-US" sz="1200" b="0" i="0" u="none" strike="noStrike" cap="none" dirty="0">
-                          <a:solidFill>
-                            <a:schemeClr val="tx1"/>
-                          </a:solidFill>
-                          <a:latin typeface="+mn-lt"/>
-                          <a:ea typeface="+mn-ea"/>
-                          <a:cs typeface="+mn-cs"/>
-                          <a:sym typeface="Arial"/>
-                        </a:rPr>
-                        <a:t>Run MVPs for Freemium options</a:t>
-                      </a:r>
-                    </a:p>
-                  </a:txBody>
-                  <a:tcPr>
-                    <a:lnL w="12700" cmpd="sng">
-                      <a:noFill/>
-                    </a:lnL>
-                    <a:lnR w="12700" cmpd="sng">
-                      <a:noFill/>
-                    </a:lnR>
-                    <a:lnT w="12700" cap="flat" cmpd="sng" algn="ctr">
-                      <a:solidFill>
-                        <a:schemeClr val="tx1"/>
-                      </a:solidFill>
-                      <a:prstDash val="solid"/>
-                      <a:round/>
-                      <a:headEnd type="none" w="med" len="med"/>
-                      <a:tailEnd type="none" w="med" len="med"/>
-                    </a:lnT>
-                    <a:lnB w="12700" cap="flat" cmpd="sng" algn="ctr">
-                      <a:solidFill>
-                        <a:schemeClr val="tx1"/>
-                      </a:solidFill>
-                      <a:prstDash val="solid"/>
-                      <a:round/>
-                      <a:headEnd type="none" w="med" len="med"/>
-                      <a:tailEnd type="none" w="med" len="med"/>
-                    </a:lnB>
-                    <a:lnTlToBr w="12700" cmpd="sng">
-                      <a:noFill/>
-                      <a:prstDash val="solid"/>
-                    </a:lnTlToBr>
-                    <a:lnBlToTr w="12700" cmpd="sng">
-                      <a:noFill/>
-                      <a:prstDash val="solid"/>
-                    </a:lnBlToTr>
-                  </a:tcPr>
-                </a:tc>
-                <a:extLst>
-                  <a:ext uri="{0D108BD9-81ED-4DB2-BD59-A6C34878D82A}">
-                    <a16:rowId xmlns:a16="http://schemas.microsoft.com/office/drawing/2014/main" val="2047728929"/>
-                  </a:ext>
-                </a:extLst>
-              </a:tr>
-            </a:tbl>
-          </a:graphicData>
-        </a:graphic>
-      </p:graphicFrame>
-    </p:spTree>
-    <p:extLst>
-      <p:ext uri="{BB962C8B-B14F-4D97-AF65-F5344CB8AC3E}">
-        <p14:creationId xmlns:p14="http://schemas.microsoft.com/office/powerpoint/2010/main" val="401125609"/>
-      </p:ext>
-    </p:extLst>
-  </p:cSld>
-  <p:clrMapOvr>
-    <a:masterClrMapping/>
-  </p:clrMapOvr>
-</p:sld>
-</file>
-
 <file path=ppt/slides/slide2.xml><?xml version="1.0" encoding="utf-8"?>
 <p:sld xmlns:a="http://schemas.openxmlformats.org/drawingml/2006/main" xmlns:r="http://schemas.openxmlformats.org/officeDocument/2006/relationships" xmlns:p="http://schemas.openxmlformats.org/presentationml/2006/main">
   <p:cSld>

</xml_diff>

<commit_message>
Further reconciled the Strategy and Product Plan
</commit_message>
<xml_diff>
--- a/docs/1_Integration/1b_Strategy/AccelRR8 Consortium Non-Profit Organization Strategy.pptx
+++ b/docs/1_Integration/1b_Strategy/AccelRR8 Consortium Non-Profit Organization Strategy.pptx
@@ -5,7 +5,7 @@
     <p:sldMasterId id="2147483648" r:id="rId1"/>
   </p:sldMasterIdLst>
   <p:notesMasterIdLst>
-    <p:notesMasterId r:id="rId16"/>
+    <p:notesMasterId r:id="rId15"/>
   </p:notesMasterIdLst>
   <p:sldIdLst>
     <p:sldId id="256" r:id="rId2"/>
@@ -21,7 +21,6 @@
     <p:sldId id="278" r:id="rId12"/>
     <p:sldId id="406" r:id="rId13"/>
     <p:sldId id="274" r:id="rId14"/>
-    <p:sldId id="417" r:id="rId15"/>
   </p:sldIdLst>
   <p:sldSz cx="12192000" cy="6858000"/>
   <p:notesSz cx="6858000" cy="9144000"/>
@@ -288,7 +287,6 @@
           <p14:sldIdLst>
             <p14:sldId id="406"/>
             <p14:sldId id="274"/>
-            <p14:sldId id="417"/>
           </p14:sldIdLst>
         </p14:section>
       </p14:sectionLst>
@@ -297,7 +295,7 @@
       <p15:sldGuideLst xmlns:p15="http://schemas.microsoft.com/office/powerpoint/2012/main"/>
     </p:ext>
     <p:ext uri="GoogleSlidesCustomDataVersion2">
-      <go:slidesCustomData xmlns="" xmlns:go="http://customooxmlschemas.google.com/" xmlns:ahyp="http://schemas.microsoft.com/office/drawing/2018/hyperlinkcolor" xmlns:p15="http://schemas.microsoft.com/office/powerpoint/2012/main" xmlns:p14="http://schemas.microsoft.com/office/powerpoint/2010/main" xmlns:com="http://schemas.openxmlformats.org/drawingml/2006/compatibility" xmlns:pvml="urn:schemas-microsoft-com:office:powerpoint" xmlns:v="urn:schemas-microsoft-com:vml" xmlns:o="urn:schemas-microsoft-com:office:office" xmlns:dgm="http://schemas.openxmlformats.org/drawingml/2006/diagram" xmlns:c="http://schemas.openxmlformats.org/drawingml/2006/chart" xmlns:mv="urn:schemas-microsoft-com:mac:vml" xmlns:mc="http://schemas.openxmlformats.org/markup-compatibility/2006" r:id="rId35" roundtripDataSignature="AMtx7mhwEp+Eio5qReXqYqUwMP31HB0A8A=="/>
+      <go:slidesCustomData xmlns:mc="http://schemas.openxmlformats.org/markup-compatibility/2006" xmlns:mv="urn:schemas-microsoft-com:mac:vml" xmlns:c="http://schemas.openxmlformats.org/drawingml/2006/chart" xmlns:dgm="http://schemas.openxmlformats.org/drawingml/2006/diagram" xmlns:o="urn:schemas-microsoft-com:office:office" xmlns:v="urn:schemas-microsoft-com:vml" xmlns:pvml="urn:schemas-microsoft-com:office:powerpoint" xmlns:com="http://schemas.openxmlformats.org/drawingml/2006/compatibility" xmlns:p14="http://schemas.microsoft.com/office/powerpoint/2010/main" xmlns:p15="http://schemas.microsoft.com/office/powerpoint/2012/main" xmlns:ahyp="http://schemas.microsoft.com/office/drawing/2018/hyperlinkcolor" xmlns:go="http://customooxmlschemas.google.com/" xmlns="" r:id="rId35" roundtripDataSignature="AMtx7mhwEp+Eio5qReXqYqUwMP31HB0A8A=="/>
     </p:ext>
   </p:extLst>
 </p:presentation>
@@ -316,7 +314,7 @@
   <pc:docChgLst>
     <pc:chgData name="Rich Reba" userId="55db41ab6eb3f845" providerId="LiveId" clId="{0E19DA16-244C-5B50-BE0F-52911DD4CA7E}"/>
     <pc:docChg chg="undo redo custSel addSld delSld modSld sldOrd delMainMaster delSection modSection">
-      <pc:chgData name="Rich Reba" userId="55db41ab6eb3f845" providerId="LiveId" clId="{0E19DA16-244C-5B50-BE0F-52911DD4CA7E}" dt="2026-08-06T20:42:45.418" v="1287" actId="2696"/>
+      <pc:chgData name="Rich Reba" userId="55db41ab6eb3f845" providerId="LiveId" clId="{0E19DA16-244C-5B50-BE0F-52911DD4CA7E}" dt="2026-08-06T20:45:45.343" v="1288" actId="2696"/>
       <pc:docMkLst>
         <pc:docMk/>
       </pc:docMkLst>
@@ -911,8 +909,8 @@
           </ac:spMkLst>
         </pc:spChg>
       </pc:sldChg>
-      <pc:sldChg chg="ord">
-        <pc:chgData name="Rich Reba" userId="55db41ab6eb3f845" providerId="LiveId" clId="{0E19DA16-244C-5B50-BE0F-52911DD4CA7E}" dt="2026-08-06T19:13:34.454" v="1257" actId="20578"/>
+      <pc:sldChg chg="del ord">
+        <pc:chgData name="Rich Reba" userId="55db41ab6eb3f845" providerId="LiveId" clId="{0E19DA16-244C-5B50-BE0F-52911DD4CA7E}" dt="2026-08-06T20:45:45.343" v="1288" actId="2696"/>
         <pc:sldMkLst>
           <pc:docMk/>
           <pc:sldMk cId="311973841" sldId="417"/>
@@ -3807,119 +3805,6 @@
 </p:sldLayout>
 </file>
 
-<file path=ppt/slideLayouts/slideLayout10.xml><?xml version="1.0" encoding="utf-8"?>
-<p:sldLayout xmlns:a="http://schemas.openxmlformats.org/drawingml/2006/main" xmlns:r="http://schemas.openxmlformats.org/officeDocument/2006/relationships" xmlns:p="http://schemas.openxmlformats.org/presentationml/2006/main" type="blank">
-  <p:cSld name="Blank">
-    <p:spTree>
-      <p:nvGrpSpPr>
-        <p:cNvPr id="1" name=""/>
-        <p:cNvGrpSpPr/>
-        <p:nvPr/>
-      </p:nvGrpSpPr>
-      <p:grpSpPr>
-        <a:xfrm>
-          <a:off x="0" y="0"/>
-          <a:ext cx="0" cy="0"/>
-          <a:chOff x="0" y="0"/>
-          <a:chExt cx="0" cy="0"/>
-        </a:xfrm>
-      </p:grpSpPr>
-      <p:sp>
-        <p:nvSpPr>
-          <p:cNvPr id="2" name="Date Placeholder 1">
-            <a:extLst>
-              <a:ext uri="{FF2B5EF4-FFF2-40B4-BE49-F238E27FC236}">
-                <a16:creationId xmlns:a16="http://schemas.microsoft.com/office/drawing/2014/main" id="{6514D81E-56A4-A0A2-279F-38C8B3343F43}"/>
-              </a:ext>
-            </a:extLst>
-          </p:cNvPr>
-          <p:cNvSpPr>
-            <a:spLocks noGrp="1"/>
-          </p:cNvSpPr>
-          <p:nvPr>
-            <p:ph type="dt" sz="half" idx="10"/>
-          </p:nvPr>
-        </p:nvSpPr>
-        <p:spPr/>
-        <p:txBody>
-          <a:bodyPr/>
-          <a:lstStyle/>
-          <a:p>
-            <a:fld id="{9DC09AF2-51A2-8243-A29F-680495D2BD2C}" type="datetimeFigureOut">
-              <a:rPr lang="en-US" smtClean="0"/>
-              <a:t>8/6/26</a:t>
-            </a:fld>
-            <a:endParaRPr lang="en-US"/>
-          </a:p>
-        </p:txBody>
-      </p:sp>
-      <p:sp>
-        <p:nvSpPr>
-          <p:cNvPr id="3" name="Footer Placeholder 2">
-            <a:extLst>
-              <a:ext uri="{FF2B5EF4-FFF2-40B4-BE49-F238E27FC236}">
-                <a16:creationId xmlns:a16="http://schemas.microsoft.com/office/drawing/2014/main" id="{6D6CC58C-80F3-655C-2597-7F3B6D3170F8}"/>
-              </a:ext>
-            </a:extLst>
-          </p:cNvPr>
-          <p:cNvSpPr>
-            <a:spLocks noGrp="1"/>
-          </p:cNvSpPr>
-          <p:nvPr>
-            <p:ph type="ftr" sz="quarter" idx="11"/>
-          </p:nvPr>
-        </p:nvSpPr>
-        <p:spPr/>
-        <p:txBody>
-          <a:bodyPr/>
-          <a:lstStyle/>
-          <a:p>
-            <a:endParaRPr lang="en-US"/>
-          </a:p>
-        </p:txBody>
-      </p:sp>
-      <p:sp>
-        <p:nvSpPr>
-          <p:cNvPr id="4" name="Slide Number Placeholder 3">
-            <a:extLst>
-              <a:ext uri="{FF2B5EF4-FFF2-40B4-BE49-F238E27FC236}">
-                <a16:creationId xmlns:a16="http://schemas.microsoft.com/office/drawing/2014/main" id="{5EA13EB0-DD69-7589-AA19-77F3D50D907F}"/>
-              </a:ext>
-            </a:extLst>
-          </p:cNvPr>
-          <p:cNvSpPr>
-            <a:spLocks noGrp="1"/>
-          </p:cNvSpPr>
-          <p:nvPr>
-            <p:ph type="sldNum" sz="quarter" idx="12"/>
-          </p:nvPr>
-        </p:nvSpPr>
-        <p:spPr/>
-        <p:txBody>
-          <a:bodyPr/>
-          <a:lstStyle/>
-          <a:p>
-            <a:fld id="{65D7FD95-7936-6347-9F0B-72114436EA6C}" type="slidenum">
-              <a:rPr lang="en-US" smtClean="0"/>
-              <a:t>‹#›</a:t>
-            </a:fld>
-            <a:endParaRPr lang="en-US"/>
-          </a:p>
-        </p:txBody>
-      </p:sp>
-    </p:spTree>
-    <p:extLst>
-      <p:ext uri="{BB962C8B-B14F-4D97-AF65-F5344CB8AC3E}">
-        <p14:creationId xmlns:p14="http://schemas.microsoft.com/office/powerpoint/2010/main" val="3880770503"/>
-      </p:ext>
-    </p:extLst>
-  </p:cSld>
-  <p:clrMapOvr>
-    <a:masterClrMapping/>
-  </p:clrMapOvr>
-</p:sldLayout>
-</file>
-
 <file path=ppt/slideLayouts/slideLayout2.xml><?xml version="1.0" encoding="utf-8"?>
 <p:sldLayout xmlns:a="http://schemas.openxmlformats.org/drawingml/2006/main" xmlns:r="http://schemas.openxmlformats.org/officeDocument/2006/relationships" xmlns:p="http://schemas.openxmlformats.org/presentationml/2006/main" matchingName="Section Header" type="secHead">
   <p:cSld name="SECTION_HEADER">
@@ -11592,7 +11477,7 @@
           <p:nvPr/>
         </p:nvPicPr>
         <p:blipFill rotWithShape="1">
-          <a:blip r:embed="rId12">
+          <a:blip r:embed="rId11">
             <a:alphaModFix/>
           </a:blip>
           <a:srcRect/>
@@ -11627,7 +11512,6 @@
     <p:sldLayoutId id="2147483658" r:id="rId7"/>
     <p:sldLayoutId id="2147483659" r:id="rId8"/>
     <p:sldLayoutId id="2147483673" r:id="rId9"/>
-    <p:sldLayoutId id="2147483685" r:id="rId10"/>
   </p:sldLayoutIdLst>
   <p:hf sldNum="0" hdr="0" ftr="0" dt="0"/>
   <p:txStyles>
@@ -16616,1177 +16500,6 @@
 </p:sld>
 </file>
 
-<file path=ppt/slides/slide14.xml><?xml version="1.0" encoding="utf-8"?>
-<p:sld xmlns:a="http://schemas.openxmlformats.org/drawingml/2006/main" xmlns:r="http://schemas.openxmlformats.org/officeDocument/2006/relationships" xmlns:p="http://schemas.openxmlformats.org/presentationml/2006/main">
-  <p:cSld>
-    <p:spTree>
-      <p:nvGrpSpPr>
-        <p:cNvPr id="1" name="">
-          <a:extLst>
-            <a:ext uri="{FF2B5EF4-FFF2-40B4-BE49-F238E27FC236}">
-              <a16:creationId xmlns:a16="http://schemas.microsoft.com/office/drawing/2014/main" id="{1678A191-60DA-7178-4AA9-712BCB1CC370}"/>
-            </a:ext>
-          </a:extLst>
-        </p:cNvPr>
-        <p:cNvGrpSpPr/>
-        <p:nvPr/>
-      </p:nvGrpSpPr>
-      <p:grpSpPr>
-        <a:xfrm>
-          <a:off x="0" y="0"/>
-          <a:ext cx="0" cy="0"/>
-          <a:chOff x="0" y="0"/>
-          <a:chExt cx="0" cy="0"/>
-        </a:xfrm>
-      </p:grpSpPr>
-      <p:sp>
-        <p:nvSpPr>
-          <p:cNvPr id="22" name="Google Shape;96;p2">
-            <a:extLst>
-              <a:ext uri="{FF2B5EF4-FFF2-40B4-BE49-F238E27FC236}">
-                <a16:creationId xmlns:a16="http://schemas.microsoft.com/office/drawing/2014/main" id="{278CDA1C-9746-8737-E977-E13F1843DD8E}"/>
-              </a:ext>
-            </a:extLst>
-          </p:cNvPr>
-          <p:cNvSpPr txBox="1">
-            <a:spLocks/>
-          </p:cNvSpPr>
-          <p:nvPr/>
-        </p:nvSpPr>
-        <p:spPr>
-          <a:xfrm>
-            <a:off x="838199" y="365125"/>
-            <a:ext cx="8950569" cy="1325563"/>
-          </a:xfrm>
-          <a:prstGeom prst="rect">
-            <a:avLst/>
-          </a:prstGeom>
-          <a:noFill/>
-          <a:ln>
-            <a:noFill/>
-          </a:ln>
-        </p:spPr>
-        <p:txBody>
-          <a:bodyPr spcFirstLastPara="1" wrap="square" lIns="91425" tIns="45700" rIns="91425" bIns="45700" anchor="ctr" anchorCtr="0">
-            <a:normAutofit/>
-          </a:bodyPr>
-          <a:lstStyle>
-            <a:defPPr marR="0" lvl="0" algn="l" rtl="0">
-              <a:lnSpc>
-                <a:spcPct val="100000"/>
-              </a:lnSpc>
-              <a:spcBef>
-                <a:spcPts val="0"/>
-              </a:spcBef>
-              <a:spcAft>
-                <a:spcPts val="0"/>
-              </a:spcAft>
-            </a:defPPr>
-            <a:lvl1pPr marR="0" lvl="0" algn="l" rtl="0">
-              <a:lnSpc>
-                <a:spcPct val="100000"/>
-              </a:lnSpc>
-              <a:spcBef>
-                <a:spcPts val="0"/>
-              </a:spcBef>
-              <a:spcAft>
-                <a:spcPts val="0"/>
-              </a:spcAft>
-              <a:buClr>
-                <a:srgbClr val="000000"/>
-              </a:buClr>
-              <a:buFont typeface="Arial"/>
-              <a:defRPr sz="1400" b="0" i="0" u="none" strike="noStrike" cap="none">
-                <a:solidFill>
-                  <a:srgbClr val="000000"/>
-                </a:solidFill>
-                <a:latin typeface="Arial"/>
-                <a:ea typeface="Arial"/>
-                <a:cs typeface="Arial"/>
-                <a:sym typeface="Arial"/>
-              </a:defRPr>
-            </a:lvl1pPr>
-            <a:lvl2pPr marR="0" lvl="1" algn="l" rtl="0">
-              <a:lnSpc>
-                <a:spcPct val="100000"/>
-              </a:lnSpc>
-              <a:spcBef>
-                <a:spcPts val="0"/>
-              </a:spcBef>
-              <a:spcAft>
-                <a:spcPts val="0"/>
-              </a:spcAft>
-              <a:buClr>
-                <a:srgbClr val="000000"/>
-              </a:buClr>
-              <a:buFont typeface="Arial"/>
-              <a:defRPr sz="1400" b="0" i="0" u="none" strike="noStrike" cap="none">
-                <a:solidFill>
-                  <a:srgbClr val="000000"/>
-                </a:solidFill>
-                <a:latin typeface="Arial"/>
-                <a:ea typeface="Arial"/>
-                <a:cs typeface="Arial"/>
-                <a:sym typeface="Arial"/>
-              </a:defRPr>
-            </a:lvl2pPr>
-            <a:lvl3pPr marR="0" lvl="2" algn="l" rtl="0">
-              <a:lnSpc>
-                <a:spcPct val="100000"/>
-              </a:lnSpc>
-              <a:spcBef>
-                <a:spcPts val="0"/>
-              </a:spcBef>
-              <a:spcAft>
-                <a:spcPts val="0"/>
-              </a:spcAft>
-              <a:buClr>
-                <a:srgbClr val="000000"/>
-              </a:buClr>
-              <a:buFont typeface="Arial"/>
-              <a:defRPr sz="1400" b="0" i="0" u="none" strike="noStrike" cap="none">
-                <a:solidFill>
-                  <a:srgbClr val="000000"/>
-                </a:solidFill>
-                <a:latin typeface="Arial"/>
-                <a:ea typeface="Arial"/>
-                <a:cs typeface="Arial"/>
-                <a:sym typeface="Arial"/>
-              </a:defRPr>
-            </a:lvl3pPr>
-            <a:lvl4pPr marR="0" lvl="3" algn="l" rtl="0">
-              <a:lnSpc>
-                <a:spcPct val="100000"/>
-              </a:lnSpc>
-              <a:spcBef>
-                <a:spcPts val="0"/>
-              </a:spcBef>
-              <a:spcAft>
-                <a:spcPts val="0"/>
-              </a:spcAft>
-              <a:buClr>
-                <a:srgbClr val="000000"/>
-              </a:buClr>
-              <a:buFont typeface="Arial"/>
-              <a:defRPr sz="1400" b="0" i="0" u="none" strike="noStrike" cap="none">
-                <a:solidFill>
-                  <a:srgbClr val="000000"/>
-                </a:solidFill>
-                <a:latin typeface="Arial"/>
-                <a:ea typeface="Arial"/>
-                <a:cs typeface="Arial"/>
-                <a:sym typeface="Arial"/>
-              </a:defRPr>
-            </a:lvl4pPr>
-            <a:lvl5pPr marR="0" lvl="4" algn="l" rtl="0">
-              <a:lnSpc>
-                <a:spcPct val="100000"/>
-              </a:lnSpc>
-              <a:spcBef>
-                <a:spcPts val="0"/>
-              </a:spcBef>
-              <a:spcAft>
-                <a:spcPts val="0"/>
-              </a:spcAft>
-              <a:buClr>
-                <a:srgbClr val="000000"/>
-              </a:buClr>
-              <a:buFont typeface="Arial"/>
-              <a:defRPr sz="1400" b="0" i="0" u="none" strike="noStrike" cap="none">
-                <a:solidFill>
-                  <a:srgbClr val="000000"/>
-                </a:solidFill>
-                <a:latin typeface="Arial"/>
-                <a:ea typeface="Arial"/>
-                <a:cs typeface="Arial"/>
-                <a:sym typeface="Arial"/>
-              </a:defRPr>
-            </a:lvl5pPr>
-            <a:lvl6pPr marR="0" lvl="5" algn="l" rtl="0">
-              <a:lnSpc>
-                <a:spcPct val="100000"/>
-              </a:lnSpc>
-              <a:spcBef>
-                <a:spcPts val="0"/>
-              </a:spcBef>
-              <a:spcAft>
-                <a:spcPts val="0"/>
-              </a:spcAft>
-              <a:buClr>
-                <a:srgbClr val="000000"/>
-              </a:buClr>
-              <a:buFont typeface="Arial"/>
-              <a:defRPr sz="1400" b="0" i="0" u="none" strike="noStrike" cap="none">
-                <a:solidFill>
-                  <a:srgbClr val="000000"/>
-                </a:solidFill>
-                <a:latin typeface="Arial"/>
-                <a:ea typeface="Arial"/>
-                <a:cs typeface="Arial"/>
-                <a:sym typeface="Arial"/>
-              </a:defRPr>
-            </a:lvl6pPr>
-            <a:lvl7pPr marR="0" lvl="6" algn="l" rtl="0">
-              <a:lnSpc>
-                <a:spcPct val="100000"/>
-              </a:lnSpc>
-              <a:spcBef>
-                <a:spcPts val="0"/>
-              </a:spcBef>
-              <a:spcAft>
-                <a:spcPts val="0"/>
-              </a:spcAft>
-              <a:buClr>
-                <a:srgbClr val="000000"/>
-              </a:buClr>
-              <a:buFont typeface="Arial"/>
-              <a:defRPr sz="1400" b="0" i="0" u="none" strike="noStrike" cap="none">
-                <a:solidFill>
-                  <a:srgbClr val="000000"/>
-                </a:solidFill>
-                <a:latin typeface="Arial"/>
-                <a:ea typeface="Arial"/>
-                <a:cs typeface="Arial"/>
-                <a:sym typeface="Arial"/>
-              </a:defRPr>
-            </a:lvl7pPr>
-            <a:lvl8pPr marR="0" lvl="7" algn="l" rtl="0">
-              <a:lnSpc>
-                <a:spcPct val="100000"/>
-              </a:lnSpc>
-              <a:spcBef>
-                <a:spcPts val="0"/>
-              </a:spcBef>
-              <a:spcAft>
-                <a:spcPts val="0"/>
-              </a:spcAft>
-              <a:buClr>
-                <a:srgbClr val="000000"/>
-              </a:buClr>
-              <a:buFont typeface="Arial"/>
-              <a:defRPr sz="1400" b="0" i="0" u="none" strike="noStrike" cap="none">
-                <a:solidFill>
-                  <a:srgbClr val="000000"/>
-                </a:solidFill>
-                <a:latin typeface="Arial"/>
-                <a:ea typeface="Arial"/>
-                <a:cs typeface="Arial"/>
-                <a:sym typeface="Arial"/>
-              </a:defRPr>
-            </a:lvl8pPr>
-            <a:lvl9pPr marR="0" lvl="8" algn="l" rtl="0">
-              <a:lnSpc>
-                <a:spcPct val="100000"/>
-              </a:lnSpc>
-              <a:spcBef>
-                <a:spcPts val="0"/>
-              </a:spcBef>
-              <a:spcAft>
-                <a:spcPts val="0"/>
-              </a:spcAft>
-              <a:buClr>
-                <a:srgbClr val="000000"/>
-              </a:buClr>
-              <a:buFont typeface="Arial"/>
-              <a:defRPr sz="1400" b="0" i="0" u="none" strike="noStrike" cap="none">
-                <a:solidFill>
-                  <a:srgbClr val="000000"/>
-                </a:solidFill>
-                <a:latin typeface="Arial"/>
-                <a:ea typeface="Arial"/>
-                <a:cs typeface="Arial"/>
-                <a:sym typeface="Arial"/>
-              </a:defRPr>
-            </a:lvl9pPr>
-          </a:lstStyle>
-          <a:p>
-            <a:pPr>
-              <a:lnSpc>
-                <a:spcPct val="90000"/>
-              </a:lnSpc>
-              <a:buClr>
-                <a:schemeClr val="dk1"/>
-              </a:buClr>
-              <a:buSzPts val="4400"/>
-              <a:buFont typeface="Calibri"/>
-              <a:buNone/>
-            </a:pPr>
-            <a:r>
-              <a:rPr lang="en-US" sz="4400" dirty="0">
-                <a:latin typeface="Calibri" panose="020F0502020204030204" pitchFamily="34" charset="0"/>
-                <a:cs typeface="Calibri" panose="020F0502020204030204" pitchFamily="34" charset="0"/>
-              </a:rPr>
-              <a:t>Consortium Priorities</a:t>
-            </a:r>
-          </a:p>
-          <a:p>
-            <a:pPr>
-              <a:lnSpc>
-                <a:spcPct val="90000"/>
-              </a:lnSpc>
-              <a:buClr>
-                <a:schemeClr val="dk1"/>
-              </a:buClr>
-              <a:buSzPts val="4400"/>
-              <a:buFont typeface="Calibri"/>
-              <a:buNone/>
-            </a:pPr>
-            <a:r>
-              <a:rPr lang="en-US" sz="2400" i="1" dirty="0">
-                <a:latin typeface="Calibri" panose="020F0502020204030204" pitchFamily="34" charset="0"/>
-                <a:cs typeface="Calibri" panose="020F0502020204030204" pitchFamily="34" charset="0"/>
-              </a:rPr>
-              <a:t>Using our own Framework to grow Consortium value exponentially</a:t>
-            </a:r>
-          </a:p>
-        </p:txBody>
-      </p:sp>
-      <p:pic>
-        <p:nvPicPr>
-          <p:cNvPr id="6" name="Picture 5">
-            <a:extLst>
-              <a:ext uri="{FF2B5EF4-FFF2-40B4-BE49-F238E27FC236}">
-                <a16:creationId xmlns:a16="http://schemas.microsoft.com/office/drawing/2014/main" id="{12251142-AFE9-20A0-A16F-3C7CBAEA2B87}"/>
-              </a:ext>
-            </a:extLst>
-          </p:cNvPr>
-          <p:cNvPicPr>
-            <a:picLocks noChangeAspect="1"/>
-          </p:cNvPicPr>
-          <p:nvPr/>
-        </p:nvPicPr>
-        <p:blipFill>
-          <a:blip r:embed="rId2"/>
-          <a:stretch>
-            <a:fillRect/>
-          </a:stretch>
-        </p:blipFill>
-        <p:spPr>
-          <a:xfrm>
-            <a:off x="1435607" y="2726901"/>
-            <a:ext cx="4757057" cy="2565080"/>
-          </a:xfrm>
-          <a:prstGeom prst="rect">
-            <a:avLst/>
-          </a:prstGeom>
-        </p:spPr>
-      </p:pic>
-      <p:graphicFrame>
-        <p:nvGraphicFramePr>
-          <p:cNvPr id="15" name="Table 14">
-            <a:extLst>
-              <a:ext uri="{FF2B5EF4-FFF2-40B4-BE49-F238E27FC236}">
-                <a16:creationId xmlns:a16="http://schemas.microsoft.com/office/drawing/2014/main" id="{D6474217-ABEC-A6EA-9151-B71EFE80D53F}"/>
-              </a:ext>
-            </a:extLst>
-          </p:cNvPr>
-          <p:cNvGraphicFramePr>
-            <a:graphicFrameLocks noGrp="1"/>
-          </p:cNvGraphicFramePr>
-          <p:nvPr>
-            <p:extLst>
-              <p:ext uri="{D42A27DB-BD31-4B8C-83A1-F6EECF244321}">
-                <p14:modId xmlns:p14="http://schemas.microsoft.com/office/powerpoint/2010/main" val="1118859826"/>
-              </p:ext>
-            </p:extLst>
-          </p:nvPr>
-        </p:nvGraphicFramePr>
-        <p:xfrm>
-          <a:off x="6901107" y="2423595"/>
-          <a:ext cx="3855286" cy="3527862"/>
-        </p:xfrm>
-        <a:graphic>
-          <a:graphicData uri="http://schemas.openxmlformats.org/drawingml/2006/table">
-            <a:tbl>
-              <a:tblPr firstRow="1" bandRow="1">
-                <a:tableStyleId>{5940675A-B579-460E-94D1-54222C63F5DA}</a:tableStyleId>
-              </a:tblPr>
-              <a:tblGrid>
-                <a:gridCol w="3855286">
-                  <a:extLst>
-                    <a:ext uri="{9D8B030D-6E8A-4147-A177-3AD203B41FA5}">
-                      <a16:colId xmlns:a16="http://schemas.microsoft.com/office/drawing/2014/main" val="20127695"/>
-                    </a:ext>
-                  </a:extLst>
-                </a:gridCol>
-              </a:tblGrid>
-              <a:tr h="748583">
-                <a:tc>
-                  <a:txBody>
-                    <a:bodyPr/>
-                    <a:lstStyle/>
-                    <a:p>
-                      <a:pPr marL="285750" marR="0" lvl="0" indent="-285750" algn="l" defTabSz="914400" rtl="0" eaLnBrk="1" fontAlgn="auto" latinLnBrk="0" hangingPunct="1">
-                        <a:lnSpc>
-                          <a:spcPct val="100000"/>
-                        </a:lnSpc>
-                        <a:spcBef>
-                          <a:spcPts val="0"/>
-                        </a:spcBef>
-                        <a:spcAft>
-                          <a:spcPts val="0"/>
-                        </a:spcAft>
-                        <a:buClr>
-                          <a:srgbClr val="000000"/>
-                        </a:buClr>
-                        <a:buSzTx/>
-                        <a:buFont typeface="Wingdings" pitchFamily="2" charset="2"/>
-                        <a:buChar char="q"/>
-                        <a:tabLst/>
-                        <a:defRPr/>
-                      </a:pPr>
-                      <a:r>
-                        <a:rPr kumimoji="0" lang="en-US" sz="1400" i="0" u="none" strike="noStrike" kern="1200" cap="none" spc="0" normalizeH="0" baseline="0" noProof="0" dirty="0">
-                          <a:ln>
-                            <a:noFill/>
-                          </a:ln>
-                          <a:solidFill>
-                            <a:schemeClr val="tx1"/>
-                          </a:solidFill>
-                          <a:effectLst/>
-                          <a:uLnTx/>
-                          <a:uFillTx/>
-                          <a:latin typeface="Aptos" panose="02110004020202020204"/>
-                          <a:ea typeface="+mn-ea"/>
-                          <a:cs typeface="Arial"/>
-                          <a:sym typeface="Arial"/>
-                        </a:rPr>
-                        <a:t>To improve our services and be credible, we should use Lean Product Management</a:t>
-                      </a:r>
-                    </a:p>
-                  </a:txBody>
-                  <a:tcPr anchor="ctr">
-                    <a:lnL w="12700" cap="flat" cmpd="sng" algn="ctr">
-                      <a:noFill/>
-                      <a:prstDash val="solid"/>
-                      <a:round/>
-                      <a:headEnd type="none" w="med" len="med"/>
-                      <a:tailEnd type="none" w="med" len="med"/>
-                    </a:lnL>
-                    <a:lnR w="12700" cmpd="sng">
-                      <a:noFill/>
-                    </a:lnR>
-                    <a:lnT w="12700" cap="flat" cmpd="sng" algn="ctr">
-                      <a:solidFill>
-                        <a:schemeClr val="tx1"/>
-                      </a:solidFill>
-                      <a:prstDash val="solid"/>
-                      <a:round/>
-                      <a:headEnd type="none" w="med" len="med"/>
-                      <a:tailEnd type="none" w="med" len="med"/>
-                    </a:lnT>
-                    <a:lnB w="12700" cap="flat" cmpd="sng" algn="ctr">
-                      <a:solidFill>
-                        <a:schemeClr val="tx1"/>
-                      </a:solidFill>
-                      <a:prstDash val="solid"/>
-                      <a:round/>
-                      <a:headEnd type="none" w="med" len="med"/>
-                      <a:tailEnd type="none" w="med" len="med"/>
-                    </a:lnB>
-                    <a:lnTlToBr w="12700" cmpd="sng">
-                      <a:noFill/>
-                      <a:prstDash val="solid"/>
-                    </a:lnTlToBr>
-                    <a:lnBlToTr w="12700" cmpd="sng">
-                      <a:noFill/>
-                      <a:prstDash val="solid"/>
-                    </a:lnBlToTr>
-                  </a:tcPr>
-                </a:tc>
-                <a:extLst>
-                  <a:ext uri="{0D108BD9-81ED-4DB2-BD59-A6C34878D82A}">
-                    <a16:rowId xmlns:a16="http://schemas.microsoft.com/office/drawing/2014/main" val="872717509"/>
-                  </a:ext>
-                </a:extLst>
-              </a:tr>
-              <a:tr h="728133">
-                <a:tc>
-                  <a:txBody>
-                    <a:bodyPr/>
-                    <a:lstStyle/>
-                    <a:p>
-                      <a:pPr marL="285750" marR="0" lvl="0" indent="-285750" algn="l" defTabSz="914400" rtl="0" eaLnBrk="1" fontAlgn="auto" latinLnBrk="0" hangingPunct="1">
-                        <a:lnSpc>
-                          <a:spcPct val="100000"/>
-                        </a:lnSpc>
-                        <a:spcBef>
-                          <a:spcPts val="0"/>
-                        </a:spcBef>
-                        <a:spcAft>
-                          <a:spcPts val="0"/>
-                        </a:spcAft>
-                        <a:buClr>
-                          <a:srgbClr val="000000"/>
-                        </a:buClr>
-                        <a:buSzTx/>
-                        <a:buFont typeface="Wingdings" pitchFamily="2" charset="2"/>
-                        <a:buChar char="q"/>
-                        <a:tabLst/>
-                        <a:defRPr/>
-                      </a:pPr>
-                      <a:r>
-                        <a:rPr kumimoji="0" lang="en-US" sz="1400" i="0" u="none" strike="noStrike" kern="1200" cap="none" spc="0" normalizeH="0" baseline="0" noProof="0" dirty="0">
-                          <a:ln>
-                            <a:noFill/>
-                          </a:ln>
-                          <a:solidFill>
-                            <a:schemeClr val="tx1"/>
-                          </a:solidFill>
-                          <a:effectLst/>
-                          <a:uLnTx/>
-                          <a:uFillTx/>
-                          <a:latin typeface="Aptos" panose="02110004020202020204"/>
-                          <a:ea typeface="+mn-ea"/>
-                          <a:cs typeface="Arial"/>
-                          <a:sym typeface="Arial"/>
-                        </a:rPr>
-                        <a:t>To connect our network and be credible, we should use the right Collaboration Platforms</a:t>
-                      </a:r>
-                    </a:p>
-                  </a:txBody>
-                  <a:tcPr anchor="ctr">
-                    <a:lnL w="12700" cap="flat" cmpd="sng" algn="ctr">
-                      <a:noFill/>
-                      <a:prstDash val="solid"/>
-                      <a:round/>
-                      <a:headEnd type="none" w="med" len="med"/>
-                      <a:tailEnd type="none" w="med" len="med"/>
-                    </a:lnL>
-                    <a:lnR w="12700" cmpd="sng">
-                      <a:noFill/>
-                    </a:lnR>
-                    <a:lnT w="12700" cap="flat" cmpd="sng" algn="ctr">
-                      <a:solidFill>
-                        <a:schemeClr val="tx1"/>
-                      </a:solidFill>
-                      <a:prstDash val="solid"/>
-                      <a:round/>
-                      <a:headEnd type="none" w="med" len="med"/>
-                      <a:tailEnd type="none" w="med" len="med"/>
-                    </a:lnT>
-                    <a:lnB w="12700" cap="flat" cmpd="sng" algn="ctr">
-                      <a:solidFill>
-                        <a:schemeClr val="tx1"/>
-                      </a:solidFill>
-                      <a:prstDash val="solid"/>
-                      <a:round/>
-                      <a:headEnd type="none" w="med" len="med"/>
-                      <a:tailEnd type="none" w="med" len="med"/>
-                    </a:lnB>
-                    <a:lnTlToBr w="12700" cmpd="sng">
-                      <a:noFill/>
-                      <a:prstDash val="solid"/>
-                    </a:lnTlToBr>
-                    <a:lnBlToTr w="12700" cmpd="sng">
-                      <a:noFill/>
-                      <a:prstDash val="solid"/>
-                    </a:lnBlToTr>
-                  </a:tcPr>
-                </a:tc>
-                <a:extLst>
-                  <a:ext uri="{0D108BD9-81ED-4DB2-BD59-A6C34878D82A}">
-                    <a16:rowId xmlns:a16="http://schemas.microsoft.com/office/drawing/2014/main" val="3089640372"/>
-                  </a:ext>
-                </a:extLst>
-              </a:tr>
-              <a:tr h="704954">
-                <a:tc>
-                  <a:txBody>
-                    <a:bodyPr/>
-                    <a:lstStyle/>
-                    <a:p>
-                      <a:pPr marL="285750" indent="-285750">
-                        <a:buFont typeface="Wingdings" pitchFamily="2" charset="2"/>
-                        <a:buChar char="q"/>
-                        <a:tabLst/>
-                      </a:pPr>
-                      <a:r>
-                        <a:rPr kumimoji="0" lang="en-US" sz="1400" i="0" u="none" strike="noStrike" kern="1200" cap="none" spc="0" normalizeH="0" baseline="0" noProof="0" dirty="0">
-                          <a:ln>
-                            <a:noFill/>
-                          </a:ln>
-                          <a:solidFill>
-                            <a:schemeClr val="tx1"/>
-                          </a:solidFill>
-                          <a:effectLst/>
-                          <a:uLnTx/>
-                          <a:uFillTx/>
-                          <a:latin typeface="Aptos" panose="02110004020202020204"/>
-                          <a:ea typeface="+mn-ea"/>
-                          <a:cs typeface="Arial"/>
-                          <a:sym typeface="Arial"/>
-                        </a:rPr>
-                        <a:t>To go viral, we must win advocacy from credible industry influencers</a:t>
-                      </a:r>
-                      <a:endParaRPr lang="en-US" dirty="0">
-                        <a:solidFill>
-                          <a:schemeClr val="tx1"/>
-                        </a:solidFill>
-                      </a:endParaRPr>
-                    </a:p>
-                  </a:txBody>
-                  <a:tcPr anchor="ctr">
-                    <a:lnL w="12700" cap="flat" cmpd="sng" algn="ctr">
-                      <a:noFill/>
-                      <a:prstDash val="solid"/>
-                      <a:round/>
-                      <a:headEnd type="none" w="med" len="med"/>
-                      <a:tailEnd type="none" w="med" len="med"/>
-                    </a:lnL>
-                    <a:lnR w="12700" cmpd="sng">
-                      <a:noFill/>
-                    </a:lnR>
-                    <a:lnT w="12700" cap="flat" cmpd="sng" algn="ctr">
-                      <a:solidFill>
-                        <a:schemeClr val="tx1"/>
-                      </a:solidFill>
-                      <a:prstDash val="solid"/>
-                      <a:round/>
-                      <a:headEnd type="none" w="med" len="med"/>
-                      <a:tailEnd type="none" w="med" len="med"/>
-                    </a:lnT>
-                    <a:lnB w="12700" cap="flat" cmpd="sng" algn="ctr">
-                      <a:solidFill>
-                        <a:schemeClr val="tx1"/>
-                      </a:solidFill>
-                      <a:prstDash val="solid"/>
-                      <a:round/>
-                      <a:headEnd type="none" w="med" len="med"/>
-                      <a:tailEnd type="none" w="med" len="med"/>
-                    </a:lnB>
-                    <a:lnTlToBr w="12700" cmpd="sng">
-                      <a:noFill/>
-                      <a:prstDash val="solid"/>
-                    </a:lnTlToBr>
-                    <a:lnBlToTr w="12700" cmpd="sng">
-                      <a:noFill/>
-                      <a:prstDash val="solid"/>
-                    </a:lnBlToTr>
-                  </a:tcPr>
-                </a:tc>
-                <a:extLst>
-                  <a:ext uri="{0D108BD9-81ED-4DB2-BD59-A6C34878D82A}">
-                    <a16:rowId xmlns:a16="http://schemas.microsoft.com/office/drawing/2014/main" val="2047728929"/>
-                  </a:ext>
-                </a:extLst>
-              </a:tr>
-              <a:tr h="683579">
-                <a:tc>
-                  <a:txBody>
-                    <a:bodyPr/>
-                    <a:lstStyle/>
-                    <a:p>
-                      <a:pPr marL="285750" indent="-285750">
-                        <a:buFont typeface="Wingdings" pitchFamily="2" charset="2"/>
-                        <a:buChar char="q"/>
-                        <a:tabLst/>
-                      </a:pPr>
-                      <a:r>
-                        <a:rPr kumimoji="0" lang="en-US" sz="1400" i="0" u="none" strike="noStrike" kern="1200" cap="none" spc="0" normalizeH="0" baseline="0" noProof="0" dirty="0">
-                          <a:ln>
-                            <a:noFill/>
-                          </a:ln>
-                          <a:solidFill>
-                            <a:schemeClr val="tx1"/>
-                          </a:solidFill>
-                          <a:effectLst/>
-                          <a:uLnTx/>
-                          <a:uFillTx/>
-                          <a:latin typeface="Aptos" panose="02110004020202020204"/>
-                          <a:ea typeface="+mn-ea"/>
-                          <a:cs typeface="Arial"/>
-                          <a:sym typeface="Arial"/>
-                        </a:rPr>
-                        <a:t>To scale quickly, we should learn from leaders experienced in similar non-profits</a:t>
-                      </a:r>
-                      <a:endParaRPr lang="en-US" dirty="0">
-                        <a:solidFill>
-                          <a:schemeClr val="tx1"/>
-                        </a:solidFill>
-                      </a:endParaRPr>
-                    </a:p>
-                  </a:txBody>
-                  <a:tcPr anchor="ctr">
-                    <a:lnL w="12700" cap="flat" cmpd="sng" algn="ctr">
-                      <a:noFill/>
-                      <a:prstDash val="solid"/>
-                      <a:round/>
-                      <a:headEnd type="none" w="med" len="med"/>
-                      <a:tailEnd type="none" w="med" len="med"/>
-                    </a:lnL>
-                    <a:lnR w="12700" cmpd="sng">
-                      <a:noFill/>
-                    </a:lnR>
-                    <a:lnT w="12700" cap="flat" cmpd="sng" algn="ctr">
-                      <a:solidFill>
-                        <a:schemeClr val="tx1"/>
-                      </a:solidFill>
-                      <a:prstDash val="solid"/>
-                      <a:round/>
-                      <a:headEnd type="none" w="med" len="med"/>
-                      <a:tailEnd type="none" w="med" len="med"/>
-                    </a:lnT>
-                    <a:lnB w="12700" cap="flat" cmpd="sng" algn="ctr">
-                      <a:solidFill>
-                        <a:schemeClr val="tx1"/>
-                      </a:solidFill>
-                      <a:prstDash val="solid"/>
-                      <a:round/>
-                      <a:headEnd type="none" w="med" len="med"/>
-                      <a:tailEnd type="none" w="med" len="med"/>
-                    </a:lnB>
-                    <a:lnTlToBr w="12700" cmpd="sng">
-                      <a:noFill/>
-                      <a:prstDash val="solid"/>
-                    </a:lnTlToBr>
-                    <a:lnBlToTr w="12700" cmpd="sng">
-                      <a:noFill/>
-                      <a:prstDash val="solid"/>
-                    </a:lnBlToTr>
-                  </a:tcPr>
-                </a:tc>
-                <a:extLst>
-                  <a:ext uri="{0D108BD9-81ED-4DB2-BD59-A6C34878D82A}">
-                    <a16:rowId xmlns:a16="http://schemas.microsoft.com/office/drawing/2014/main" val="2321847728"/>
-                  </a:ext>
-                </a:extLst>
-              </a:tr>
-              <a:tr h="662613">
-                <a:tc>
-                  <a:txBody>
-                    <a:bodyPr/>
-                    <a:lstStyle/>
-                    <a:p>
-                      <a:pPr marL="285750" indent="-285750">
-                        <a:buFont typeface="Wingdings" pitchFamily="2" charset="2"/>
-                        <a:buChar char="q"/>
-                        <a:tabLst/>
-                      </a:pPr>
-                      <a:r>
-                        <a:rPr lang="en-US" sz="1400" kern="1200" dirty="0">
-                          <a:solidFill>
-                            <a:schemeClr val="tx1"/>
-                          </a:solidFill>
-                          <a:latin typeface="Aptos" panose="02110004020202020204"/>
-                          <a:ea typeface="+mn-ea"/>
-                        </a:rPr>
-                        <a:t>To help us scale and be credible, we must experiment with and practice using AI</a:t>
-                      </a:r>
-                      <a:endParaRPr lang="en-US" dirty="0">
-                        <a:solidFill>
-                          <a:schemeClr val="tx1"/>
-                        </a:solidFill>
-                      </a:endParaRPr>
-                    </a:p>
-                  </a:txBody>
-                  <a:tcPr anchor="ctr">
-                    <a:lnL w="12700" cap="flat" cmpd="sng" algn="ctr">
-                      <a:noFill/>
-                      <a:prstDash val="solid"/>
-                      <a:round/>
-                      <a:headEnd type="none" w="med" len="med"/>
-                      <a:tailEnd type="none" w="med" len="med"/>
-                    </a:lnL>
-                    <a:lnR w="12700" cmpd="sng">
-                      <a:noFill/>
-                    </a:lnR>
-                    <a:lnT w="12700" cap="flat" cmpd="sng" algn="ctr">
-                      <a:solidFill>
-                        <a:schemeClr val="tx1"/>
-                      </a:solidFill>
-                      <a:prstDash val="solid"/>
-                      <a:round/>
-                      <a:headEnd type="none" w="med" len="med"/>
-                      <a:tailEnd type="none" w="med" len="med"/>
-                    </a:lnT>
-                    <a:lnB w="12700" cap="flat" cmpd="sng" algn="ctr">
-                      <a:solidFill>
-                        <a:schemeClr val="tx1"/>
-                      </a:solidFill>
-                      <a:prstDash val="solid"/>
-                      <a:round/>
-                      <a:headEnd type="none" w="med" len="med"/>
-                      <a:tailEnd type="none" w="med" len="med"/>
-                    </a:lnB>
-                    <a:lnTlToBr w="12700" cmpd="sng">
-                      <a:noFill/>
-                      <a:prstDash val="solid"/>
-                    </a:lnTlToBr>
-                    <a:lnBlToTr w="12700" cmpd="sng">
-                      <a:noFill/>
-                      <a:prstDash val="solid"/>
-                    </a:lnBlToTr>
-                  </a:tcPr>
-                </a:tc>
-                <a:extLst>
-                  <a:ext uri="{0D108BD9-81ED-4DB2-BD59-A6C34878D82A}">
-                    <a16:rowId xmlns:a16="http://schemas.microsoft.com/office/drawing/2014/main" val="1735022269"/>
-                  </a:ext>
-                </a:extLst>
-              </a:tr>
-            </a:tbl>
-          </a:graphicData>
-        </a:graphic>
-      </p:graphicFrame>
-      <p:sp>
-        <p:nvSpPr>
-          <p:cNvPr id="27" name="TextBox 26">
-            <a:extLst>
-              <a:ext uri="{FF2B5EF4-FFF2-40B4-BE49-F238E27FC236}">
-                <a16:creationId xmlns:a16="http://schemas.microsoft.com/office/drawing/2014/main" id="{47F7FEC5-E4F2-4640-BABB-2DC3CF664665}"/>
-              </a:ext>
-            </a:extLst>
-          </p:cNvPr>
-          <p:cNvSpPr txBox="1"/>
-          <p:nvPr/>
-        </p:nvSpPr>
-        <p:spPr>
-          <a:xfrm>
-            <a:off x="7195646" y="1843223"/>
-            <a:ext cx="3190530" cy="523220"/>
-          </a:xfrm>
-          <a:prstGeom prst="rect">
-            <a:avLst/>
-          </a:prstGeom>
-          <a:noFill/>
-        </p:spPr>
-        <p:txBody>
-          <a:bodyPr wrap="square">
-            <a:spAutoFit/>
-          </a:bodyPr>
-          <a:lstStyle/>
-          <a:p>
-            <a:r>
-              <a:rPr kumimoji="0" lang="en-US" sz="1400" b="1" i="0" u="none" strike="noStrike" kern="1200" cap="none" spc="0" normalizeH="0" baseline="0" noProof="0" dirty="0">
-                <a:ln>
-                  <a:noFill/>
-                </a:ln>
-                <a:solidFill>
-                  <a:schemeClr val="tx1"/>
-                </a:solidFill>
-                <a:effectLst/>
-                <a:uLnTx/>
-                <a:uFillTx/>
-                <a:latin typeface="Aptos" panose="02110004020202020204"/>
-                <a:ea typeface="+mn-ea"/>
-                <a:cs typeface="Arial"/>
-                <a:sym typeface="Arial"/>
-              </a:rPr>
-              <a:t>What we need to do now to grow </a:t>
-            </a:r>
-            <a:br>
-              <a:rPr kumimoji="0" lang="en-US" sz="1400" b="1" i="0" u="none" strike="noStrike" kern="1200" cap="none" spc="0" normalizeH="0" baseline="0" noProof="0" dirty="0">
-                <a:ln>
-                  <a:noFill/>
-                </a:ln>
-                <a:solidFill>
-                  <a:schemeClr val="tx1"/>
-                </a:solidFill>
-                <a:effectLst/>
-                <a:uLnTx/>
-                <a:uFillTx/>
-                <a:latin typeface="Aptos" panose="02110004020202020204"/>
-                <a:ea typeface="+mn-ea"/>
-                <a:cs typeface="Arial"/>
-                <a:sym typeface="Arial"/>
-              </a:rPr>
-            </a:br>
-            <a:r>
-              <a:rPr kumimoji="0" lang="en-US" sz="1400" b="1" i="0" u="none" strike="noStrike" kern="1200" cap="none" spc="0" normalizeH="0" baseline="0" noProof="0" dirty="0">
-                <a:ln>
-                  <a:noFill/>
-                </a:ln>
-                <a:solidFill>
-                  <a:schemeClr val="tx1"/>
-                </a:solidFill>
-                <a:effectLst/>
-                <a:uLnTx/>
-                <a:uFillTx/>
-                <a:latin typeface="Aptos" panose="02110004020202020204"/>
-                <a:ea typeface="+mn-ea"/>
-                <a:cs typeface="Arial"/>
-                <a:sym typeface="Arial"/>
-              </a:rPr>
-              <a:t>Consortium value exponentially</a:t>
-            </a:r>
-            <a:endParaRPr lang="en-US" dirty="0">
-              <a:solidFill>
-                <a:schemeClr val="tx1"/>
-              </a:solidFill>
-            </a:endParaRPr>
-          </a:p>
-        </p:txBody>
-      </p:sp>
-      <p:cxnSp>
-        <p:nvCxnSpPr>
-          <p:cNvPr id="33" name="Straight Connector 32">
-            <a:extLst>
-              <a:ext uri="{FF2B5EF4-FFF2-40B4-BE49-F238E27FC236}">
-                <a16:creationId xmlns:a16="http://schemas.microsoft.com/office/drawing/2014/main" id="{A10F0D5E-B3A7-C15F-E7E4-FB9BC83DE9A2}"/>
-              </a:ext>
-            </a:extLst>
-          </p:cNvPr>
-          <p:cNvCxnSpPr/>
-          <p:nvPr/>
-        </p:nvCxnSpPr>
-        <p:spPr>
-          <a:xfrm flipV="1">
-            <a:off x="6096000" y="2423595"/>
-            <a:ext cx="805107" cy="746325"/>
-          </a:xfrm>
-          <a:prstGeom prst="line">
-            <a:avLst/>
-          </a:prstGeom>
-          <a:ln w="12700">
-            <a:solidFill>
-              <a:schemeClr val="tx1"/>
-            </a:solidFill>
-          </a:ln>
-        </p:spPr>
-        <p:style>
-          <a:lnRef idx="1">
-            <a:schemeClr val="accent1"/>
-          </a:lnRef>
-          <a:fillRef idx="0">
-            <a:schemeClr val="accent1"/>
-          </a:fillRef>
-          <a:effectRef idx="0">
-            <a:schemeClr val="accent1"/>
-          </a:effectRef>
-          <a:fontRef idx="minor">
-            <a:schemeClr val="tx1"/>
-          </a:fontRef>
-        </p:style>
-      </p:cxnSp>
-      <p:cxnSp>
-        <p:nvCxnSpPr>
-          <p:cNvPr id="34" name="Straight Connector 33">
-            <a:extLst>
-              <a:ext uri="{FF2B5EF4-FFF2-40B4-BE49-F238E27FC236}">
-                <a16:creationId xmlns:a16="http://schemas.microsoft.com/office/drawing/2014/main" id="{BD61CF38-CCAA-9867-0AC2-DE2EF1BC6EC9}"/>
-              </a:ext>
-            </a:extLst>
-          </p:cNvPr>
-          <p:cNvCxnSpPr>
-            <a:cxnSpLocks/>
-          </p:cNvCxnSpPr>
-          <p:nvPr/>
-        </p:nvCxnSpPr>
-        <p:spPr>
-          <a:xfrm flipV="1">
-            <a:off x="6096000" y="3169920"/>
-            <a:ext cx="805107" cy="377952"/>
-          </a:xfrm>
-          <a:prstGeom prst="line">
-            <a:avLst/>
-          </a:prstGeom>
-          <a:ln w="12700">
-            <a:solidFill>
-              <a:schemeClr val="tx1"/>
-            </a:solidFill>
-          </a:ln>
-        </p:spPr>
-        <p:style>
-          <a:lnRef idx="1">
-            <a:schemeClr val="accent1"/>
-          </a:lnRef>
-          <a:fillRef idx="0">
-            <a:schemeClr val="accent1"/>
-          </a:fillRef>
-          <a:effectRef idx="0">
-            <a:schemeClr val="accent1"/>
-          </a:effectRef>
-          <a:fontRef idx="minor">
-            <a:schemeClr val="tx1"/>
-          </a:fontRef>
-        </p:style>
-      </p:cxnSp>
-      <p:cxnSp>
-        <p:nvCxnSpPr>
-          <p:cNvPr id="38" name="Straight Connector 37">
-            <a:extLst>
-              <a:ext uri="{FF2B5EF4-FFF2-40B4-BE49-F238E27FC236}">
-                <a16:creationId xmlns:a16="http://schemas.microsoft.com/office/drawing/2014/main" id="{D6F35091-77BE-6B3B-00CA-FB1DD33B1F6A}"/>
-              </a:ext>
-            </a:extLst>
-          </p:cNvPr>
-          <p:cNvCxnSpPr>
-            <a:cxnSpLocks/>
-          </p:cNvCxnSpPr>
-          <p:nvPr/>
-        </p:nvCxnSpPr>
-        <p:spPr>
-          <a:xfrm>
-            <a:off x="6096000" y="3897827"/>
-            <a:ext cx="805107" cy="0"/>
-          </a:xfrm>
-          <a:prstGeom prst="line">
-            <a:avLst/>
-          </a:prstGeom>
-          <a:ln w="12700">
-            <a:solidFill>
-              <a:schemeClr val="tx1"/>
-            </a:solidFill>
-          </a:ln>
-        </p:spPr>
-        <p:style>
-          <a:lnRef idx="1">
-            <a:schemeClr val="accent1"/>
-          </a:lnRef>
-          <a:fillRef idx="0">
-            <a:schemeClr val="accent1"/>
-          </a:fillRef>
-          <a:effectRef idx="0">
-            <a:schemeClr val="accent1"/>
-          </a:effectRef>
-          <a:fontRef idx="minor">
-            <a:schemeClr val="tx1"/>
-          </a:fontRef>
-        </p:style>
-      </p:cxnSp>
-      <p:cxnSp>
-        <p:nvCxnSpPr>
-          <p:cNvPr id="41" name="Straight Connector 40">
-            <a:extLst>
-              <a:ext uri="{FF2B5EF4-FFF2-40B4-BE49-F238E27FC236}">
-                <a16:creationId xmlns:a16="http://schemas.microsoft.com/office/drawing/2014/main" id="{9629667B-249A-E98D-36A0-56DA92AFC590}"/>
-              </a:ext>
-            </a:extLst>
-          </p:cNvPr>
-          <p:cNvCxnSpPr>
-            <a:cxnSpLocks/>
-          </p:cNvCxnSpPr>
-          <p:nvPr/>
-        </p:nvCxnSpPr>
-        <p:spPr>
-          <a:xfrm>
-            <a:off x="6096000" y="4259072"/>
-            <a:ext cx="805107" cy="346795"/>
-          </a:xfrm>
-          <a:prstGeom prst="line">
-            <a:avLst/>
-          </a:prstGeom>
-          <a:ln w="12700">
-            <a:solidFill>
-              <a:schemeClr val="tx1"/>
-            </a:solidFill>
-          </a:ln>
-        </p:spPr>
-        <p:style>
-          <a:lnRef idx="1">
-            <a:schemeClr val="accent1"/>
-          </a:lnRef>
-          <a:fillRef idx="0">
-            <a:schemeClr val="accent1"/>
-          </a:fillRef>
-          <a:effectRef idx="0">
-            <a:schemeClr val="accent1"/>
-          </a:effectRef>
-          <a:fontRef idx="minor">
-            <a:schemeClr val="tx1"/>
-          </a:fontRef>
-        </p:style>
-      </p:cxnSp>
-      <p:cxnSp>
-        <p:nvCxnSpPr>
-          <p:cNvPr id="43" name="Straight Connector 42">
-            <a:extLst>
-              <a:ext uri="{FF2B5EF4-FFF2-40B4-BE49-F238E27FC236}">
-                <a16:creationId xmlns:a16="http://schemas.microsoft.com/office/drawing/2014/main" id="{1F55AE74-C89D-D93F-9786-D18B80792D69}"/>
-              </a:ext>
-            </a:extLst>
-          </p:cNvPr>
-          <p:cNvCxnSpPr>
-            <a:cxnSpLocks/>
-          </p:cNvCxnSpPr>
-          <p:nvPr/>
-        </p:nvCxnSpPr>
-        <p:spPr>
-          <a:xfrm>
-            <a:off x="6096000" y="4603383"/>
-            <a:ext cx="805107" cy="686102"/>
-          </a:xfrm>
-          <a:prstGeom prst="line">
-            <a:avLst/>
-          </a:prstGeom>
-          <a:ln w="12700">
-            <a:solidFill>
-              <a:schemeClr val="tx1"/>
-            </a:solidFill>
-          </a:ln>
-        </p:spPr>
-        <p:style>
-          <a:lnRef idx="1">
-            <a:schemeClr val="accent1"/>
-          </a:lnRef>
-          <a:fillRef idx="0">
-            <a:schemeClr val="accent1"/>
-          </a:fillRef>
-          <a:effectRef idx="0">
-            <a:schemeClr val="accent1"/>
-          </a:effectRef>
-          <a:fontRef idx="minor">
-            <a:schemeClr val="tx1"/>
-          </a:fontRef>
-        </p:style>
-      </p:cxnSp>
-      <p:cxnSp>
-        <p:nvCxnSpPr>
-          <p:cNvPr id="45" name="Straight Connector 44">
-            <a:extLst>
-              <a:ext uri="{FF2B5EF4-FFF2-40B4-BE49-F238E27FC236}">
-                <a16:creationId xmlns:a16="http://schemas.microsoft.com/office/drawing/2014/main" id="{85717EBB-9B32-6ADB-6B3E-3C8E82766FFA}"/>
-              </a:ext>
-            </a:extLst>
-          </p:cNvPr>
-          <p:cNvCxnSpPr>
-            <a:cxnSpLocks/>
-          </p:cNvCxnSpPr>
-          <p:nvPr/>
-        </p:nvCxnSpPr>
-        <p:spPr>
-          <a:xfrm>
-            <a:off x="6096000" y="4970272"/>
-            <a:ext cx="805107" cy="981185"/>
-          </a:xfrm>
-          <a:prstGeom prst="line">
-            <a:avLst/>
-          </a:prstGeom>
-          <a:ln w="12700">
-            <a:solidFill>
-              <a:schemeClr val="tx1"/>
-            </a:solidFill>
-          </a:ln>
-        </p:spPr>
-        <p:style>
-          <a:lnRef idx="1">
-            <a:schemeClr val="accent1"/>
-          </a:lnRef>
-          <a:fillRef idx="0">
-            <a:schemeClr val="accent1"/>
-          </a:fillRef>
-          <a:effectRef idx="0">
-            <a:schemeClr val="accent1"/>
-          </a:effectRef>
-          <a:fontRef idx="minor">
-            <a:schemeClr val="tx1"/>
-          </a:fontRef>
-        </p:style>
-      </p:cxnSp>
-    </p:spTree>
-    <p:extLst>
-      <p:ext uri="{BB962C8B-B14F-4D97-AF65-F5344CB8AC3E}">
-        <p14:creationId xmlns:p14="http://schemas.microsoft.com/office/powerpoint/2010/main" val="311973841"/>
-      </p:ext>
-    </p:extLst>
-  </p:cSld>
-  <p:clrMapOvr>
-    <a:masterClrMapping/>
-  </p:clrMapOvr>
-</p:sld>
-</file>
-
 <file path=ppt/slides/slide2.xml><?xml version="1.0" encoding="utf-8"?>
 <p:sld xmlns:a="http://schemas.openxmlformats.org/drawingml/2006/main" xmlns:r="http://schemas.openxmlformats.org/officeDocument/2006/relationships" xmlns:p="http://schemas.openxmlformats.org/presentationml/2006/main">
   <p:cSld>

</xml_diff>

<commit_message>
Added Consortium Priorities to the Strategy
</commit_message>
<xml_diff>
--- a/docs/1_Integration/1b_Strategy/AccelRR8 Consortium Non-Profit Organization Strategy.pptx
+++ b/docs/1_Integration/1b_Strategy/AccelRR8 Consortium Non-Profit Organization Strategy.pptx
@@ -5,7 +5,7 @@
     <p:sldMasterId id="2147483648" r:id="rId1"/>
   </p:sldMasterIdLst>
   <p:notesMasterIdLst>
-    <p:notesMasterId r:id="rId15"/>
+    <p:notesMasterId r:id="rId16"/>
   </p:notesMasterIdLst>
   <p:sldIdLst>
     <p:sldId id="256" r:id="rId2"/>
@@ -21,6 +21,7 @@
     <p:sldId id="278" r:id="rId12"/>
     <p:sldId id="406" r:id="rId13"/>
     <p:sldId id="274" r:id="rId14"/>
+    <p:sldId id="418" r:id="rId15"/>
   </p:sldIdLst>
   <p:sldSz cx="12192000" cy="6858000"/>
   <p:notesSz cx="6858000" cy="9144000"/>
@@ -287,6 +288,7 @@
           <p14:sldIdLst>
             <p14:sldId id="406"/>
             <p14:sldId id="274"/>
+            <p14:sldId id="418"/>
           </p14:sldIdLst>
         </p14:section>
       </p14:sectionLst>
@@ -295,7 +297,7 @@
       <p15:sldGuideLst xmlns:p15="http://schemas.microsoft.com/office/powerpoint/2012/main"/>
     </p:ext>
     <p:ext uri="GoogleSlidesCustomDataVersion2">
-      <go:slidesCustomData xmlns:mc="http://schemas.openxmlformats.org/markup-compatibility/2006" xmlns:mv="urn:schemas-microsoft-com:mac:vml" xmlns:c="http://schemas.openxmlformats.org/drawingml/2006/chart" xmlns:dgm="http://schemas.openxmlformats.org/drawingml/2006/diagram" xmlns:o="urn:schemas-microsoft-com:office:office" xmlns:v="urn:schemas-microsoft-com:vml" xmlns:pvml="urn:schemas-microsoft-com:office:powerpoint" xmlns:com="http://schemas.openxmlformats.org/drawingml/2006/compatibility" xmlns:p14="http://schemas.microsoft.com/office/powerpoint/2010/main" xmlns:p15="http://schemas.microsoft.com/office/powerpoint/2012/main" xmlns:ahyp="http://schemas.microsoft.com/office/drawing/2018/hyperlinkcolor" xmlns:go="http://customooxmlschemas.google.com/" xmlns="" r:id="rId35" roundtripDataSignature="AMtx7mhwEp+Eio5qReXqYqUwMP31HB0A8A=="/>
+      <go:slidesCustomData xmlns="" xmlns:go="http://customooxmlschemas.google.com/" xmlns:ahyp="http://schemas.microsoft.com/office/drawing/2018/hyperlinkcolor" xmlns:p15="http://schemas.microsoft.com/office/powerpoint/2012/main" xmlns:p14="http://schemas.microsoft.com/office/powerpoint/2010/main" xmlns:com="http://schemas.openxmlformats.org/drawingml/2006/compatibility" xmlns:pvml="urn:schemas-microsoft-com:office:powerpoint" xmlns:v="urn:schemas-microsoft-com:vml" xmlns:o="urn:schemas-microsoft-com:office:office" xmlns:dgm="http://schemas.openxmlformats.org/drawingml/2006/diagram" xmlns:c="http://schemas.openxmlformats.org/drawingml/2006/chart" xmlns:mv="urn:schemas-microsoft-com:mac:vml" xmlns:mc="http://schemas.openxmlformats.org/markup-compatibility/2006" r:id="rId35" roundtripDataSignature="AMtx7mhwEp+Eio5qReXqYqUwMP31HB0A8A=="/>
     </p:ext>
   </p:extLst>
 </p:presentation>
@@ -304,7 +306,7 @@
 <file path=ppt/revisionInfo.xml><?xml version="1.0" encoding="utf-8"?>
 <p1510:revInfo xmlns:a="http://schemas.openxmlformats.org/drawingml/2006/main" xmlns:r="http://schemas.openxmlformats.org/officeDocument/2006/relationships" xmlns:p1510="http://schemas.microsoft.com/office/powerpoint/2015/10/main">
   <p1510:revLst>
-    <p1510:client id="{CADD2A7E-913D-4848-8702-F40BD19E1117}" v="29" dt="2026-08-06T19:09:12.787"/>
+    <p1510:client id="{CADD2A7E-913D-4848-8702-F40BD19E1117}" v="34" dt="2026-08-14T12:38:39.548"/>
   </p1510:revLst>
 </p1510:revInfo>
 </file>
@@ -314,7 +316,7 @@
   <pc:docChgLst>
     <pc:chgData name="Rich Reba" userId="55db41ab6eb3f845" providerId="LiveId" clId="{0E19DA16-244C-5B50-BE0F-52911DD4CA7E}"/>
     <pc:docChg chg="undo redo custSel addSld delSld modSld sldOrd delMainMaster delSection modSection">
-      <pc:chgData name="Rich Reba" userId="55db41ab6eb3f845" providerId="LiveId" clId="{0E19DA16-244C-5B50-BE0F-52911DD4CA7E}" dt="2026-08-06T20:45:45.343" v="1288" actId="2696"/>
+      <pc:chgData name="Rich Reba" userId="55db41ab6eb3f845" providerId="LiveId" clId="{0E19DA16-244C-5B50-BE0F-52911DD4CA7E}" dt="2026-08-14T12:38:39.547" v="1297"/>
       <pc:docMkLst>
         <pc:docMk/>
       </pc:docMkLst>
@@ -324,14 +326,6 @@
           <pc:docMk/>
           <pc:sldMk cId="0" sldId="256"/>
         </pc:sldMkLst>
-        <pc:spChg chg="del">
-          <ac:chgData name="Rich Reba" userId="55db41ab6eb3f845" providerId="LiveId" clId="{0E19DA16-244C-5B50-BE0F-52911DD4CA7E}" dt="2026-08-06T18:58:24.758" v="730" actId="478"/>
-          <ac:spMkLst>
-            <pc:docMk/>
-            <pc:sldMk cId="0" sldId="256"/>
-            <ac:spMk id="2" creationId="{5FACCA81-B362-8D11-103C-37960FC92AAC}"/>
-          </ac:spMkLst>
-        </pc:spChg>
         <pc:spChg chg="mod">
           <ac:chgData name="Rich Reba" userId="55db41ab6eb3f845" providerId="LiveId" clId="{0E19DA16-244C-5B50-BE0F-52911DD4CA7E}" dt="2026-08-06T17:16:55.137" v="137" actId="20577"/>
           <ac:spMkLst>
@@ -347,29 +341,6 @@
           <pc:docMk/>
           <pc:sldMk cId="2353389302" sldId="262"/>
         </pc:sldMkLst>
-        <pc:spChg chg="del">
-          <ac:chgData name="Rich Reba" userId="55db41ab6eb3f845" providerId="LiveId" clId="{0E19DA16-244C-5B50-BE0F-52911DD4CA7E}" dt="2026-08-06T18:58:44.221" v="737" actId="478"/>
-          <ac:spMkLst>
-            <pc:docMk/>
-            <pc:sldMk cId="2353389302" sldId="262"/>
-            <ac:spMk id="2" creationId="{BCAB5B48-B8F8-D8B0-3363-89BF14A47DA5}"/>
-          </ac:spMkLst>
-        </pc:spChg>
-      </pc:sldChg>
-      <pc:sldChg chg="delSp add del mod">
-        <pc:chgData name="Rich Reba" userId="55db41ab6eb3f845" providerId="LiveId" clId="{0E19DA16-244C-5B50-BE0F-52911DD4CA7E}" dt="2026-08-06T19:44:07.330" v="1280" actId="2696"/>
-        <pc:sldMkLst>
-          <pc:docMk/>
-          <pc:sldMk cId="4088822028" sldId="263"/>
-        </pc:sldMkLst>
-        <pc:spChg chg="del">
-          <ac:chgData name="Rich Reba" userId="55db41ab6eb3f845" providerId="LiveId" clId="{0E19DA16-244C-5B50-BE0F-52911DD4CA7E}" dt="2026-08-06T18:59:05.597" v="743" actId="478"/>
-          <ac:spMkLst>
-            <pc:docMk/>
-            <pc:sldMk cId="4088822028" sldId="263"/>
-            <ac:spMk id="2" creationId="{D57AE71C-2FC9-1FBC-19D6-92E0039AEF7D}"/>
-          </ac:spMkLst>
-        </pc:spChg>
       </pc:sldChg>
       <pc:sldChg chg="delSp modSp mod">
         <pc:chgData name="Rich Reba" userId="55db41ab6eb3f845" providerId="LiveId" clId="{0E19DA16-244C-5B50-BE0F-52911DD4CA7E}" dt="2026-08-06T18:58:32.405" v="733" actId="478"/>
@@ -377,14 +348,6 @@
           <pc:docMk/>
           <pc:sldMk cId="4274695656" sldId="273"/>
         </pc:sldMkLst>
-        <pc:spChg chg="del">
-          <ac:chgData name="Rich Reba" userId="55db41ab6eb3f845" providerId="LiveId" clId="{0E19DA16-244C-5B50-BE0F-52911DD4CA7E}" dt="2026-08-06T18:58:32.405" v="733" actId="478"/>
-          <ac:spMkLst>
-            <pc:docMk/>
-            <pc:sldMk cId="4274695656" sldId="273"/>
-            <ac:spMk id="2" creationId="{4B602561-35D8-AF27-76E9-EB18F18FC081}"/>
-          </ac:spMkLst>
-        </pc:spChg>
         <pc:spChg chg="mod">
           <ac:chgData name="Rich Reba" userId="55db41ab6eb3f845" providerId="LiveId" clId="{0E19DA16-244C-5B50-BE0F-52911DD4CA7E}" dt="2026-08-06T16:49:37.012" v="11" actId="20577"/>
           <ac:spMkLst>
@@ -400,14 +363,6 @@
           <pc:docMk/>
           <pc:sldMk cId="1656586467" sldId="274"/>
         </pc:sldMkLst>
-        <pc:spChg chg="del">
-          <ac:chgData name="Rich Reba" userId="55db41ab6eb3f845" providerId="LiveId" clId="{0E19DA16-244C-5B50-BE0F-52911DD4CA7E}" dt="2026-08-06T18:59:28.154" v="750" actId="478"/>
-          <ac:spMkLst>
-            <pc:docMk/>
-            <pc:sldMk cId="1656586467" sldId="274"/>
-            <ac:spMk id="6" creationId="{CF348359-6A33-94C2-7023-E826A712A5B3}"/>
-          </ac:spMkLst>
-        </pc:spChg>
         <pc:spChg chg="mod">
           <ac:chgData name="Rich Reba" userId="55db41ab6eb3f845" providerId="LiveId" clId="{0E19DA16-244C-5B50-BE0F-52911DD4CA7E}" dt="2026-08-06T16:55:26.775" v="37" actId="20577"/>
           <ac:spMkLst>
@@ -458,17 +413,17 @@
         </pc:spChg>
       </pc:sldChg>
       <pc:sldChg chg="delSp modSp mod">
-        <pc:chgData name="Rich Reba" userId="55db41ab6eb3f845" providerId="LiveId" clId="{0E19DA16-244C-5B50-BE0F-52911DD4CA7E}" dt="2026-08-06T18:59:11.719" v="745" actId="478"/>
+        <pc:chgData name="Rich Reba" userId="55db41ab6eb3f845" providerId="LiveId" clId="{0E19DA16-244C-5B50-BE0F-52911DD4CA7E}" dt="2026-08-14T12:36:12.470" v="1291"/>
         <pc:sldMkLst>
           <pc:docMk/>
           <pc:sldMk cId="2269987968" sldId="275"/>
         </pc:sldMkLst>
-        <pc:spChg chg="del">
-          <ac:chgData name="Rich Reba" userId="55db41ab6eb3f845" providerId="LiveId" clId="{0E19DA16-244C-5B50-BE0F-52911DD4CA7E}" dt="2026-08-06T18:59:11.719" v="745" actId="478"/>
+        <pc:spChg chg="mod">
+          <ac:chgData name="Rich Reba" userId="55db41ab6eb3f845" providerId="LiveId" clId="{0E19DA16-244C-5B50-BE0F-52911DD4CA7E}" dt="2026-08-14T12:36:12.470" v="1291"/>
           <ac:spMkLst>
             <pc:docMk/>
             <pc:sldMk cId="2269987968" sldId="275"/>
-            <ac:spMk id="2" creationId="{FAEC2788-BD9D-9EED-BC5E-1AED8264C6F9}"/>
+            <ac:spMk id="96" creationId="{00000000-0000-0000-0000-000000000000}"/>
           </ac:spMkLst>
         </pc:spChg>
         <pc:graphicFrameChg chg="modGraphic">
@@ -480,33 +435,18 @@
           </ac:graphicFrameMkLst>
         </pc:graphicFrameChg>
       </pc:sldChg>
-      <pc:sldChg chg="delSp add del mod ord">
-        <pc:chgData name="Rich Reba" userId="55db41ab6eb3f845" providerId="LiveId" clId="{0E19DA16-244C-5B50-BE0F-52911DD4CA7E}" dt="2026-08-06T19:44:07.329" v="1279" actId="2696"/>
-        <pc:sldMkLst>
-          <pc:docMk/>
-          <pc:sldMk cId="1732335019" sldId="276"/>
-        </pc:sldMkLst>
-        <pc:spChg chg="del">
-          <ac:chgData name="Rich Reba" userId="55db41ab6eb3f845" providerId="LiveId" clId="{0E19DA16-244C-5B50-BE0F-52911DD4CA7E}" dt="2026-08-06T18:59:14.554" v="746" actId="478"/>
-          <ac:spMkLst>
-            <pc:docMk/>
-            <pc:sldMk cId="1732335019" sldId="276"/>
-            <ac:spMk id="2" creationId="{FAEC2788-BD9D-9EED-BC5E-1AED8264C6F9}"/>
-          </ac:spMkLst>
-        </pc:spChg>
-      </pc:sldChg>
       <pc:sldChg chg="delSp modSp mod ord">
-        <pc:chgData name="Rich Reba" userId="55db41ab6eb3f845" providerId="LiveId" clId="{0E19DA16-244C-5B50-BE0F-52911DD4CA7E}" dt="2026-08-06T19:08:08.180" v="1126" actId="20578"/>
+        <pc:chgData name="Rich Reba" userId="55db41ab6eb3f845" providerId="LiveId" clId="{0E19DA16-244C-5B50-BE0F-52911DD4CA7E}" dt="2026-08-14T12:35:41.701" v="1290"/>
         <pc:sldMkLst>
           <pc:docMk/>
           <pc:sldMk cId="2006733346" sldId="277"/>
         </pc:sldMkLst>
-        <pc:spChg chg="del">
-          <ac:chgData name="Rich Reba" userId="55db41ab6eb3f845" providerId="LiveId" clId="{0E19DA16-244C-5B50-BE0F-52911DD4CA7E}" dt="2026-08-06T18:58:40.010" v="735" actId="478"/>
+        <pc:spChg chg="mod">
+          <ac:chgData name="Rich Reba" userId="55db41ab6eb3f845" providerId="LiveId" clId="{0E19DA16-244C-5B50-BE0F-52911DD4CA7E}" dt="2026-08-14T12:35:41.701" v="1290"/>
           <ac:spMkLst>
             <pc:docMk/>
             <pc:sldMk cId="2006733346" sldId="277"/>
-            <ac:spMk id="2" creationId="{FAEC2788-BD9D-9EED-BC5E-1AED8264C6F9}"/>
+            <ac:spMk id="96" creationId="{00000000-0000-0000-0000-000000000000}"/>
           </ac:spMkLst>
         </pc:spChg>
         <pc:graphicFrameChg chg="modGraphic">
@@ -524,30 +464,6 @@
           <pc:docMk/>
           <pc:sldMk cId="823924525" sldId="278"/>
         </pc:sldMkLst>
-        <pc:spChg chg="del">
-          <ac:chgData name="Rich Reba" userId="55db41ab6eb3f845" providerId="LiveId" clId="{0E19DA16-244C-5B50-BE0F-52911DD4CA7E}" dt="2026-08-06T18:58:57.062" v="740" actId="478"/>
-          <ac:spMkLst>
-            <pc:docMk/>
-            <pc:sldMk cId="823924525" sldId="278"/>
-            <ac:spMk id="2" creationId="{BCAB5B48-B8F8-D8B0-3363-89BF14A47DA5}"/>
-          </ac:spMkLst>
-        </pc:spChg>
-        <pc:spChg chg="add del">
-          <ac:chgData name="Rich Reba" userId="55db41ab6eb3f845" providerId="LiveId" clId="{0E19DA16-244C-5B50-BE0F-52911DD4CA7E}" dt="2026-08-06T18:50:26.564" v="425" actId="478"/>
-          <ac:spMkLst>
-            <pc:docMk/>
-            <pc:sldMk cId="823924525" sldId="278"/>
-            <ac:spMk id="3" creationId="{392980C8-0F91-1F0B-8CBB-CBE24E0507F8}"/>
-          </ac:spMkLst>
-        </pc:spChg>
-        <pc:spChg chg="add del">
-          <ac:chgData name="Rich Reba" userId="55db41ab6eb3f845" providerId="LiveId" clId="{0E19DA16-244C-5B50-BE0F-52911DD4CA7E}" dt="2026-08-06T18:51:12.660" v="427" actId="478"/>
-          <ac:spMkLst>
-            <pc:docMk/>
-            <pc:sldMk cId="823924525" sldId="278"/>
-            <ac:spMk id="4" creationId="{9F161222-B6F7-86A1-550C-BD26186B4BC5}"/>
-          </ac:spMkLst>
-        </pc:spChg>
         <pc:graphicFrameChg chg="mod modGraphic">
           <ac:chgData name="Rich Reba" userId="55db41ab6eb3f845" providerId="LiveId" clId="{0E19DA16-244C-5B50-BE0F-52911DD4CA7E}" dt="2026-08-06T19:04:41.257" v="1121" actId="20577"/>
           <ac:graphicFrameMkLst>
@@ -596,167 +512,84 @@
             <ac:picMk id="1038" creationId="{57B0734D-BE0E-D5FA-AC6A-C87310AA285C}"/>
           </ac:picMkLst>
         </pc:picChg>
-        <pc:picChg chg="del">
-          <ac:chgData name="Rich Reba" userId="55db41ab6eb3f845" providerId="LiveId" clId="{0E19DA16-244C-5B50-BE0F-52911DD4CA7E}" dt="2026-08-06T18:48:59.058" v="417" actId="478"/>
-          <ac:picMkLst>
-            <pc:docMk/>
-            <pc:sldMk cId="823924525" sldId="278"/>
-            <ac:picMk id="1040" creationId="{B51E3085-C2E4-EDC0-0FA4-21B534177CB1}"/>
-          </ac:picMkLst>
-        </pc:picChg>
-      </pc:sldChg>
-      <pc:sldChg chg="delSp add del mod ord">
-        <pc:chgData name="Rich Reba" userId="55db41ab6eb3f845" providerId="LiveId" clId="{0E19DA16-244C-5B50-BE0F-52911DD4CA7E}" dt="2026-08-06T19:44:07.377" v="1285" actId="2696"/>
-        <pc:sldMkLst>
-          <pc:docMk/>
-          <pc:sldMk cId="3641467929" sldId="279"/>
-        </pc:sldMkLst>
-        <pc:spChg chg="del">
-          <ac:chgData name="Rich Reba" userId="55db41ab6eb3f845" providerId="LiveId" clId="{0E19DA16-244C-5B50-BE0F-52911DD4CA7E}" dt="2026-08-06T18:59:20.189" v="748" actId="478"/>
-          <ac:spMkLst>
-            <pc:docMk/>
-            <pc:sldMk cId="3641467929" sldId="279"/>
-            <ac:spMk id="2" creationId="{FAEC2788-BD9D-9EED-BC5E-1AED8264C6F9}"/>
-          </ac:spMkLst>
-        </pc:spChg>
-      </pc:sldChg>
-      <pc:sldChg chg="del">
-        <pc:chgData name="Rich Reba" userId="55db41ab6eb3f845" providerId="LiveId" clId="{0E19DA16-244C-5B50-BE0F-52911DD4CA7E}" dt="2026-08-06T19:08:33.438" v="1128" actId="2696"/>
-        <pc:sldMkLst>
-          <pc:docMk/>
-          <pc:sldMk cId="2176843835" sldId="398"/>
-        </pc:sldMkLst>
-      </pc:sldChg>
-      <pc:sldChg chg="del">
-        <pc:chgData name="Rich Reba" userId="55db41ab6eb3f845" providerId="LiveId" clId="{0E19DA16-244C-5B50-BE0F-52911DD4CA7E}" dt="2026-08-06T19:08:30.971" v="1127" actId="2696"/>
-        <pc:sldMkLst>
-          <pc:docMk/>
-          <pc:sldMk cId="3350860745" sldId="399"/>
-        </pc:sldMkLst>
-      </pc:sldChg>
-      <pc:sldChg chg="delSp modSp add del mod">
-        <pc:chgData name="Rich Reba" userId="55db41ab6eb3f845" providerId="LiveId" clId="{0E19DA16-244C-5B50-BE0F-52911DD4CA7E}" dt="2026-08-06T19:44:07.349" v="1283" actId="2696"/>
-        <pc:sldMkLst>
-          <pc:docMk/>
-          <pc:sldMk cId="797649862" sldId="400"/>
-        </pc:sldMkLst>
-        <pc:spChg chg="del">
-          <ac:chgData name="Rich Reba" userId="55db41ab6eb3f845" providerId="LiveId" clId="{0E19DA16-244C-5B50-BE0F-52911DD4CA7E}" dt="2026-08-06T18:58:59.192" v="741" actId="478"/>
-          <ac:spMkLst>
-            <pc:docMk/>
-            <pc:sldMk cId="797649862" sldId="400"/>
-            <ac:spMk id="2" creationId="{FAEC2788-BD9D-9EED-BC5E-1AED8264C6F9}"/>
-          </ac:spMkLst>
-        </pc:spChg>
-        <pc:graphicFrameChg chg="modGraphic">
-          <ac:chgData name="Rich Reba" userId="55db41ab6eb3f845" providerId="LiveId" clId="{0E19DA16-244C-5B50-BE0F-52911DD4CA7E}" dt="2026-08-06T16:53:24.579" v="35" actId="20577"/>
-          <ac:graphicFrameMkLst>
-            <pc:docMk/>
-            <pc:sldMk cId="797649862" sldId="400"/>
-            <ac:graphicFrameMk id="5" creationId="{4B70F3A5-8062-29A2-30D0-2783CB3DFCCA}"/>
-          </ac:graphicFrameMkLst>
-        </pc:graphicFrameChg>
-      </pc:sldChg>
-      <pc:sldChg chg="delSp add del mod">
-        <pc:chgData name="Rich Reba" userId="55db41ab6eb3f845" providerId="LiveId" clId="{0E19DA16-244C-5B50-BE0F-52911DD4CA7E}" dt="2026-08-06T19:44:07.349" v="1284" actId="2696"/>
-        <pc:sldMkLst>
-          <pc:docMk/>
-          <pc:sldMk cId="1598126850" sldId="401"/>
-        </pc:sldMkLst>
-        <pc:spChg chg="del">
-          <ac:chgData name="Rich Reba" userId="55db41ab6eb3f845" providerId="LiveId" clId="{0E19DA16-244C-5B50-BE0F-52911DD4CA7E}" dt="2026-08-06T18:58:54.911" v="739" actId="478"/>
-          <ac:spMkLst>
-            <pc:docMk/>
-            <pc:sldMk cId="1598126850" sldId="401"/>
-            <ac:spMk id="2" creationId="{BCAB5B48-B8F8-D8B0-3363-89BF14A47DA5}"/>
-          </ac:spMkLst>
-        </pc:spChg>
       </pc:sldChg>
       <pc:sldChg chg="delSp modSp mod">
-        <pc:chgData name="Rich Reba" userId="55db41ab6eb3f845" providerId="LiveId" clId="{0E19DA16-244C-5B50-BE0F-52911DD4CA7E}" dt="2026-08-06T19:11:35.712" v="1163" actId="20577"/>
+        <pc:chgData name="Rich Reba" userId="55db41ab6eb3f845" providerId="LiveId" clId="{0E19DA16-244C-5B50-BE0F-52911DD4CA7E}" dt="2026-08-14T12:37:00.218" v="1293" actId="14100"/>
         <pc:sldMkLst>
           <pc:docMk/>
           <pc:sldMk cId="1483759223" sldId="403"/>
         </pc:sldMkLst>
-        <pc:spChg chg="del">
-          <ac:chgData name="Rich Reba" userId="55db41ab6eb3f845" providerId="LiveId" clId="{0E19DA16-244C-5B50-BE0F-52911DD4CA7E}" dt="2026-08-06T18:58:27.442" v="731" actId="478"/>
-          <ac:spMkLst>
-            <pc:docMk/>
-            <pc:sldMk cId="1483759223" sldId="403"/>
-            <ac:spMk id="2" creationId="{7B5B63BC-3120-923D-5436-DA830F4D5D86}"/>
-          </ac:spMkLst>
-        </pc:spChg>
         <pc:spChg chg="mod">
-          <ac:chgData name="Rich Reba" userId="55db41ab6eb3f845" providerId="LiveId" clId="{0E19DA16-244C-5B50-BE0F-52911DD4CA7E}" dt="2026-08-06T19:11:35.712" v="1163" actId="20577"/>
+          <ac:chgData name="Rich Reba" userId="55db41ab6eb3f845" providerId="LiveId" clId="{0E19DA16-244C-5B50-BE0F-52911DD4CA7E}" dt="2026-08-14T12:36:44.113" v="1292"/>
           <ac:spMkLst>
             <pc:docMk/>
             <pc:sldMk cId="1483759223" sldId="403"/>
             <ac:spMk id="6" creationId="{F4337B15-7E23-2EDE-6CF5-D3B89F80D6EE}"/>
           </ac:spMkLst>
         </pc:spChg>
+        <pc:spChg chg="mod">
+          <ac:chgData name="Rich Reba" userId="55db41ab6eb3f845" providerId="LiveId" clId="{0E19DA16-244C-5B50-BE0F-52911DD4CA7E}" dt="2026-08-14T12:37:00.218" v="1293" actId="14100"/>
+          <ac:spMkLst>
+            <pc:docMk/>
+            <pc:sldMk cId="1483759223" sldId="403"/>
+            <ac:spMk id="9" creationId="{FC592DD1-87F5-D132-4E6D-9E6BD39D8684}"/>
+          </ac:spMkLst>
+        </pc:spChg>
       </pc:sldChg>
       <pc:sldChg chg="delSp modSp mod">
-        <pc:chgData name="Rich Reba" userId="55db41ab6eb3f845" providerId="LiveId" clId="{0E19DA16-244C-5B50-BE0F-52911DD4CA7E}" dt="2026-08-06T19:12:00.735" v="1190" actId="20577"/>
+        <pc:chgData name="Rich Reba" userId="55db41ab6eb3f845" providerId="LiveId" clId="{0E19DA16-244C-5B50-BE0F-52911DD4CA7E}" dt="2026-08-14T12:37:09.645" v="1294" actId="14100"/>
         <pc:sldMkLst>
           <pc:docMk/>
           <pc:sldMk cId="3748971185" sldId="404"/>
         </pc:sldMkLst>
-        <pc:spChg chg="del">
-          <ac:chgData name="Rich Reba" userId="55db41ab6eb3f845" providerId="LiveId" clId="{0E19DA16-244C-5B50-BE0F-52911DD4CA7E}" dt="2026-08-06T18:58:42.218" v="736" actId="478"/>
-          <ac:spMkLst>
-            <pc:docMk/>
-            <pc:sldMk cId="3748971185" sldId="404"/>
-            <ac:spMk id="2" creationId="{256364FD-CD4B-5575-E7D2-EA4F4665E6BC}"/>
-          </ac:spMkLst>
-        </pc:spChg>
         <pc:spChg chg="mod">
-          <ac:chgData name="Rich Reba" userId="55db41ab6eb3f845" providerId="LiveId" clId="{0E19DA16-244C-5B50-BE0F-52911DD4CA7E}" dt="2026-08-06T19:12:00.735" v="1190" actId="20577"/>
+          <ac:chgData name="Rich Reba" userId="55db41ab6eb3f845" providerId="LiveId" clId="{0E19DA16-244C-5B50-BE0F-52911DD4CA7E}" dt="2026-08-14T12:36:44.113" v="1292"/>
           <ac:spMkLst>
             <pc:docMk/>
             <pc:sldMk cId="3748971185" sldId="404"/>
             <ac:spMk id="6" creationId="{9B95851A-A86B-94C8-AC0F-62639EF5B78F}"/>
           </ac:spMkLst>
         </pc:spChg>
+        <pc:spChg chg="mod">
+          <ac:chgData name="Rich Reba" userId="55db41ab6eb3f845" providerId="LiveId" clId="{0E19DA16-244C-5B50-BE0F-52911DD4CA7E}" dt="2026-08-14T12:37:09.645" v="1294" actId="14100"/>
+          <ac:spMkLst>
+            <pc:docMk/>
+            <pc:sldMk cId="3748971185" sldId="404"/>
+            <ac:spMk id="9" creationId="{4888346C-64E6-5130-171F-82AB0956539C}"/>
+          </ac:spMkLst>
+        </pc:spChg>
       </pc:sldChg>
       <pc:sldChg chg="delSp modSp mod ord">
-        <pc:chgData name="Rich Reba" userId="55db41ab6eb3f845" providerId="LiveId" clId="{0E19DA16-244C-5B50-BE0F-52911DD4CA7E}" dt="2026-08-06T19:13:17.674" v="1255" actId="20577"/>
+        <pc:chgData name="Rich Reba" userId="55db41ab6eb3f845" providerId="LiveId" clId="{0E19DA16-244C-5B50-BE0F-52911DD4CA7E}" dt="2026-08-14T12:37:20.962" v="1295" actId="14100"/>
         <pc:sldMkLst>
           <pc:docMk/>
           <pc:sldMk cId="635661509" sldId="405"/>
         </pc:sldMkLst>
-        <pc:spChg chg="del">
-          <ac:chgData name="Rich Reba" userId="55db41ab6eb3f845" providerId="LiveId" clId="{0E19DA16-244C-5B50-BE0F-52911DD4CA7E}" dt="2026-08-06T18:58:51.712" v="738" actId="478"/>
-          <ac:spMkLst>
-            <pc:docMk/>
-            <pc:sldMk cId="635661509" sldId="405"/>
-            <ac:spMk id="2" creationId="{E5478777-DA64-9B83-8C03-24B5170685D3}"/>
-          </ac:spMkLst>
-        </pc:spChg>
         <pc:spChg chg="mod">
-          <ac:chgData name="Rich Reba" userId="55db41ab6eb3f845" providerId="LiveId" clId="{0E19DA16-244C-5B50-BE0F-52911DD4CA7E}" dt="2026-08-06T19:13:17.674" v="1255" actId="20577"/>
+          <ac:chgData name="Rich Reba" userId="55db41ab6eb3f845" providerId="LiveId" clId="{0E19DA16-244C-5B50-BE0F-52911DD4CA7E}" dt="2026-08-14T12:36:44.113" v="1292"/>
           <ac:spMkLst>
             <pc:docMk/>
             <pc:sldMk cId="635661509" sldId="405"/>
             <ac:spMk id="6" creationId="{E2FF06AE-D06F-A2CC-7814-895F8CA31E06}"/>
           </ac:spMkLst>
         </pc:spChg>
+        <pc:spChg chg="mod">
+          <ac:chgData name="Rich Reba" userId="55db41ab6eb3f845" providerId="LiveId" clId="{0E19DA16-244C-5B50-BE0F-52911DD4CA7E}" dt="2026-08-14T12:37:20.962" v="1295" actId="14100"/>
+          <ac:spMkLst>
+            <pc:docMk/>
+            <pc:sldMk cId="635661509" sldId="405"/>
+            <ac:spMk id="9" creationId="{19E67006-FB22-3E51-1C43-10DE8E8FD432}"/>
+          </ac:spMkLst>
+        </pc:spChg>
       </pc:sldChg>
       <pc:sldChg chg="delSp modSp mod ord">
-        <pc:chgData name="Rich Reba" userId="55db41ab6eb3f845" providerId="LiveId" clId="{0E19DA16-244C-5B50-BE0F-52911DD4CA7E}" dt="2026-08-06T19:12:55.341" v="1227" actId="20578"/>
+        <pc:chgData name="Rich Reba" userId="55db41ab6eb3f845" providerId="LiveId" clId="{0E19DA16-244C-5B50-BE0F-52911DD4CA7E}" dt="2026-08-14T12:37:33.595" v="1296" actId="14100"/>
         <pc:sldMkLst>
           <pc:docMk/>
           <pc:sldMk cId="2348277429" sldId="406"/>
         </pc:sldMkLst>
-        <pc:spChg chg="del">
-          <ac:chgData name="Rich Reba" userId="55db41ab6eb3f845" providerId="LiveId" clId="{0E19DA16-244C-5B50-BE0F-52911DD4CA7E}" dt="2026-08-06T18:59:08.448" v="744" actId="478"/>
-          <ac:spMkLst>
-            <pc:docMk/>
-            <pc:sldMk cId="2348277429" sldId="406"/>
-            <ac:spMk id="2" creationId="{0A81DB07-1D33-EC9D-0BAF-6CBE9A3C7FD2}"/>
-          </ac:spMkLst>
-        </pc:spChg>
         <pc:spChg chg="mod">
-          <ac:chgData name="Rich Reba" userId="55db41ab6eb3f845" providerId="LiveId" clId="{0E19DA16-244C-5B50-BE0F-52911DD4CA7E}" dt="2026-08-06T19:12:21.934" v="1225" actId="20577"/>
+          <ac:chgData name="Rich Reba" userId="55db41ab6eb3f845" providerId="LiveId" clId="{0E19DA16-244C-5B50-BE0F-52911DD4CA7E}" dt="2026-08-14T12:36:44.113" v="1292"/>
           <ac:spMkLst>
             <pc:docMk/>
             <pc:sldMk cId="2348277429" sldId="406"/>
@@ -764,7 +597,7 @@
           </ac:spMkLst>
         </pc:spChg>
         <pc:spChg chg="mod">
-          <ac:chgData name="Rich Reba" userId="55db41ab6eb3f845" providerId="LiveId" clId="{0E19DA16-244C-5B50-BE0F-52911DD4CA7E}" dt="2026-08-06T19:12:18.523" v="1222" actId="14100"/>
+          <ac:chgData name="Rich Reba" userId="55db41ab6eb3f845" providerId="LiveId" clId="{0E19DA16-244C-5B50-BE0F-52911DD4CA7E}" dt="2026-08-14T12:37:33.595" v="1296" actId="14100"/>
           <ac:spMkLst>
             <pc:docMk/>
             <pc:sldMk cId="2348277429" sldId="406"/>
@@ -772,127 +605,12 @@
           </ac:spMkLst>
         </pc:spChg>
       </pc:sldChg>
-      <pc:sldChg chg="delSp modSp del mod">
-        <pc:chgData name="Rich Reba" userId="55db41ab6eb3f845" providerId="LiveId" clId="{0E19DA16-244C-5B50-BE0F-52911DD4CA7E}" dt="2026-08-06T19:12:57.416" v="1228" actId="2696"/>
-        <pc:sldMkLst>
-          <pc:docMk/>
-          <pc:sldMk cId="1990316212" sldId="407"/>
-        </pc:sldMkLst>
-        <pc:spChg chg="del">
-          <ac:chgData name="Rich Reba" userId="55db41ab6eb3f845" providerId="LiveId" clId="{0E19DA16-244C-5B50-BE0F-52911DD4CA7E}" dt="2026-08-06T18:59:23.284" v="749" actId="478"/>
-          <ac:spMkLst>
-            <pc:docMk/>
-            <pc:sldMk cId="1990316212" sldId="407"/>
-            <ac:spMk id="2" creationId="{2C6C1327-5F69-A48B-8F52-9C41FBC10335}"/>
-          </ac:spMkLst>
-        </pc:spChg>
-        <pc:spChg chg="mod">
-          <ac:chgData name="Rich Reba" userId="55db41ab6eb3f845" providerId="LiveId" clId="{0E19DA16-244C-5B50-BE0F-52911DD4CA7E}" dt="2026-08-06T19:09:12.787" v="1130"/>
-          <ac:spMkLst>
-            <pc:docMk/>
-            <pc:sldMk cId="1990316212" sldId="407"/>
-            <ac:spMk id="6" creationId="{CBE8DA7C-F70F-DAFA-61AA-BE49B8168F4E}"/>
-          </ac:spMkLst>
-        </pc:spChg>
-      </pc:sldChg>
-      <pc:sldChg chg="delSp modSp del mod">
-        <pc:chgData name="Rich Reba" userId="55db41ab6eb3f845" providerId="LiveId" clId="{0E19DA16-244C-5B50-BE0F-52911DD4CA7E}" dt="2026-08-06T19:13:28.978" v="1256" actId="2696"/>
-        <pc:sldMkLst>
-          <pc:docMk/>
-          <pc:sldMk cId="1127022654" sldId="408"/>
-        </pc:sldMkLst>
-        <pc:spChg chg="del">
-          <ac:chgData name="Rich Reba" userId="55db41ab6eb3f845" providerId="LiveId" clId="{0E19DA16-244C-5B50-BE0F-52911DD4CA7E}" dt="2026-08-06T18:59:45.495" v="755" actId="478"/>
-          <ac:spMkLst>
-            <pc:docMk/>
-            <pc:sldMk cId="1127022654" sldId="408"/>
-            <ac:spMk id="2" creationId="{2F718659-9E92-DB57-5D05-71670796977D}"/>
-          </ac:spMkLst>
-        </pc:spChg>
-        <pc:spChg chg="mod">
-          <ac:chgData name="Rich Reba" userId="55db41ab6eb3f845" providerId="LiveId" clId="{0E19DA16-244C-5B50-BE0F-52911DD4CA7E}" dt="2026-08-06T19:09:12.787" v="1130"/>
-          <ac:spMkLst>
-            <pc:docMk/>
-            <pc:sldMk cId="1127022654" sldId="408"/>
-            <ac:spMk id="6" creationId="{68E8A7B6-C8A3-91B1-C3A0-85015C8AA20F}"/>
-          </ac:spMkLst>
-        </pc:spChg>
-      </pc:sldChg>
-      <pc:sldChg chg="delSp modSp del mod ord">
-        <pc:chgData name="Rich Reba" userId="55db41ab6eb3f845" providerId="LiveId" clId="{0E19DA16-244C-5B50-BE0F-52911DD4CA7E}" dt="2026-08-06T20:42:45.418" v="1287" actId="2696"/>
-        <pc:sldMkLst>
-          <pc:docMk/>
-          <pc:sldMk cId="401125609" sldId="409"/>
-        </pc:sldMkLst>
-        <pc:spChg chg="del">
-          <ac:chgData name="Rich Reba" userId="55db41ab6eb3f845" providerId="LiveId" clId="{0E19DA16-244C-5B50-BE0F-52911DD4CA7E}" dt="2026-08-06T18:59:49.237" v="756" actId="478"/>
-          <ac:spMkLst>
-            <pc:docMk/>
-            <pc:sldMk cId="401125609" sldId="409"/>
-            <ac:spMk id="2" creationId="{E1AC71C2-3A98-1EDD-95E0-0996A2B53388}"/>
-          </ac:spMkLst>
-        </pc:spChg>
-        <pc:spChg chg="mod">
-          <ac:chgData name="Rich Reba" userId="55db41ab6eb3f845" providerId="LiveId" clId="{0E19DA16-244C-5B50-BE0F-52911DD4CA7E}" dt="2026-08-06T16:56:15.491" v="92" actId="20577"/>
-          <ac:spMkLst>
-            <pc:docMk/>
-            <pc:sldMk cId="401125609" sldId="409"/>
-            <ac:spMk id="96" creationId="{213A3A61-4044-D39A-7839-F3AEFE0C296B}"/>
-          </ac:spMkLst>
-        </pc:spChg>
-        <pc:graphicFrameChg chg="modGraphic">
-          <ac:chgData name="Rich Reba" userId="55db41ab6eb3f845" providerId="LiveId" clId="{0E19DA16-244C-5B50-BE0F-52911DD4CA7E}" dt="2026-08-06T16:56:31.704" v="101" actId="20577"/>
-          <ac:graphicFrameMkLst>
-            <pc:docMk/>
-            <pc:sldMk cId="401125609" sldId="409"/>
-            <ac:graphicFrameMk id="5" creationId="{5855B0BF-5869-4C17-DDB9-4330FF90D640}"/>
-          </ac:graphicFrameMkLst>
-        </pc:graphicFrameChg>
-      </pc:sldChg>
       <pc:sldChg chg="delSp mod">
         <pc:chgData name="Rich Reba" userId="55db41ab6eb3f845" providerId="LiveId" clId="{0E19DA16-244C-5B50-BE0F-52911DD4CA7E}" dt="2026-08-06T18:58:29.737" v="732" actId="478"/>
         <pc:sldMkLst>
           <pc:docMk/>
           <pc:sldMk cId="4221448727" sldId="412"/>
         </pc:sldMkLst>
-        <pc:spChg chg="del">
-          <ac:chgData name="Rich Reba" userId="55db41ab6eb3f845" providerId="LiveId" clId="{0E19DA16-244C-5B50-BE0F-52911DD4CA7E}" dt="2026-08-06T18:58:29.737" v="732" actId="478"/>
-          <ac:spMkLst>
-            <pc:docMk/>
-            <pc:sldMk cId="4221448727" sldId="412"/>
-            <ac:spMk id="2" creationId="{9B5EBED0-2DE7-7CD5-9F31-0BA4D2AE325D}"/>
-          </ac:spMkLst>
-        </pc:spChg>
-      </pc:sldChg>
-      <pc:sldChg chg="delSp add del mod">
-        <pc:chgData name="Rich Reba" userId="55db41ab6eb3f845" providerId="LiveId" clId="{0E19DA16-244C-5B50-BE0F-52911DD4CA7E}" dt="2026-08-06T19:44:07.347" v="1282" actId="2696"/>
-        <pc:sldMkLst>
-          <pc:docMk/>
-          <pc:sldMk cId="2432848383" sldId="414"/>
-        </pc:sldMkLst>
-        <pc:spChg chg="del">
-          <ac:chgData name="Rich Reba" userId="55db41ab6eb3f845" providerId="LiveId" clId="{0E19DA16-244C-5B50-BE0F-52911DD4CA7E}" dt="2026-08-06T18:59:02.936" v="742" actId="478"/>
-          <ac:spMkLst>
-            <pc:docMk/>
-            <pc:sldMk cId="2432848383" sldId="414"/>
-            <ac:spMk id="2" creationId="{D57AE71C-2FC9-1FBC-19D6-92E0039AEF7D}"/>
-          </ac:spMkLst>
-        </pc:spChg>
-      </pc:sldChg>
-      <pc:sldChg chg="delSp add del mod ord">
-        <pc:chgData name="Rich Reba" userId="55db41ab6eb3f845" providerId="LiveId" clId="{0E19DA16-244C-5B50-BE0F-52911DD4CA7E}" dt="2026-08-06T19:44:07.346" v="1281" actId="2696"/>
-        <pc:sldMkLst>
-          <pc:docMk/>
-          <pc:sldMk cId="778364000" sldId="415"/>
-        </pc:sldMkLst>
-        <pc:spChg chg="del">
-          <ac:chgData name="Rich Reba" userId="55db41ab6eb3f845" providerId="LiveId" clId="{0E19DA16-244C-5B50-BE0F-52911DD4CA7E}" dt="2026-08-06T18:59:16.610" v="747" actId="478"/>
-          <ac:spMkLst>
-            <pc:docMk/>
-            <pc:sldMk cId="778364000" sldId="415"/>
-            <ac:spMk id="2" creationId="{4AE0829C-5062-BA46-E8AF-7AF2F6F341D0}"/>
-          </ac:spMkLst>
-        </pc:spChg>
       </pc:sldChg>
       <pc:sldChg chg="delSp mod">
         <pc:chgData name="Rich Reba" userId="55db41ab6eb3f845" providerId="LiveId" clId="{0E19DA16-244C-5B50-BE0F-52911DD4CA7E}" dt="2026-08-06T18:58:36.383" v="734" actId="478"/>
@@ -900,103 +618,14 @@
           <pc:docMk/>
           <pc:sldMk cId="2033129414" sldId="416"/>
         </pc:sldMkLst>
-        <pc:spChg chg="del">
-          <ac:chgData name="Rich Reba" userId="55db41ab6eb3f845" providerId="LiveId" clId="{0E19DA16-244C-5B50-BE0F-52911DD4CA7E}" dt="2026-08-06T18:58:36.383" v="734" actId="478"/>
-          <ac:spMkLst>
-            <pc:docMk/>
-            <pc:sldMk cId="2033129414" sldId="416"/>
-            <ac:spMk id="6" creationId="{F32EC156-DB74-96C9-E919-C71668652936}"/>
-          </ac:spMkLst>
-        </pc:spChg>
       </pc:sldChg>
-      <pc:sldChg chg="del ord">
-        <pc:chgData name="Rich Reba" userId="55db41ab6eb3f845" providerId="LiveId" clId="{0E19DA16-244C-5B50-BE0F-52911DD4CA7E}" dt="2026-08-06T20:45:45.343" v="1288" actId="2696"/>
+      <pc:sldChg chg="add">
+        <pc:chgData name="Rich Reba" userId="55db41ab6eb3f845" providerId="LiveId" clId="{0E19DA16-244C-5B50-BE0F-52911DD4CA7E}" dt="2026-08-14T12:38:39.547" v="1297"/>
         <pc:sldMkLst>
           <pc:docMk/>
-          <pc:sldMk cId="311973841" sldId="417"/>
+          <pc:sldMk cId="3955824805" sldId="418"/>
         </pc:sldMkLst>
       </pc:sldChg>
-      <pc:sldChg chg="delSp add del mod">
-        <pc:chgData name="Rich Reba" userId="55db41ab6eb3f845" providerId="LiveId" clId="{0E19DA16-244C-5B50-BE0F-52911DD4CA7E}" dt="2026-08-06T19:13:49.506" v="1262" actId="2696"/>
-        <pc:sldMkLst>
-          <pc:docMk/>
-          <pc:sldMk cId="4015092339" sldId="418"/>
-        </pc:sldMkLst>
-        <pc:spChg chg="del">
-          <ac:chgData name="Rich Reba" userId="55db41ab6eb3f845" providerId="LiveId" clId="{0E19DA16-244C-5B50-BE0F-52911DD4CA7E}" dt="2026-08-06T18:59:34.708" v="752" actId="478"/>
-          <ac:spMkLst>
-            <pc:docMk/>
-            <pc:sldMk cId="4015092339" sldId="418"/>
-            <ac:spMk id="2" creationId="{462B9D62-4B92-3A8C-DA14-A225E2194D1F}"/>
-          </ac:spMkLst>
-        </pc:spChg>
-      </pc:sldChg>
-      <pc:sldChg chg="delSp add del mod">
-        <pc:chgData name="Rich Reba" userId="55db41ab6eb3f845" providerId="LiveId" clId="{0E19DA16-244C-5B50-BE0F-52911DD4CA7E}" dt="2026-08-06T19:13:49.497" v="1261" actId="2696"/>
-        <pc:sldMkLst>
-          <pc:docMk/>
-          <pc:sldMk cId="3381750306" sldId="419"/>
-        </pc:sldMkLst>
-        <pc:spChg chg="del">
-          <ac:chgData name="Rich Reba" userId="55db41ab6eb3f845" providerId="LiveId" clId="{0E19DA16-244C-5B50-BE0F-52911DD4CA7E}" dt="2026-08-06T18:59:38.068" v="753" actId="478"/>
-          <ac:spMkLst>
-            <pc:docMk/>
-            <pc:sldMk cId="3381750306" sldId="419"/>
-            <ac:spMk id="2" creationId="{A837E304-B0E0-78B0-2263-1A31EE4658E7}"/>
-          </ac:spMkLst>
-        </pc:spChg>
-      </pc:sldChg>
-      <pc:sldChg chg="delSp add del mod">
-        <pc:chgData name="Rich Reba" userId="55db41ab6eb3f845" providerId="LiveId" clId="{0E19DA16-244C-5B50-BE0F-52911DD4CA7E}" dt="2026-08-06T19:13:49.496" v="1260" actId="2696"/>
-        <pc:sldMkLst>
-          <pc:docMk/>
-          <pc:sldMk cId="4209041106" sldId="420"/>
-        </pc:sldMkLst>
-        <pc:spChg chg="del">
-          <ac:chgData name="Rich Reba" userId="55db41ab6eb3f845" providerId="LiveId" clId="{0E19DA16-244C-5B50-BE0F-52911DD4CA7E}" dt="2026-08-06T18:59:41.636" v="754" actId="478"/>
-          <ac:spMkLst>
-            <pc:docMk/>
-            <pc:sldMk cId="4209041106" sldId="420"/>
-            <ac:spMk id="2" creationId="{7FEDDB3B-2B33-FC16-9957-17D50DC8B784}"/>
-          </ac:spMkLst>
-        </pc:spChg>
-      </pc:sldChg>
-      <pc:sldChg chg="delSp add del mod">
-        <pc:chgData name="Rich Reba" userId="55db41ab6eb3f845" providerId="LiveId" clId="{0E19DA16-244C-5B50-BE0F-52911DD4CA7E}" dt="2026-08-06T19:13:49.493" v="1259" actId="2696"/>
-        <pc:sldMkLst>
-          <pc:docMk/>
-          <pc:sldMk cId="3765181648" sldId="421"/>
-        </pc:sldMkLst>
-        <pc:spChg chg="del">
-          <ac:chgData name="Rich Reba" userId="55db41ab6eb3f845" providerId="LiveId" clId="{0E19DA16-244C-5B50-BE0F-52911DD4CA7E}" dt="2026-08-06T18:59:32.549" v="751" actId="478"/>
-          <ac:spMkLst>
-            <pc:docMk/>
-            <pc:sldMk cId="3765181648" sldId="421"/>
-            <ac:spMk id="2" creationId="{581D35DC-2D2E-4B81-D251-A66615F9BC3C}"/>
-          </ac:spMkLst>
-        </pc:spChg>
-      </pc:sldChg>
-      <pc:sldMasterChg chg="del">
-        <pc:chgData name="Rich Reba" userId="55db41ab6eb3f845" providerId="LiveId" clId="{0E19DA16-244C-5B50-BE0F-52911DD4CA7E}" dt="2026-08-06T19:08:33.446" v="1129" actId="2696"/>
-        <pc:sldMasterMkLst>
-          <pc:docMk/>
-          <pc:sldMasterMk cId="3149524428" sldId="2147483661"/>
-        </pc:sldMasterMkLst>
-      </pc:sldMasterChg>
-      <pc:sldMasterChg chg="del">
-        <pc:chgData name="Rich Reba" userId="55db41ab6eb3f845" providerId="LiveId" clId="{0E19DA16-244C-5B50-BE0F-52911DD4CA7E}" dt="2026-08-06T17:15:59.552" v="124" actId="2696"/>
-        <pc:sldMasterMkLst>
-          <pc:docMk/>
-          <pc:sldMasterMk cId="3088172269" sldId="2147483674"/>
-        </pc:sldMasterMkLst>
-      </pc:sldMasterChg>
-      <pc:sldMasterChg chg="del">
-        <pc:chgData name="Rich Reba" userId="55db41ab6eb3f845" providerId="LiveId" clId="{0E19DA16-244C-5B50-BE0F-52911DD4CA7E}" dt="2026-08-06T19:13:49.513" v="1263" actId="2696"/>
-        <pc:sldMasterMkLst>
-          <pc:docMk/>
-          <pc:sldMasterMk cId="808344323" sldId="2147483686"/>
-        </pc:sldMasterMkLst>
-      </pc:sldMasterChg>
     </pc:docChg>
   </pc:docChgLst>
 </pc:chgInfo>
@@ -2005,6 +1634,75 @@
 </p:notes>
 </file>
 
+<file path=ppt/notesSlides/notesSlide14.xml><?xml version="1.0" encoding="utf-8"?>
+<p:notes xmlns:a="http://schemas.openxmlformats.org/drawingml/2006/main" xmlns:r="http://schemas.openxmlformats.org/officeDocument/2006/relationships" xmlns:p="http://schemas.openxmlformats.org/presentationml/2006/main">
+  <p:cSld>
+    <p:spTree>
+      <p:nvGrpSpPr>
+        <p:cNvPr id="1" name=""/>
+        <p:cNvGrpSpPr/>
+        <p:nvPr/>
+      </p:nvGrpSpPr>
+      <p:grpSpPr>
+        <a:xfrm>
+          <a:off x="0" y="0"/>
+          <a:ext cx="0" cy="0"/>
+          <a:chOff x="0" y="0"/>
+          <a:chExt cx="0" cy="0"/>
+        </a:xfrm>
+      </p:grpSpPr>
+      <p:sp>
+        <p:nvSpPr>
+          <p:cNvPr id="2" name="Slide Image Placeholder 1"/>
+          <p:cNvSpPr>
+            <a:spLocks noGrp="1" noRot="1" noChangeAspect="1"/>
+          </p:cNvSpPr>
+          <p:nvPr>
+            <p:ph type="sldImg"/>
+          </p:nvPr>
+        </p:nvSpPr>
+        <p:spPr>
+          <a:xfrm>
+            <a:off x="381000" y="685800"/>
+            <a:ext cx="6096000" cy="3429000"/>
+          </a:xfrm>
+        </p:spPr>
+      </p:sp>
+      <p:sp>
+        <p:nvSpPr>
+          <p:cNvPr id="3" name="Notes Placeholder 2"/>
+          <p:cNvSpPr>
+            <a:spLocks noGrp="1"/>
+          </p:cNvSpPr>
+          <p:nvPr>
+            <p:ph type="body" idx="1"/>
+          </p:nvPr>
+        </p:nvSpPr>
+        <p:spPr/>
+        <p:txBody>
+          <a:bodyPr/>
+          <a:lstStyle/>
+          <a:p>
+            <a:r>
+              <a:rPr lang="en-US" dirty="0"/>
+              <a:t>These are our most important near-term Product priorities</a:t>
+            </a:r>
+          </a:p>
+        </p:txBody>
+      </p:sp>
+    </p:spTree>
+    <p:extLst>
+      <p:ext uri="{BB962C8B-B14F-4D97-AF65-F5344CB8AC3E}">
+        <p14:creationId xmlns:p14="http://schemas.microsoft.com/office/powerpoint/2010/main" val="1523806764"/>
+      </p:ext>
+    </p:extLst>
+  </p:cSld>
+  <p:clrMapOvr>
+    <a:masterClrMapping/>
+  </p:clrMapOvr>
+</p:notes>
+</file>
+
 <file path=ppt/notesSlides/notesSlide2.xml><?xml version="1.0" encoding="utf-8"?>
 <p:notes xmlns:a="http://schemas.openxmlformats.org/drawingml/2006/main" xmlns:r="http://schemas.openxmlformats.org/officeDocument/2006/relationships" xmlns:p="http://schemas.openxmlformats.org/presentationml/2006/main" showMasterSp="0" showMasterPhAnim="0">
   <p:cSld>
@@ -3805,6 +3503,119 @@
 </p:sldLayout>
 </file>
 
+<file path=ppt/slideLayouts/slideLayout10.xml><?xml version="1.0" encoding="utf-8"?>
+<p:sldLayout xmlns:a="http://schemas.openxmlformats.org/drawingml/2006/main" xmlns:r="http://schemas.openxmlformats.org/officeDocument/2006/relationships" xmlns:p="http://schemas.openxmlformats.org/presentationml/2006/main" type="blank">
+  <p:cSld name="Blank">
+    <p:spTree>
+      <p:nvGrpSpPr>
+        <p:cNvPr id="1" name=""/>
+        <p:cNvGrpSpPr/>
+        <p:nvPr/>
+      </p:nvGrpSpPr>
+      <p:grpSpPr>
+        <a:xfrm>
+          <a:off x="0" y="0"/>
+          <a:ext cx="0" cy="0"/>
+          <a:chOff x="0" y="0"/>
+          <a:chExt cx="0" cy="0"/>
+        </a:xfrm>
+      </p:grpSpPr>
+      <p:sp>
+        <p:nvSpPr>
+          <p:cNvPr id="2" name="Date Placeholder 1">
+            <a:extLst>
+              <a:ext uri="{FF2B5EF4-FFF2-40B4-BE49-F238E27FC236}">
+                <a16:creationId xmlns:a16="http://schemas.microsoft.com/office/drawing/2014/main" id="{6514D81E-56A4-A0A2-279F-38C8B3343F43}"/>
+              </a:ext>
+            </a:extLst>
+          </p:cNvPr>
+          <p:cNvSpPr>
+            <a:spLocks noGrp="1"/>
+          </p:cNvSpPr>
+          <p:nvPr>
+            <p:ph type="dt" sz="half" idx="10"/>
+          </p:nvPr>
+        </p:nvSpPr>
+        <p:spPr/>
+        <p:txBody>
+          <a:bodyPr/>
+          <a:lstStyle/>
+          <a:p>
+            <a:fld id="{9DC09AF2-51A2-8243-A29F-680495D2BD2C}" type="datetimeFigureOut">
+              <a:rPr lang="en-US" smtClean="0"/>
+              <a:t>8/14/26</a:t>
+            </a:fld>
+            <a:endParaRPr lang="en-US"/>
+          </a:p>
+        </p:txBody>
+      </p:sp>
+      <p:sp>
+        <p:nvSpPr>
+          <p:cNvPr id="3" name="Footer Placeholder 2">
+            <a:extLst>
+              <a:ext uri="{FF2B5EF4-FFF2-40B4-BE49-F238E27FC236}">
+                <a16:creationId xmlns:a16="http://schemas.microsoft.com/office/drawing/2014/main" id="{6D6CC58C-80F3-655C-2597-7F3B6D3170F8}"/>
+              </a:ext>
+            </a:extLst>
+          </p:cNvPr>
+          <p:cNvSpPr>
+            <a:spLocks noGrp="1"/>
+          </p:cNvSpPr>
+          <p:nvPr>
+            <p:ph type="ftr" sz="quarter" idx="11"/>
+          </p:nvPr>
+        </p:nvSpPr>
+        <p:spPr/>
+        <p:txBody>
+          <a:bodyPr/>
+          <a:lstStyle/>
+          <a:p>
+            <a:endParaRPr lang="en-US"/>
+          </a:p>
+        </p:txBody>
+      </p:sp>
+      <p:sp>
+        <p:nvSpPr>
+          <p:cNvPr id="4" name="Slide Number Placeholder 3">
+            <a:extLst>
+              <a:ext uri="{FF2B5EF4-FFF2-40B4-BE49-F238E27FC236}">
+                <a16:creationId xmlns:a16="http://schemas.microsoft.com/office/drawing/2014/main" id="{5EA13EB0-DD69-7589-AA19-77F3D50D907F}"/>
+              </a:ext>
+            </a:extLst>
+          </p:cNvPr>
+          <p:cNvSpPr>
+            <a:spLocks noGrp="1"/>
+          </p:cNvSpPr>
+          <p:nvPr>
+            <p:ph type="sldNum" sz="quarter" idx="12"/>
+          </p:nvPr>
+        </p:nvSpPr>
+        <p:spPr/>
+        <p:txBody>
+          <a:bodyPr/>
+          <a:lstStyle/>
+          <a:p>
+            <a:fld id="{65D7FD95-7936-6347-9F0B-72114436EA6C}" type="slidenum">
+              <a:rPr lang="en-US" smtClean="0"/>
+              <a:t>‹#›</a:t>
+            </a:fld>
+            <a:endParaRPr lang="en-US"/>
+          </a:p>
+        </p:txBody>
+      </p:sp>
+    </p:spTree>
+    <p:extLst>
+      <p:ext uri="{BB962C8B-B14F-4D97-AF65-F5344CB8AC3E}">
+        <p14:creationId xmlns:p14="http://schemas.microsoft.com/office/powerpoint/2010/main" val="573133202"/>
+      </p:ext>
+    </p:extLst>
+  </p:cSld>
+  <p:clrMapOvr>
+    <a:masterClrMapping/>
+  </p:clrMapOvr>
+</p:sldLayout>
+</file>
+
 <file path=ppt/slideLayouts/slideLayout2.xml><?xml version="1.0" encoding="utf-8"?>
 <p:sldLayout xmlns:a="http://schemas.openxmlformats.org/drawingml/2006/main" xmlns:r="http://schemas.openxmlformats.org/officeDocument/2006/relationships" xmlns:p="http://schemas.openxmlformats.org/presentationml/2006/main" matchingName="Section Header" type="secHead">
   <p:cSld name="SECTION_HEADER">
@@ -11477,7 +11288,7 @@
           <p:nvPr/>
         </p:nvPicPr>
         <p:blipFill rotWithShape="1">
-          <a:blip r:embed="rId11">
+          <a:blip r:embed="rId12">
             <a:alphaModFix/>
           </a:blip>
           <a:srcRect/>
@@ -11512,6 +11323,7 @@
     <p:sldLayoutId id="2147483658" r:id="rId7"/>
     <p:sldLayoutId id="2147483659" r:id="rId8"/>
     <p:sldLayoutId id="2147483673" r:id="rId9"/>
+    <p:sldLayoutId id="2147483674" r:id="rId10"/>
   </p:sldLayoutIdLst>
   <p:hf sldNum="0" hdr="0" ftr="0" dt="0"/>
   <p:txStyles>
@@ -12419,7 +12231,7 @@
             </a:pPr>
             <a:r>
               <a:rPr lang="en-US" dirty="0"/>
-              <a:t>Consortium Success Factors</a:t>
+              <a:t>Consortium Doing What It Takes To Succeed</a:t>
             </a:r>
             <a:endParaRPr dirty="0"/>
           </a:p>
@@ -14803,8 +14615,8 @@
         </p:nvSpPr>
         <p:spPr>
           <a:xfrm>
-            <a:off x="3230880" y="3976910"/>
-            <a:ext cx="5696552" cy="524256"/>
+            <a:off x="3230879" y="3976910"/>
+            <a:ext cx="6402977" cy="524256"/>
           </a:xfrm>
           <a:prstGeom prst="rect">
             <a:avLst/>
@@ -14960,19 +14772,19 @@
           <a:p>
             <a:r>
               <a:rPr lang="en-US" dirty="0"/>
-              <a:t>Intent and Ambition</a:t>
+              <a:t>Realizing Our Long Term Ambition</a:t>
             </a:r>
           </a:p>
           <a:p>
             <a:r>
               <a:rPr lang="en-US" dirty="0"/>
-              <a:t>Consortium Opportunity</a:t>
+              <a:t>Staying Focused On Our Opportunity</a:t>
             </a:r>
           </a:p>
           <a:p>
             <a:r>
               <a:rPr lang="en-US" dirty="0"/>
-              <a:t>Success Factors</a:t>
+              <a:t>Doing What It Takes To Succeed</a:t>
             </a:r>
           </a:p>
           <a:p>
@@ -14987,7 +14799,7 @@
                   <a:schemeClr val="bg1"/>
                 </a:solidFill>
               </a:rPr>
-              <a:t>3-Horizon Roadmap for the 2020s</a:t>
+              <a:t>Executing Our 3-Horizon Strategy</a:t>
             </a:r>
           </a:p>
         </p:txBody>
@@ -16500,6 +16312,1171 @@
 </p:sld>
 </file>
 
+<file path=ppt/slides/slide14.xml><?xml version="1.0" encoding="utf-8"?>
+<p:sld xmlns:a="http://schemas.openxmlformats.org/drawingml/2006/main" xmlns:r="http://schemas.openxmlformats.org/officeDocument/2006/relationships" xmlns:p="http://schemas.openxmlformats.org/presentationml/2006/main">
+  <p:cSld>
+    <p:spTree>
+      <p:nvGrpSpPr>
+        <p:cNvPr id="1" name="">
+          <a:extLst>
+            <a:ext uri="{FF2B5EF4-FFF2-40B4-BE49-F238E27FC236}">
+              <a16:creationId xmlns:a16="http://schemas.microsoft.com/office/drawing/2014/main" id="{1678A191-60DA-7178-4AA9-712BCB1CC370}"/>
+            </a:ext>
+          </a:extLst>
+        </p:cNvPr>
+        <p:cNvGrpSpPr/>
+        <p:nvPr/>
+      </p:nvGrpSpPr>
+      <p:grpSpPr>
+        <a:xfrm>
+          <a:off x="0" y="0"/>
+          <a:ext cx="0" cy="0"/>
+          <a:chOff x="0" y="0"/>
+          <a:chExt cx="0" cy="0"/>
+        </a:xfrm>
+      </p:grpSpPr>
+      <p:sp>
+        <p:nvSpPr>
+          <p:cNvPr id="22" name="Google Shape;96;p2">
+            <a:extLst>
+              <a:ext uri="{FF2B5EF4-FFF2-40B4-BE49-F238E27FC236}">
+                <a16:creationId xmlns:a16="http://schemas.microsoft.com/office/drawing/2014/main" id="{278CDA1C-9746-8737-E977-E13F1843DD8E}"/>
+              </a:ext>
+            </a:extLst>
+          </p:cNvPr>
+          <p:cNvSpPr txBox="1">
+            <a:spLocks/>
+          </p:cNvSpPr>
+          <p:nvPr/>
+        </p:nvSpPr>
+        <p:spPr>
+          <a:xfrm>
+            <a:off x="838199" y="365125"/>
+            <a:ext cx="8950569" cy="1325563"/>
+          </a:xfrm>
+          <a:prstGeom prst="rect">
+            <a:avLst/>
+          </a:prstGeom>
+          <a:noFill/>
+          <a:ln>
+            <a:noFill/>
+          </a:ln>
+        </p:spPr>
+        <p:txBody>
+          <a:bodyPr spcFirstLastPara="1" wrap="square" lIns="91425" tIns="45700" rIns="91425" bIns="45700" anchor="ctr" anchorCtr="0">
+            <a:normAutofit/>
+          </a:bodyPr>
+          <a:lstStyle>
+            <a:defPPr marR="0" lvl="0" algn="l" rtl="0">
+              <a:lnSpc>
+                <a:spcPct val="100000"/>
+              </a:lnSpc>
+              <a:spcBef>
+                <a:spcPts val="0"/>
+              </a:spcBef>
+              <a:spcAft>
+                <a:spcPts val="0"/>
+              </a:spcAft>
+            </a:defPPr>
+            <a:lvl1pPr marR="0" lvl="0" algn="l" rtl="0">
+              <a:lnSpc>
+                <a:spcPct val="100000"/>
+              </a:lnSpc>
+              <a:spcBef>
+                <a:spcPts val="0"/>
+              </a:spcBef>
+              <a:spcAft>
+                <a:spcPts val="0"/>
+              </a:spcAft>
+              <a:buClr>
+                <a:srgbClr val="000000"/>
+              </a:buClr>
+              <a:buFont typeface="Arial"/>
+              <a:defRPr sz="1400" b="0" i="0" u="none" strike="noStrike" cap="none">
+                <a:solidFill>
+                  <a:srgbClr val="000000"/>
+                </a:solidFill>
+                <a:latin typeface="Arial"/>
+                <a:ea typeface="Arial"/>
+                <a:cs typeface="Arial"/>
+                <a:sym typeface="Arial"/>
+              </a:defRPr>
+            </a:lvl1pPr>
+            <a:lvl2pPr marR="0" lvl="1" algn="l" rtl="0">
+              <a:lnSpc>
+                <a:spcPct val="100000"/>
+              </a:lnSpc>
+              <a:spcBef>
+                <a:spcPts val="0"/>
+              </a:spcBef>
+              <a:spcAft>
+                <a:spcPts val="0"/>
+              </a:spcAft>
+              <a:buClr>
+                <a:srgbClr val="000000"/>
+              </a:buClr>
+              <a:buFont typeface="Arial"/>
+              <a:defRPr sz="1400" b="0" i="0" u="none" strike="noStrike" cap="none">
+                <a:solidFill>
+                  <a:srgbClr val="000000"/>
+                </a:solidFill>
+                <a:latin typeface="Arial"/>
+                <a:ea typeface="Arial"/>
+                <a:cs typeface="Arial"/>
+                <a:sym typeface="Arial"/>
+              </a:defRPr>
+            </a:lvl2pPr>
+            <a:lvl3pPr marR="0" lvl="2" algn="l" rtl="0">
+              <a:lnSpc>
+                <a:spcPct val="100000"/>
+              </a:lnSpc>
+              <a:spcBef>
+                <a:spcPts val="0"/>
+              </a:spcBef>
+              <a:spcAft>
+                <a:spcPts val="0"/>
+              </a:spcAft>
+              <a:buClr>
+                <a:srgbClr val="000000"/>
+              </a:buClr>
+              <a:buFont typeface="Arial"/>
+              <a:defRPr sz="1400" b="0" i="0" u="none" strike="noStrike" cap="none">
+                <a:solidFill>
+                  <a:srgbClr val="000000"/>
+                </a:solidFill>
+                <a:latin typeface="Arial"/>
+                <a:ea typeface="Arial"/>
+                <a:cs typeface="Arial"/>
+                <a:sym typeface="Arial"/>
+              </a:defRPr>
+            </a:lvl3pPr>
+            <a:lvl4pPr marR="0" lvl="3" algn="l" rtl="0">
+              <a:lnSpc>
+                <a:spcPct val="100000"/>
+              </a:lnSpc>
+              <a:spcBef>
+                <a:spcPts val="0"/>
+              </a:spcBef>
+              <a:spcAft>
+                <a:spcPts val="0"/>
+              </a:spcAft>
+              <a:buClr>
+                <a:srgbClr val="000000"/>
+              </a:buClr>
+              <a:buFont typeface="Arial"/>
+              <a:defRPr sz="1400" b="0" i="0" u="none" strike="noStrike" cap="none">
+                <a:solidFill>
+                  <a:srgbClr val="000000"/>
+                </a:solidFill>
+                <a:latin typeface="Arial"/>
+                <a:ea typeface="Arial"/>
+                <a:cs typeface="Arial"/>
+                <a:sym typeface="Arial"/>
+              </a:defRPr>
+            </a:lvl4pPr>
+            <a:lvl5pPr marR="0" lvl="4" algn="l" rtl="0">
+              <a:lnSpc>
+                <a:spcPct val="100000"/>
+              </a:lnSpc>
+              <a:spcBef>
+                <a:spcPts val="0"/>
+              </a:spcBef>
+              <a:spcAft>
+                <a:spcPts val="0"/>
+              </a:spcAft>
+              <a:buClr>
+                <a:srgbClr val="000000"/>
+              </a:buClr>
+              <a:buFont typeface="Arial"/>
+              <a:defRPr sz="1400" b="0" i="0" u="none" strike="noStrike" cap="none">
+                <a:solidFill>
+                  <a:srgbClr val="000000"/>
+                </a:solidFill>
+                <a:latin typeface="Arial"/>
+                <a:ea typeface="Arial"/>
+                <a:cs typeface="Arial"/>
+                <a:sym typeface="Arial"/>
+              </a:defRPr>
+            </a:lvl5pPr>
+            <a:lvl6pPr marR="0" lvl="5" algn="l" rtl="0">
+              <a:lnSpc>
+                <a:spcPct val="100000"/>
+              </a:lnSpc>
+              <a:spcBef>
+                <a:spcPts val="0"/>
+              </a:spcBef>
+              <a:spcAft>
+                <a:spcPts val="0"/>
+              </a:spcAft>
+              <a:buClr>
+                <a:srgbClr val="000000"/>
+              </a:buClr>
+              <a:buFont typeface="Arial"/>
+              <a:defRPr sz="1400" b="0" i="0" u="none" strike="noStrike" cap="none">
+                <a:solidFill>
+                  <a:srgbClr val="000000"/>
+                </a:solidFill>
+                <a:latin typeface="Arial"/>
+                <a:ea typeface="Arial"/>
+                <a:cs typeface="Arial"/>
+                <a:sym typeface="Arial"/>
+              </a:defRPr>
+            </a:lvl6pPr>
+            <a:lvl7pPr marR="0" lvl="6" algn="l" rtl="0">
+              <a:lnSpc>
+                <a:spcPct val="100000"/>
+              </a:lnSpc>
+              <a:spcBef>
+                <a:spcPts val="0"/>
+              </a:spcBef>
+              <a:spcAft>
+                <a:spcPts val="0"/>
+              </a:spcAft>
+              <a:buClr>
+                <a:srgbClr val="000000"/>
+              </a:buClr>
+              <a:buFont typeface="Arial"/>
+              <a:defRPr sz="1400" b="0" i="0" u="none" strike="noStrike" cap="none">
+                <a:solidFill>
+                  <a:srgbClr val="000000"/>
+                </a:solidFill>
+                <a:latin typeface="Arial"/>
+                <a:ea typeface="Arial"/>
+                <a:cs typeface="Arial"/>
+                <a:sym typeface="Arial"/>
+              </a:defRPr>
+            </a:lvl7pPr>
+            <a:lvl8pPr marR="0" lvl="7" algn="l" rtl="0">
+              <a:lnSpc>
+                <a:spcPct val="100000"/>
+              </a:lnSpc>
+              <a:spcBef>
+                <a:spcPts val="0"/>
+              </a:spcBef>
+              <a:spcAft>
+                <a:spcPts val="0"/>
+              </a:spcAft>
+              <a:buClr>
+                <a:srgbClr val="000000"/>
+              </a:buClr>
+              <a:buFont typeface="Arial"/>
+              <a:defRPr sz="1400" b="0" i="0" u="none" strike="noStrike" cap="none">
+                <a:solidFill>
+                  <a:srgbClr val="000000"/>
+                </a:solidFill>
+                <a:latin typeface="Arial"/>
+                <a:ea typeface="Arial"/>
+                <a:cs typeface="Arial"/>
+                <a:sym typeface="Arial"/>
+              </a:defRPr>
+            </a:lvl8pPr>
+            <a:lvl9pPr marR="0" lvl="8" algn="l" rtl="0">
+              <a:lnSpc>
+                <a:spcPct val="100000"/>
+              </a:lnSpc>
+              <a:spcBef>
+                <a:spcPts val="0"/>
+              </a:spcBef>
+              <a:spcAft>
+                <a:spcPts val="0"/>
+              </a:spcAft>
+              <a:buClr>
+                <a:srgbClr val="000000"/>
+              </a:buClr>
+              <a:buFont typeface="Arial"/>
+              <a:defRPr sz="1400" b="0" i="0" u="none" strike="noStrike" cap="none">
+                <a:solidFill>
+                  <a:srgbClr val="000000"/>
+                </a:solidFill>
+                <a:latin typeface="Arial"/>
+                <a:ea typeface="Arial"/>
+                <a:cs typeface="Arial"/>
+                <a:sym typeface="Arial"/>
+              </a:defRPr>
+            </a:lvl9pPr>
+          </a:lstStyle>
+          <a:p>
+            <a:pPr>
+              <a:lnSpc>
+                <a:spcPct val="90000"/>
+              </a:lnSpc>
+              <a:buClr>
+                <a:schemeClr val="dk1"/>
+              </a:buClr>
+              <a:buSzPts val="4400"/>
+              <a:buFont typeface="Calibri"/>
+              <a:buNone/>
+            </a:pPr>
+            <a:r>
+              <a:rPr lang="en-US" sz="4400" dirty="0">
+                <a:latin typeface="Calibri" panose="020F0502020204030204" pitchFamily="34" charset="0"/>
+                <a:cs typeface="Calibri" panose="020F0502020204030204" pitchFamily="34" charset="0"/>
+              </a:rPr>
+              <a:t>Consortium Priorities</a:t>
+            </a:r>
+          </a:p>
+          <a:p>
+            <a:pPr>
+              <a:lnSpc>
+                <a:spcPct val="90000"/>
+              </a:lnSpc>
+              <a:buClr>
+                <a:schemeClr val="dk1"/>
+              </a:buClr>
+              <a:buSzPts val="4400"/>
+              <a:buFont typeface="Calibri"/>
+              <a:buNone/>
+            </a:pPr>
+            <a:r>
+              <a:rPr lang="en-US" sz="2400" i="1" dirty="0">
+                <a:latin typeface="Calibri" panose="020F0502020204030204" pitchFamily="34" charset="0"/>
+                <a:cs typeface="Calibri" panose="020F0502020204030204" pitchFamily="34" charset="0"/>
+              </a:rPr>
+              <a:t>Using our own Framework to grow Consortium value exponentially</a:t>
+            </a:r>
+          </a:p>
+        </p:txBody>
+      </p:sp>
+      <p:pic>
+        <p:nvPicPr>
+          <p:cNvPr id="6" name="Picture 5">
+            <a:extLst>
+              <a:ext uri="{FF2B5EF4-FFF2-40B4-BE49-F238E27FC236}">
+                <a16:creationId xmlns:a16="http://schemas.microsoft.com/office/drawing/2014/main" id="{12251142-AFE9-20A0-A16F-3C7CBAEA2B87}"/>
+              </a:ext>
+            </a:extLst>
+          </p:cNvPr>
+          <p:cNvPicPr>
+            <a:picLocks noChangeAspect="1"/>
+          </p:cNvPicPr>
+          <p:nvPr/>
+        </p:nvPicPr>
+        <p:blipFill>
+          <a:blip r:embed="rId3"/>
+          <a:stretch>
+            <a:fillRect/>
+          </a:stretch>
+        </p:blipFill>
+        <p:spPr>
+          <a:xfrm>
+            <a:off x="1435607" y="2726901"/>
+            <a:ext cx="4757057" cy="2565080"/>
+          </a:xfrm>
+          <a:prstGeom prst="rect">
+            <a:avLst/>
+          </a:prstGeom>
+        </p:spPr>
+      </p:pic>
+      <p:graphicFrame>
+        <p:nvGraphicFramePr>
+          <p:cNvPr id="15" name="Table 14">
+            <a:extLst>
+              <a:ext uri="{FF2B5EF4-FFF2-40B4-BE49-F238E27FC236}">
+                <a16:creationId xmlns:a16="http://schemas.microsoft.com/office/drawing/2014/main" id="{D6474217-ABEC-A6EA-9151-B71EFE80D53F}"/>
+              </a:ext>
+            </a:extLst>
+          </p:cNvPr>
+          <p:cNvGraphicFramePr>
+            <a:graphicFrameLocks noGrp="1"/>
+          </p:cNvGraphicFramePr>
+          <p:nvPr/>
+        </p:nvGraphicFramePr>
+        <p:xfrm>
+          <a:off x="6901107" y="2423595"/>
+          <a:ext cx="3855286" cy="3527862"/>
+        </p:xfrm>
+        <a:graphic>
+          <a:graphicData uri="http://schemas.openxmlformats.org/drawingml/2006/table">
+            <a:tbl>
+              <a:tblPr firstRow="1" bandRow="1">
+                <a:tableStyleId>{5940675A-B579-460E-94D1-54222C63F5DA}</a:tableStyleId>
+              </a:tblPr>
+              <a:tblGrid>
+                <a:gridCol w="3855286">
+                  <a:extLst>
+                    <a:ext uri="{9D8B030D-6E8A-4147-A177-3AD203B41FA5}">
+                      <a16:colId xmlns:a16="http://schemas.microsoft.com/office/drawing/2014/main" val="20127695"/>
+                    </a:ext>
+                  </a:extLst>
+                </a:gridCol>
+              </a:tblGrid>
+              <a:tr h="748583">
+                <a:tc>
+                  <a:txBody>
+                    <a:bodyPr/>
+                    <a:lstStyle/>
+                    <a:p>
+                      <a:pPr marL="285750" marR="0" lvl="0" indent="-285750" algn="l" defTabSz="914400" rtl="0" eaLnBrk="1" fontAlgn="auto" latinLnBrk="0" hangingPunct="1">
+                        <a:lnSpc>
+                          <a:spcPct val="100000"/>
+                        </a:lnSpc>
+                        <a:spcBef>
+                          <a:spcPts val="0"/>
+                        </a:spcBef>
+                        <a:spcAft>
+                          <a:spcPts val="0"/>
+                        </a:spcAft>
+                        <a:buClr>
+                          <a:srgbClr val="000000"/>
+                        </a:buClr>
+                        <a:buSzTx/>
+                        <a:buFont typeface="Wingdings" pitchFamily="2" charset="2"/>
+                        <a:buChar char="q"/>
+                        <a:tabLst/>
+                        <a:defRPr/>
+                      </a:pPr>
+                      <a:r>
+                        <a:rPr kumimoji="0" lang="en-US" sz="1400" i="0" u="none" strike="noStrike" kern="1200" cap="none" spc="0" normalizeH="0" baseline="0" noProof="0" dirty="0">
+                          <a:ln>
+                            <a:noFill/>
+                          </a:ln>
+                          <a:solidFill>
+                            <a:schemeClr val="tx1"/>
+                          </a:solidFill>
+                          <a:effectLst/>
+                          <a:uLnTx/>
+                          <a:uFillTx/>
+                          <a:latin typeface="Aptos" panose="02110004020202020204"/>
+                          <a:ea typeface="+mn-ea"/>
+                          <a:cs typeface="Arial"/>
+                          <a:sym typeface="Arial"/>
+                        </a:rPr>
+                        <a:t>To improve our services and be credible, we should use Lean Product Management</a:t>
+                      </a:r>
+                    </a:p>
+                  </a:txBody>
+                  <a:tcPr anchor="ctr">
+                    <a:lnL w="12700" cap="flat" cmpd="sng" algn="ctr">
+                      <a:noFill/>
+                      <a:prstDash val="solid"/>
+                      <a:round/>
+                      <a:headEnd type="none" w="med" len="med"/>
+                      <a:tailEnd type="none" w="med" len="med"/>
+                    </a:lnL>
+                    <a:lnR w="12700" cmpd="sng">
+                      <a:noFill/>
+                    </a:lnR>
+                    <a:lnT w="12700" cap="flat" cmpd="sng" algn="ctr">
+                      <a:solidFill>
+                        <a:schemeClr val="tx1"/>
+                      </a:solidFill>
+                      <a:prstDash val="solid"/>
+                      <a:round/>
+                      <a:headEnd type="none" w="med" len="med"/>
+                      <a:tailEnd type="none" w="med" len="med"/>
+                    </a:lnT>
+                    <a:lnB w="12700" cap="flat" cmpd="sng" algn="ctr">
+                      <a:solidFill>
+                        <a:schemeClr val="tx1"/>
+                      </a:solidFill>
+                      <a:prstDash val="solid"/>
+                      <a:round/>
+                      <a:headEnd type="none" w="med" len="med"/>
+                      <a:tailEnd type="none" w="med" len="med"/>
+                    </a:lnB>
+                    <a:lnTlToBr w="12700" cmpd="sng">
+                      <a:noFill/>
+                      <a:prstDash val="solid"/>
+                    </a:lnTlToBr>
+                    <a:lnBlToTr w="12700" cmpd="sng">
+                      <a:noFill/>
+                      <a:prstDash val="solid"/>
+                    </a:lnBlToTr>
+                  </a:tcPr>
+                </a:tc>
+                <a:extLst>
+                  <a:ext uri="{0D108BD9-81ED-4DB2-BD59-A6C34878D82A}">
+                    <a16:rowId xmlns:a16="http://schemas.microsoft.com/office/drawing/2014/main" val="872717509"/>
+                  </a:ext>
+                </a:extLst>
+              </a:tr>
+              <a:tr h="728133">
+                <a:tc>
+                  <a:txBody>
+                    <a:bodyPr/>
+                    <a:lstStyle/>
+                    <a:p>
+                      <a:pPr marL="285750" marR="0" lvl="0" indent="-285750" algn="l" defTabSz="914400" rtl="0" eaLnBrk="1" fontAlgn="auto" latinLnBrk="0" hangingPunct="1">
+                        <a:lnSpc>
+                          <a:spcPct val="100000"/>
+                        </a:lnSpc>
+                        <a:spcBef>
+                          <a:spcPts val="0"/>
+                        </a:spcBef>
+                        <a:spcAft>
+                          <a:spcPts val="0"/>
+                        </a:spcAft>
+                        <a:buClr>
+                          <a:srgbClr val="000000"/>
+                        </a:buClr>
+                        <a:buSzTx/>
+                        <a:buFont typeface="Wingdings" pitchFamily="2" charset="2"/>
+                        <a:buChar char="q"/>
+                        <a:tabLst/>
+                        <a:defRPr/>
+                      </a:pPr>
+                      <a:r>
+                        <a:rPr kumimoji="0" lang="en-US" sz="1400" i="0" u="none" strike="noStrike" kern="1200" cap="none" spc="0" normalizeH="0" baseline="0" noProof="0" dirty="0">
+                          <a:ln>
+                            <a:noFill/>
+                          </a:ln>
+                          <a:solidFill>
+                            <a:schemeClr val="tx1"/>
+                          </a:solidFill>
+                          <a:effectLst/>
+                          <a:uLnTx/>
+                          <a:uFillTx/>
+                          <a:latin typeface="Aptos" panose="02110004020202020204"/>
+                          <a:ea typeface="+mn-ea"/>
+                          <a:cs typeface="Arial"/>
+                          <a:sym typeface="Arial"/>
+                        </a:rPr>
+                        <a:t>To connect our network and be credible, we should use the right Collaboration Platforms</a:t>
+                      </a:r>
+                    </a:p>
+                  </a:txBody>
+                  <a:tcPr anchor="ctr">
+                    <a:lnL w="12700" cap="flat" cmpd="sng" algn="ctr">
+                      <a:noFill/>
+                      <a:prstDash val="solid"/>
+                      <a:round/>
+                      <a:headEnd type="none" w="med" len="med"/>
+                      <a:tailEnd type="none" w="med" len="med"/>
+                    </a:lnL>
+                    <a:lnR w="12700" cmpd="sng">
+                      <a:noFill/>
+                    </a:lnR>
+                    <a:lnT w="12700" cap="flat" cmpd="sng" algn="ctr">
+                      <a:solidFill>
+                        <a:schemeClr val="tx1"/>
+                      </a:solidFill>
+                      <a:prstDash val="solid"/>
+                      <a:round/>
+                      <a:headEnd type="none" w="med" len="med"/>
+                      <a:tailEnd type="none" w="med" len="med"/>
+                    </a:lnT>
+                    <a:lnB w="12700" cap="flat" cmpd="sng" algn="ctr">
+                      <a:solidFill>
+                        <a:schemeClr val="tx1"/>
+                      </a:solidFill>
+                      <a:prstDash val="solid"/>
+                      <a:round/>
+                      <a:headEnd type="none" w="med" len="med"/>
+                      <a:tailEnd type="none" w="med" len="med"/>
+                    </a:lnB>
+                    <a:lnTlToBr w="12700" cmpd="sng">
+                      <a:noFill/>
+                      <a:prstDash val="solid"/>
+                    </a:lnTlToBr>
+                    <a:lnBlToTr w="12700" cmpd="sng">
+                      <a:noFill/>
+                      <a:prstDash val="solid"/>
+                    </a:lnBlToTr>
+                  </a:tcPr>
+                </a:tc>
+                <a:extLst>
+                  <a:ext uri="{0D108BD9-81ED-4DB2-BD59-A6C34878D82A}">
+                    <a16:rowId xmlns:a16="http://schemas.microsoft.com/office/drawing/2014/main" val="3089640372"/>
+                  </a:ext>
+                </a:extLst>
+              </a:tr>
+              <a:tr h="704954">
+                <a:tc>
+                  <a:txBody>
+                    <a:bodyPr/>
+                    <a:lstStyle/>
+                    <a:p>
+                      <a:pPr marL="285750" indent="-285750">
+                        <a:buFont typeface="Wingdings" pitchFamily="2" charset="2"/>
+                        <a:buChar char="q"/>
+                        <a:tabLst/>
+                      </a:pPr>
+                      <a:r>
+                        <a:rPr kumimoji="0" lang="en-US" sz="1400" i="0" u="none" strike="noStrike" kern="1200" cap="none" spc="0" normalizeH="0" baseline="0" noProof="0" dirty="0">
+                          <a:ln>
+                            <a:noFill/>
+                          </a:ln>
+                          <a:solidFill>
+                            <a:schemeClr val="tx1"/>
+                          </a:solidFill>
+                          <a:effectLst/>
+                          <a:uLnTx/>
+                          <a:uFillTx/>
+                          <a:latin typeface="Aptos" panose="02110004020202020204"/>
+                          <a:ea typeface="+mn-ea"/>
+                          <a:cs typeface="Arial"/>
+                          <a:sym typeface="Arial"/>
+                        </a:rPr>
+                        <a:t>To go viral, we must win advocacy from credible industry influencers</a:t>
+                      </a:r>
+                      <a:endParaRPr lang="en-US" dirty="0">
+                        <a:solidFill>
+                          <a:schemeClr val="tx1"/>
+                        </a:solidFill>
+                      </a:endParaRPr>
+                    </a:p>
+                  </a:txBody>
+                  <a:tcPr anchor="ctr">
+                    <a:lnL w="12700" cap="flat" cmpd="sng" algn="ctr">
+                      <a:noFill/>
+                      <a:prstDash val="solid"/>
+                      <a:round/>
+                      <a:headEnd type="none" w="med" len="med"/>
+                      <a:tailEnd type="none" w="med" len="med"/>
+                    </a:lnL>
+                    <a:lnR w="12700" cmpd="sng">
+                      <a:noFill/>
+                    </a:lnR>
+                    <a:lnT w="12700" cap="flat" cmpd="sng" algn="ctr">
+                      <a:solidFill>
+                        <a:schemeClr val="tx1"/>
+                      </a:solidFill>
+                      <a:prstDash val="solid"/>
+                      <a:round/>
+                      <a:headEnd type="none" w="med" len="med"/>
+                      <a:tailEnd type="none" w="med" len="med"/>
+                    </a:lnT>
+                    <a:lnB w="12700" cap="flat" cmpd="sng" algn="ctr">
+                      <a:solidFill>
+                        <a:schemeClr val="tx1"/>
+                      </a:solidFill>
+                      <a:prstDash val="solid"/>
+                      <a:round/>
+                      <a:headEnd type="none" w="med" len="med"/>
+                      <a:tailEnd type="none" w="med" len="med"/>
+                    </a:lnB>
+                    <a:lnTlToBr w="12700" cmpd="sng">
+                      <a:noFill/>
+                      <a:prstDash val="solid"/>
+                    </a:lnTlToBr>
+                    <a:lnBlToTr w="12700" cmpd="sng">
+                      <a:noFill/>
+                      <a:prstDash val="solid"/>
+                    </a:lnBlToTr>
+                  </a:tcPr>
+                </a:tc>
+                <a:extLst>
+                  <a:ext uri="{0D108BD9-81ED-4DB2-BD59-A6C34878D82A}">
+                    <a16:rowId xmlns:a16="http://schemas.microsoft.com/office/drawing/2014/main" val="2047728929"/>
+                  </a:ext>
+                </a:extLst>
+              </a:tr>
+              <a:tr h="683579">
+                <a:tc>
+                  <a:txBody>
+                    <a:bodyPr/>
+                    <a:lstStyle/>
+                    <a:p>
+                      <a:pPr marL="285750" indent="-285750">
+                        <a:buFont typeface="Wingdings" pitchFamily="2" charset="2"/>
+                        <a:buChar char="q"/>
+                        <a:tabLst/>
+                      </a:pPr>
+                      <a:r>
+                        <a:rPr kumimoji="0" lang="en-US" sz="1400" i="0" u="none" strike="noStrike" kern="1200" cap="none" spc="0" normalizeH="0" baseline="0" noProof="0" dirty="0">
+                          <a:ln>
+                            <a:noFill/>
+                          </a:ln>
+                          <a:solidFill>
+                            <a:schemeClr val="tx1"/>
+                          </a:solidFill>
+                          <a:effectLst/>
+                          <a:uLnTx/>
+                          <a:uFillTx/>
+                          <a:latin typeface="Aptos" panose="02110004020202020204"/>
+                          <a:ea typeface="+mn-ea"/>
+                          <a:cs typeface="Arial"/>
+                          <a:sym typeface="Arial"/>
+                        </a:rPr>
+                        <a:t>To scale quickly, we should learn from leaders experienced in similar non-profits</a:t>
+                      </a:r>
+                      <a:endParaRPr lang="en-US" dirty="0">
+                        <a:solidFill>
+                          <a:schemeClr val="tx1"/>
+                        </a:solidFill>
+                      </a:endParaRPr>
+                    </a:p>
+                  </a:txBody>
+                  <a:tcPr anchor="ctr">
+                    <a:lnL w="12700" cap="flat" cmpd="sng" algn="ctr">
+                      <a:noFill/>
+                      <a:prstDash val="solid"/>
+                      <a:round/>
+                      <a:headEnd type="none" w="med" len="med"/>
+                      <a:tailEnd type="none" w="med" len="med"/>
+                    </a:lnL>
+                    <a:lnR w="12700" cmpd="sng">
+                      <a:noFill/>
+                    </a:lnR>
+                    <a:lnT w="12700" cap="flat" cmpd="sng" algn="ctr">
+                      <a:solidFill>
+                        <a:schemeClr val="tx1"/>
+                      </a:solidFill>
+                      <a:prstDash val="solid"/>
+                      <a:round/>
+                      <a:headEnd type="none" w="med" len="med"/>
+                      <a:tailEnd type="none" w="med" len="med"/>
+                    </a:lnT>
+                    <a:lnB w="12700" cap="flat" cmpd="sng" algn="ctr">
+                      <a:solidFill>
+                        <a:schemeClr val="tx1"/>
+                      </a:solidFill>
+                      <a:prstDash val="solid"/>
+                      <a:round/>
+                      <a:headEnd type="none" w="med" len="med"/>
+                      <a:tailEnd type="none" w="med" len="med"/>
+                    </a:lnB>
+                    <a:lnTlToBr w="12700" cmpd="sng">
+                      <a:noFill/>
+                      <a:prstDash val="solid"/>
+                    </a:lnTlToBr>
+                    <a:lnBlToTr w="12700" cmpd="sng">
+                      <a:noFill/>
+                      <a:prstDash val="solid"/>
+                    </a:lnBlToTr>
+                  </a:tcPr>
+                </a:tc>
+                <a:extLst>
+                  <a:ext uri="{0D108BD9-81ED-4DB2-BD59-A6C34878D82A}">
+                    <a16:rowId xmlns:a16="http://schemas.microsoft.com/office/drawing/2014/main" val="2321847728"/>
+                  </a:ext>
+                </a:extLst>
+              </a:tr>
+              <a:tr h="662613">
+                <a:tc>
+                  <a:txBody>
+                    <a:bodyPr/>
+                    <a:lstStyle/>
+                    <a:p>
+                      <a:pPr marL="285750" indent="-285750">
+                        <a:buFont typeface="Wingdings" pitchFamily="2" charset="2"/>
+                        <a:buChar char="q"/>
+                        <a:tabLst/>
+                      </a:pPr>
+                      <a:r>
+                        <a:rPr lang="en-US" sz="1400" kern="1200" dirty="0">
+                          <a:solidFill>
+                            <a:schemeClr val="tx1"/>
+                          </a:solidFill>
+                          <a:latin typeface="Aptos" panose="02110004020202020204"/>
+                          <a:ea typeface="+mn-ea"/>
+                        </a:rPr>
+                        <a:t>To help us scale and be credible, we must experiment with and practice using AI</a:t>
+                      </a:r>
+                      <a:endParaRPr lang="en-US" dirty="0">
+                        <a:solidFill>
+                          <a:schemeClr val="tx1"/>
+                        </a:solidFill>
+                      </a:endParaRPr>
+                    </a:p>
+                  </a:txBody>
+                  <a:tcPr anchor="ctr">
+                    <a:lnL w="12700" cap="flat" cmpd="sng" algn="ctr">
+                      <a:noFill/>
+                      <a:prstDash val="solid"/>
+                      <a:round/>
+                      <a:headEnd type="none" w="med" len="med"/>
+                      <a:tailEnd type="none" w="med" len="med"/>
+                    </a:lnL>
+                    <a:lnR w="12700" cmpd="sng">
+                      <a:noFill/>
+                    </a:lnR>
+                    <a:lnT w="12700" cap="flat" cmpd="sng" algn="ctr">
+                      <a:solidFill>
+                        <a:schemeClr val="tx1"/>
+                      </a:solidFill>
+                      <a:prstDash val="solid"/>
+                      <a:round/>
+                      <a:headEnd type="none" w="med" len="med"/>
+                      <a:tailEnd type="none" w="med" len="med"/>
+                    </a:lnT>
+                    <a:lnB w="12700" cap="flat" cmpd="sng" algn="ctr">
+                      <a:solidFill>
+                        <a:schemeClr val="tx1"/>
+                      </a:solidFill>
+                      <a:prstDash val="solid"/>
+                      <a:round/>
+                      <a:headEnd type="none" w="med" len="med"/>
+                      <a:tailEnd type="none" w="med" len="med"/>
+                    </a:lnB>
+                    <a:lnTlToBr w="12700" cmpd="sng">
+                      <a:noFill/>
+                      <a:prstDash val="solid"/>
+                    </a:lnTlToBr>
+                    <a:lnBlToTr w="12700" cmpd="sng">
+                      <a:noFill/>
+                      <a:prstDash val="solid"/>
+                    </a:lnBlToTr>
+                  </a:tcPr>
+                </a:tc>
+                <a:extLst>
+                  <a:ext uri="{0D108BD9-81ED-4DB2-BD59-A6C34878D82A}">
+                    <a16:rowId xmlns:a16="http://schemas.microsoft.com/office/drawing/2014/main" val="1735022269"/>
+                  </a:ext>
+                </a:extLst>
+              </a:tr>
+            </a:tbl>
+          </a:graphicData>
+        </a:graphic>
+      </p:graphicFrame>
+      <p:sp>
+        <p:nvSpPr>
+          <p:cNvPr id="27" name="TextBox 26">
+            <a:extLst>
+              <a:ext uri="{FF2B5EF4-FFF2-40B4-BE49-F238E27FC236}">
+                <a16:creationId xmlns:a16="http://schemas.microsoft.com/office/drawing/2014/main" id="{47F7FEC5-E4F2-4640-BABB-2DC3CF664665}"/>
+              </a:ext>
+            </a:extLst>
+          </p:cNvPr>
+          <p:cNvSpPr txBox="1"/>
+          <p:nvPr/>
+        </p:nvSpPr>
+        <p:spPr>
+          <a:xfrm>
+            <a:off x="7195646" y="1843223"/>
+            <a:ext cx="3190530" cy="523220"/>
+          </a:xfrm>
+          <a:prstGeom prst="rect">
+            <a:avLst/>
+          </a:prstGeom>
+          <a:noFill/>
+        </p:spPr>
+        <p:txBody>
+          <a:bodyPr wrap="square">
+            <a:spAutoFit/>
+          </a:bodyPr>
+          <a:lstStyle/>
+          <a:p>
+            <a:r>
+              <a:rPr kumimoji="0" lang="en-US" sz="1400" b="1" i="0" u="none" strike="noStrike" kern="1200" cap="none" spc="0" normalizeH="0" baseline="0" noProof="0" dirty="0">
+                <a:ln>
+                  <a:noFill/>
+                </a:ln>
+                <a:solidFill>
+                  <a:schemeClr val="tx1"/>
+                </a:solidFill>
+                <a:effectLst/>
+                <a:uLnTx/>
+                <a:uFillTx/>
+                <a:latin typeface="Aptos" panose="02110004020202020204"/>
+                <a:ea typeface="+mn-ea"/>
+                <a:cs typeface="Arial"/>
+                <a:sym typeface="Arial"/>
+              </a:rPr>
+              <a:t>What we need to do now to grow </a:t>
+            </a:r>
+            <a:br>
+              <a:rPr kumimoji="0" lang="en-US" sz="1400" b="1" i="0" u="none" strike="noStrike" kern="1200" cap="none" spc="0" normalizeH="0" baseline="0" noProof="0" dirty="0">
+                <a:ln>
+                  <a:noFill/>
+                </a:ln>
+                <a:solidFill>
+                  <a:schemeClr val="tx1"/>
+                </a:solidFill>
+                <a:effectLst/>
+                <a:uLnTx/>
+                <a:uFillTx/>
+                <a:latin typeface="Aptos" panose="02110004020202020204"/>
+                <a:ea typeface="+mn-ea"/>
+                <a:cs typeface="Arial"/>
+                <a:sym typeface="Arial"/>
+              </a:rPr>
+            </a:br>
+            <a:r>
+              <a:rPr kumimoji="0" lang="en-US" sz="1400" b="1" i="0" u="none" strike="noStrike" kern="1200" cap="none" spc="0" normalizeH="0" baseline="0" noProof="0" dirty="0">
+                <a:ln>
+                  <a:noFill/>
+                </a:ln>
+                <a:solidFill>
+                  <a:schemeClr val="tx1"/>
+                </a:solidFill>
+                <a:effectLst/>
+                <a:uLnTx/>
+                <a:uFillTx/>
+                <a:latin typeface="Aptos" panose="02110004020202020204"/>
+                <a:ea typeface="+mn-ea"/>
+                <a:cs typeface="Arial"/>
+                <a:sym typeface="Arial"/>
+              </a:rPr>
+              <a:t>Consortium value exponentially</a:t>
+            </a:r>
+            <a:endParaRPr lang="en-US" dirty="0">
+              <a:solidFill>
+                <a:schemeClr val="tx1"/>
+              </a:solidFill>
+            </a:endParaRPr>
+          </a:p>
+        </p:txBody>
+      </p:sp>
+      <p:cxnSp>
+        <p:nvCxnSpPr>
+          <p:cNvPr id="33" name="Straight Connector 32">
+            <a:extLst>
+              <a:ext uri="{FF2B5EF4-FFF2-40B4-BE49-F238E27FC236}">
+                <a16:creationId xmlns:a16="http://schemas.microsoft.com/office/drawing/2014/main" id="{A10F0D5E-B3A7-C15F-E7E4-FB9BC83DE9A2}"/>
+              </a:ext>
+            </a:extLst>
+          </p:cNvPr>
+          <p:cNvCxnSpPr/>
+          <p:nvPr/>
+        </p:nvCxnSpPr>
+        <p:spPr>
+          <a:xfrm flipV="1">
+            <a:off x="6096000" y="2423595"/>
+            <a:ext cx="805107" cy="746325"/>
+          </a:xfrm>
+          <a:prstGeom prst="line">
+            <a:avLst/>
+          </a:prstGeom>
+          <a:ln w="12700">
+            <a:solidFill>
+              <a:schemeClr val="tx1"/>
+            </a:solidFill>
+          </a:ln>
+        </p:spPr>
+        <p:style>
+          <a:lnRef idx="1">
+            <a:schemeClr val="accent1"/>
+          </a:lnRef>
+          <a:fillRef idx="0">
+            <a:schemeClr val="accent1"/>
+          </a:fillRef>
+          <a:effectRef idx="0">
+            <a:schemeClr val="accent1"/>
+          </a:effectRef>
+          <a:fontRef idx="minor">
+            <a:schemeClr val="tx1"/>
+          </a:fontRef>
+        </p:style>
+      </p:cxnSp>
+      <p:cxnSp>
+        <p:nvCxnSpPr>
+          <p:cNvPr id="34" name="Straight Connector 33">
+            <a:extLst>
+              <a:ext uri="{FF2B5EF4-FFF2-40B4-BE49-F238E27FC236}">
+                <a16:creationId xmlns:a16="http://schemas.microsoft.com/office/drawing/2014/main" id="{BD61CF38-CCAA-9867-0AC2-DE2EF1BC6EC9}"/>
+              </a:ext>
+            </a:extLst>
+          </p:cNvPr>
+          <p:cNvCxnSpPr>
+            <a:cxnSpLocks/>
+          </p:cNvCxnSpPr>
+          <p:nvPr/>
+        </p:nvCxnSpPr>
+        <p:spPr>
+          <a:xfrm flipV="1">
+            <a:off x="6096000" y="3169920"/>
+            <a:ext cx="805107" cy="377952"/>
+          </a:xfrm>
+          <a:prstGeom prst="line">
+            <a:avLst/>
+          </a:prstGeom>
+          <a:ln w="12700">
+            <a:solidFill>
+              <a:schemeClr val="tx1"/>
+            </a:solidFill>
+          </a:ln>
+        </p:spPr>
+        <p:style>
+          <a:lnRef idx="1">
+            <a:schemeClr val="accent1"/>
+          </a:lnRef>
+          <a:fillRef idx="0">
+            <a:schemeClr val="accent1"/>
+          </a:fillRef>
+          <a:effectRef idx="0">
+            <a:schemeClr val="accent1"/>
+          </a:effectRef>
+          <a:fontRef idx="minor">
+            <a:schemeClr val="tx1"/>
+          </a:fontRef>
+        </p:style>
+      </p:cxnSp>
+      <p:cxnSp>
+        <p:nvCxnSpPr>
+          <p:cNvPr id="38" name="Straight Connector 37">
+            <a:extLst>
+              <a:ext uri="{FF2B5EF4-FFF2-40B4-BE49-F238E27FC236}">
+                <a16:creationId xmlns:a16="http://schemas.microsoft.com/office/drawing/2014/main" id="{D6F35091-77BE-6B3B-00CA-FB1DD33B1F6A}"/>
+              </a:ext>
+            </a:extLst>
+          </p:cNvPr>
+          <p:cNvCxnSpPr>
+            <a:cxnSpLocks/>
+          </p:cNvCxnSpPr>
+          <p:nvPr/>
+        </p:nvCxnSpPr>
+        <p:spPr>
+          <a:xfrm>
+            <a:off x="6096000" y="3897827"/>
+            <a:ext cx="805107" cy="0"/>
+          </a:xfrm>
+          <a:prstGeom prst="line">
+            <a:avLst/>
+          </a:prstGeom>
+          <a:ln w="12700">
+            <a:solidFill>
+              <a:schemeClr val="tx1"/>
+            </a:solidFill>
+          </a:ln>
+        </p:spPr>
+        <p:style>
+          <a:lnRef idx="1">
+            <a:schemeClr val="accent1"/>
+          </a:lnRef>
+          <a:fillRef idx="0">
+            <a:schemeClr val="accent1"/>
+          </a:fillRef>
+          <a:effectRef idx="0">
+            <a:schemeClr val="accent1"/>
+          </a:effectRef>
+          <a:fontRef idx="minor">
+            <a:schemeClr val="tx1"/>
+          </a:fontRef>
+        </p:style>
+      </p:cxnSp>
+      <p:cxnSp>
+        <p:nvCxnSpPr>
+          <p:cNvPr id="41" name="Straight Connector 40">
+            <a:extLst>
+              <a:ext uri="{FF2B5EF4-FFF2-40B4-BE49-F238E27FC236}">
+                <a16:creationId xmlns:a16="http://schemas.microsoft.com/office/drawing/2014/main" id="{9629667B-249A-E98D-36A0-56DA92AFC590}"/>
+              </a:ext>
+            </a:extLst>
+          </p:cNvPr>
+          <p:cNvCxnSpPr>
+            <a:cxnSpLocks/>
+          </p:cNvCxnSpPr>
+          <p:nvPr/>
+        </p:nvCxnSpPr>
+        <p:spPr>
+          <a:xfrm>
+            <a:off x="6096000" y="4259072"/>
+            <a:ext cx="805107" cy="346795"/>
+          </a:xfrm>
+          <a:prstGeom prst="line">
+            <a:avLst/>
+          </a:prstGeom>
+          <a:ln w="12700">
+            <a:solidFill>
+              <a:schemeClr val="tx1"/>
+            </a:solidFill>
+          </a:ln>
+        </p:spPr>
+        <p:style>
+          <a:lnRef idx="1">
+            <a:schemeClr val="accent1"/>
+          </a:lnRef>
+          <a:fillRef idx="0">
+            <a:schemeClr val="accent1"/>
+          </a:fillRef>
+          <a:effectRef idx="0">
+            <a:schemeClr val="accent1"/>
+          </a:effectRef>
+          <a:fontRef idx="minor">
+            <a:schemeClr val="tx1"/>
+          </a:fontRef>
+        </p:style>
+      </p:cxnSp>
+      <p:cxnSp>
+        <p:nvCxnSpPr>
+          <p:cNvPr id="43" name="Straight Connector 42">
+            <a:extLst>
+              <a:ext uri="{FF2B5EF4-FFF2-40B4-BE49-F238E27FC236}">
+                <a16:creationId xmlns:a16="http://schemas.microsoft.com/office/drawing/2014/main" id="{1F55AE74-C89D-D93F-9786-D18B80792D69}"/>
+              </a:ext>
+            </a:extLst>
+          </p:cNvPr>
+          <p:cNvCxnSpPr>
+            <a:cxnSpLocks/>
+          </p:cNvCxnSpPr>
+          <p:nvPr/>
+        </p:nvCxnSpPr>
+        <p:spPr>
+          <a:xfrm>
+            <a:off x="6096000" y="4603383"/>
+            <a:ext cx="805107" cy="686102"/>
+          </a:xfrm>
+          <a:prstGeom prst="line">
+            <a:avLst/>
+          </a:prstGeom>
+          <a:ln w="12700">
+            <a:solidFill>
+              <a:schemeClr val="tx1"/>
+            </a:solidFill>
+          </a:ln>
+        </p:spPr>
+        <p:style>
+          <a:lnRef idx="1">
+            <a:schemeClr val="accent1"/>
+          </a:lnRef>
+          <a:fillRef idx="0">
+            <a:schemeClr val="accent1"/>
+          </a:fillRef>
+          <a:effectRef idx="0">
+            <a:schemeClr val="accent1"/>
+          </a:effectRef>
+          <a:fontRef idx="minor">
+            <a:schemeClr val="tx1"/>
+          </a:fontRef>
+        </p:style>
+      </p:cxnSp>
+      <p:cxnSp>
+        <p:nvCxnSpPr>
+          <p:cNvPr id="45" name="Straight Connector 44">
+            <a:extLst>
+              <a:ext uri="{FF2B5EF4-FFF2-40B4-BE49-F238E27FC236}">
+                <a16:creationId xmlns:a16="http://schemas.microsoft.com/office/drawing/2014/main" id="{85717EBB-9B32-6ADB-6B3E-3C8E82766FFA}"/>
+              </a:ext>
+            </a:extLst>
+          </p:cNvPr>
+          <p:cNvCxnSpPr>
+            <a:cxnSpLocks/>
+          </p:cNvCxnSpPr>
+          <p:nvPr/>
+        </p:nvCxnSpPr>
+        <p:spPr>
+          <a:xfrm>
+            <a:off x="6096000" y="4970272"/>
+            <a:ext cx="805107" cy="981185"/>
+          </a:xfrm>
+          <a:prstGeom prst="line">
+            <a:avLst/>
+          </a:prstGeom>
+          <a:ln w="12700">
+            <a:solidFill>
+              <a:schemeClr val="tx1"/>
+            </a:solidFill>
+          </a:ln>
+        </p:spPr>
+        <p:style>
+          <a:lnRef idx="1">
+            <a:schemeClr val="accent1"/>
+          </a:lnRef>
+          <a:fillRef idx="0">
+            <a:schemeClr val="accent1"/>
+          </a:fillRef>
+          <a:effectRef idx="0">
+            <a:schemeClr val="accent1"/>
+          </a:effectRef>
+          <a:fontRef idx="minor">
+            <a:schemeClr val="tx1"/>
+          </a:fontRef>
+        </p:style>
+      </p:cxnSp>
+    </p:spTree>
+    <p:extLst>
+      <p:ext uri="{BB962C8B-B14F-4D97-AF65-F5344CB8AC3E}">
+        <p14:creationId xmlns:p14="http://schemas.microsoft.com/office/powerpoint/2010/main" val="3955824805"/>
+      </p:ext>
+    </p:extLst>
+  </p:cSld>
+  <p:clrMapOvr>
+    <a:masterClrMapping/>
+  </p:clrMapOvr>
+</p:sld>
+</file>
+
 <file path=ppt/slides/slide2.xml><?xml version="1.0" encoding="utf-8"?>
 <p:sld xmlns:a="http://schemas.openxmlformats.org/drawingml/2006/main" xmlns:r="http://schemas.openxmlformats.org/officeDocument/2006/relationships" xmlns:p="http://schemas.openxmlformats.org/presentationml/2006/main">
   <p:cSld>
@@ -16537,8 +17514,8 @@
         </p:nvSpPr>
         <p:spPr>
           <a:xfrm>
-            <a:off x="3230880" y="2438400"/>
-            <a:ext cx="4632960" cy="524256"/>
+            <a:off x="3230879" y="2438400"/>
+            <a:ext cx="6402977" cy="524256"/>
           </a:xfrm>
           <a:prstGeom prst="rect">
             <a:avLst/>
@@ -16671,25 +17648,25 @@
                   <a:schemeClr val="bg1"/>
                 </a:solidFill>
               </a:rPr>
-              <a:t>Intent and Ambition</a:t>
+              <a:t>Realizing Our Long Term Ambition</a:t>
             </a:r>
           </a:p>
           <a:p>
             <a:r>
               <a:rPr lang="en-US" dirty="0"/>
-              <a:t>Consortium Opportunity</a:t>
+              <a:t>Staying Focused On Our Opportunity</a:t>
             </a:r>
           </a:p>
           <a:p>
             <a:r>
               <a:rPr lang="en-US" dirty="0"/>
-              <a:t>Success Factors</a:t>
+              <a:t>Doing What It Takes To Succeed</a:t>
             </a:r>
           </a:p>
           <a:p>
             <a:r>
               <a:rPr lang="en-US" dirty="0"/>
-              <a:t>3-Horizon Roadmap for the 2020s</a:t>
+              <a:t>Executing Our 3-Horizon Strategy</a:t>
             </a:r>
           </a:p>
         </p:txBody>
@@ -18763,8 +19740,8 @@
         </p:nvSpPr>
         <p:spPr>
           <a:xfrm>
-            <a:off x="3230880" y="2916936"/>
-            <a:ext cx="4632960" cy="524256"/>
+            <a:off x="3230879" y="2916936"/>
+            <a:ext cx="6402977" cy="524256"/>
           </a:xfrm>
           <a:prstGeom prst="rect">
             <a:avLst/>
@@ -18920,7 +19897,7 @@
           <a:p>
             <a:r>
               <a:rPr lang="en-US" dirty="0"/>
-              <a:t>Intent and Ambition</a:t>
+              <a:t>Realizing Our Long Term Ambition</a:t>
             </a:r>
           </a:p>
           <a:p>
@@ -18935,19 +19912,19 @@
                   <a:schemeClr val="bg1"/>
                 </a:solidFill>
               </a:rPr>
-              <a:t>Consortium Opportunity</a:t>
+              <a:t>Staying Focused On Our Opportunity</a:t>
             </a:r>
           </a:p>
           <a:p>
             <a:r>
               <a:rPr lang="en-US" dirty="0"/>
-              <a:t>Success Factors</a:t>
+              <a:t>Doing What It Takes To Succeed</a:t>
             </a:r>
           </a:p>
           <a:p>
             <a:r>
               <a:rPr lang="en-US" dirty="0"/>
-              <a:t>3-Horizon Roadmap for the 2020s</a:t>
+              <a:t>Executing Our 3-Horizon Strategy</a:t>
             </a:r>
           </a:p>
         </p:txBody>
@@ -19026,7 +20003,7 @@
             </a:pPr>
             <a:r>
               <a:rPr lang="en-US" dirty="0"/>
-              <a:t>Consortium Opportunity</a:t>
+              <a:t>Staying Focused On Our Opportunity</a:t>
             </a:r>
             <a:endParaRPr dirty="0"/>
           </a:p>
@@ -21468,8 +22445,8 @@
         </p:nvSpPr>
         <p:spPr>
           <a:xfrm>
-            <a:off x="3230880" y="3429000"/>
-            <a:ext cx="4632960" cy="524256"/>
+            <a:off x="3230879" y="3429000"/>
+            <a:ext cx="6402977" cy="524256"/>
           </a:xfrm>
           <a:prstGeom prst="rect">
             <a:avLst/>
@@ -21625,13 +22602,13 @@
           <a:p>
             <a:r>
               <a:rPr lang="en-US" dirty="0"/>
-              <a:t>Intent and Ambition</a:t>
+              <a:t>Realizing Our Long Term Ambition</a:t>
             </a:r>
           </a:p>
           <a:p>
             <a:r>
               <a:rPr lang="en-US" dirty="0"/>
-              <a:t>Consortium Opportunity</a:t>
+              <a:t>Staying Focused On Our Opportunity</a:t>
             </a:r>
           </a:p>
           <a:p>
@@ -21646,13 +22623,13 @@
                   <a:schemeClr val="bg1"/>
                 </a:solidFill>
               </a:rPr>
-              <a:t>Success Factors</a:t>
+              <a:t>Doing What It Takes To Succeed</a:t>
             </a:r>
           </a:p>
           <a:p>
             <a:r>
               <a:rPr lang="en-US" dirty="0"/>
-              <a:t>3-Horizon Roadmap for the 2020s</a:t>
+              <a:t>Executing Our 3-Horizon Strategy</a:t>
             </a:r>
           </a:p>
         </p:txBody>

</xml_diff>

<commit_message>
Refined the Product Plan and labeled the Consortium Priorities
</commit_message>
<xml_diff>
--- a/docs/1_Integration/1b_Strategy/AccelRR8 Consortium Non-Profit Organization Strategy.pptx
+++ b/docs/1_Integration/1b_Strategy/AccelRR8 Consortium Non-Profit Organization Strategy.pptx
@@ -306,7 +306,7 @@
 <file path=ppt/revisionInfo.xml><?xml version="1.0" encoding="utf-8"?>
 <p1510:revInfo xmlns:a="http://schemas.openxmlformats.org/drawingml/2006/main" xmlns:r="http://schemas.openxmlformats.org/officeDocument/2006/relationships" xmlns:p1510="http://schemas.microsoft.com/office/powerpoint/2015/10/main">
   <p1510:revLst>
-    <p1510:client id="{CADD2A7E-913D-4848-8702-F40BD19E1117}" v="34" dt="2026-08-14T12:38:39.548"/>
+    <p1510:client id="{CADD2A7E-913D-4848-8702-F40BD19E1117}" v="38" dt="2026-08-14T19:45:02.655"/>
   </p1510:revLst>
 </p1510:revInfo>
 </file>
@@ -316,7 +316,7 @@
   <pc:docChgLst>
     <pc:chgData name="Rich Reba" userId="55db41ab6eb3f845" providerId="LiveId" clId="{0E19DA16-244C-5B50-BE0F-52911DD4CA7E}"/>
     <pc:docChg chg="undo redo custSel addSld delSld modSld sldOrd delMainMaster delSection modSection">
-      <pc:chgData name="Rich Reba" userId="55db41ab6eb3f845" providerId="LiveId" clId="{0E19DA16-244C-5B50-BE0F-52911DD4CA7E}" dt="2026-08-14T12:38:39.547" v="1297"/>
+      <pc:chgData name="Rich Reba" userId="55db41ab6eb3f845" providerId="LiveId" clId="{0E19DA16-244C-5B50-BE0F-52911DD4CA7E}" dt="2026-08-14T19:45:05.395" v="1318" actId="20577"/>
       <pc:docMkLst>
         <pc:docMk/>
       </pc:docMkLst>
@@ -619,12 +619,52 @@
           <pc:sldMk cId="2033129414" sldId="416"/>
         </pc:sldMkLst>
       </pc:sldChg>
-      <pc:sldChg chg="add">
-        <pc:chgData name="Rich Reba" userId="55db41ab6eb3f845" providerId="LiveId" clId="{0E19DA16-244C-5B50-BE0F-52911DD4CA7E}" dt="2026-08-14T12:38:39.547" v="1297"/>
+      <pc:sldChg chg="addSp modSp add mod">
+        <pc:chgData name="Rich Reba" userId="55db41ab6eb3f845" providerId="LiveId" clId="{0E19DA16-244C-5B50-BE0F-52911DD4CA7E}" dt="2026-08-14T19:45:05.395" v="1318" actId="20577"/>
         <pc:sldMkLst>
           <pc:docMk/>
           <pc:sldMk cId="3955824805" sldId="418"/>
         </pc:sldMkLst>
+        <pc:spChg chg="add mod">
+          <ac:chgData name="Rich Reba" userId="55db41ab6eb3f845" providerId="LiveId" clId="{0E19DA16-244C-5B50-BE0F-52911DD4CA7E}" dt="2026-08-14T19:44:34.315" v="1306" actId="2085"/>
+          <ac:spMkLst>
+            <pc:docMk/>
+            <pc:sldMk cId="3955824805" sldId="418"/>
+            <ac:spMk id="2" creationId="{ED98FCF8-CC99-548F-CF88-C67D15D697A4}"/>
+          </ac:spMkLst>
+        </pc:spChg>
+        <pc:spChg chg="add mod">
+          <ac:chgData name="Rich Reba" userId="55db41ab6eb3f845" providerId="LiveId" clId="{0E19DA16-244C-5B50-BE0F-52911DD4CA7E}" dt="2026-08-14T19:44:43.177" v="1309" actId="20577"/>
+          <ac:spMkLst>
+            <pc:docMk/>
+            <pc:sldMk cId="3955824805" sldId="418"/>
+            <ac:spMk id="3" creationId="{E3589252-6570-575A-164F-CA5FE013D01B}"/>
+          </ac:spMkLst>
+        </pc:spChg>
+        <pc:spChg chg="add mod">
+          <ac:chgData name="Rich Reba" userId="55db41ab6eb3f845" providerId="LiveId" clId="{0E19DA16-244C-5B50-BE0F-52911DD4CA7E}" dt="2026-08-14T19:44:49.883" v="1312" actId="20577"/>
+          <ac:spMkLst>
+            <pc:docMk/>
+            <pc:sldMk cId="3955824805" sldId="418"/>
+            <ac:spMk id="4" creationId="{F62977F1-FBE7-3164-8735-A9F4C63A9779}"/>
+          </ac:spMkLst>
+        </pc:spChg>
+        <pc:spChg chg="add mod">
+          <ac:chgData name="Rich Reba" userId="55db41ab6eb3f845" providerId="LiveId" clId="{0E19DA16-244C-5B50-BE0F-52911DD4CA7E}" dt="2026-08-14T19:44:56.619" v="1315" actId="20577"/>
+          <ac:spMkLst>
+            <pc:docMk/>
+            <pc:sldMk cId="3955824805" sldId="418"/>
+            <ac:spMk id="5" creationId="{F1846E38-7555-6EFB-EADE-E580F1C8185D}"/>
+          </ac:spMkLst>
+        </pc:spChg>
+        <pc:spChg chg="add mod">
+          <ac:chgData name="Rich Reba" userId="55db41ab6eb3f845" providerId="LiveId" clId="{0E19DA16-244C-5B50-BE0F-52911DD4CA7E}" dt="2026-08-14T19:45:05.395" v="1318" actId="20577"/>
+          <ac:spMkLst>
+            <pc:docMk/>
+            <pc:sldMk cId="3955824805" sldId="418"/>
+            <ac:spMk id="7" creationId="{E79BAC72-9A8F-A76A-0C60-2900991432F8}"/>
+          </ac:spMkLst>
+        </pc:spChg>
       </pc:sldChg>
     </pc:docChg>
   </pc:docChgLst>
@@ -17464,6 +17504,301 @@
           </a:fontRef>
         </p:style>
       </p:cxnSp>
+      <p:sp>
+        <p:nvSpPr>
+          <p:cNvPr id="2" name="Oval 1">
+            <a:extLst>
+              <a:ext uri="{FF2B5EF4-FFF2-40B4-BE49-F238E27FC236}">
+                <a16:creationId xmlns:a16="http://schemas.microsoft.com/office/drawing/2014/main" id="{ED98FCF8-CC99-548F-CF88-C67D15D697A4}"/>
+              </a:ext>
+            </a:extLst>
+          </p:cNvPr>
+          <p:cNvSpPr/>
+          <p:nvPr/>
+        </p:nvSpPr>
+        <p:spPr>
+          <a:xfrm>
+            <a:off x="10781571" y="2623360"/>
+            <a:ext cx="346794" cy="346794"/>
+          </a:xfrm>
+          <a:prstGeom prst="ellipse">
+            <a:avLst/>
+          </a:prstGeom>
+          <a:solidFill>
+            <a:schemeClr val="tx1"/>
+          </a:solidFill>
+          <a:ln>
+            <a:noFill/>
+          </a:ln>
+        </p:spPr>
+        <p:style>
+          <a:lnRef idx="2">
+            <a:schemeClr val="accent1">
+              <a:shade val="15000"/>
+            </a:schemeClr>
+          </a:lnRef>
+          <a:fillRef idx="1">
+            <a:schemeClr val="accent1"/>
+          </a:fillRef>
+          <a:effectRef idx="0">
+            <a:schemeClr val="accent1"/>
+          </a:effectRef>
+          <a:fontRef idx="minor">
+            <a:schemeClr val="lt1"/>
+          </a:fontRef>
+        </p:style>
+        <p:txBody>
+          <a:bodyPr rtlCol="0" anchor="ctr"/>
+          <a:lstStyle/>
+          <a:p>
+            <a:pPr algn="ctr"/>
+            <a:r>
+              <a:rPr lang="en-US" dirty="0">
+                <a:solidFill>
+                  <a:schemeClr val="bg1"/>
+                </a:solidFill>
+              </a:rPr>
+              <a:t>1</a:t>
+            </a:r>
+          </a:p>
+        </p:txBody>
+      </p:sp>
+      <p:sp>
+        <p:nvSpPr>
+          <p:cNvPr id="3" name="Oval 2">
+            <a:extLst>
+              <a:ext uri="{FF2B5EF4-FFF2-40B4-BE49-F238E27FC236}">
+                <a16:creationId xmlns:a16="http://schemas.microsoft.com/office/drawing/2014/main" id="{E3589252-6570-575A-164F-CA5FE013D01B}"/>
+              </a:ext>
+            </a:extLst>
+          </p:cNvPr>
+          <p:cNvSpPr/>
+          <p:nvPr/>
+        </p:nvSpPr>
+        <p:spPr>
+          <a:xfrm>
+            <a:off x="10781571" y="3358896"/>
+            <a:ext cx="346794" cy="346794"/>
+          </a:xfrm>
+          <a:prstGeom prst="ellipse">
+            <a:avLst/>
+          </a:prstGeom>
+          <a:solidFill>
+            <a:schemeClr val="tx1"/>
+          </a:solidFill>
+          <a:ln>
+            <a:noFill/>
+          </a:ln>
+        </p:spPr>
+        <p:style>
+          <a:lnRef idx="2">
+            <a:schemeClr val="accent1">
+              <a:shade val="15000"/>
+            </a:schemeClr>
+          </a:lnRef>
+          <a:fillRef idx="1">
+            <a:schemeClr val="accent1"/>
+          </a:fillRef>
+          <a:effectRef idx="0">
+            <a:schemeClr val="accent1"/>
+          </a:effectRef>
+          <a:fontRef idx="minor">
+            <a:schemeClr val="lt1"/>
+          </a:fontRef>
+        </p:style>
+        <p:txBody>
+          <a:bodyPr rtlCol="0" anchor="ctr"/>
+          <a:lstStyle/>
+          <a:p>
+            <a:pPr algn="ctr"/>
+            <a:r>
+              <a:rPr lang="en-US" dirty="0">
+                <a:solidFill>
+                  <a:schemeClr val="bg1"/>
+                </a:solidFill>
+              </a:rPr>
+              <a:t>2</a:t>
+            </a:r>
+          </a:p>
+        </p:txBody>
+      </p:sp>
+      <p:sp>
+        <p:nvSpPr>
+          <p:cNvPr id="4" name="Oval 3">
+            <a:extLst>
+              <a:ext uri="{FF2B5EF4-FFF2-40B4-BE49-F238E27FC236}">
+                <a16:creationId xmlns:a16="http://schemas.microsoft.com/office/drawing/2014/main" id="{F62977F1-FBE7-3164-8735-A9F4C63A9779}"/>
+              </a:ext>
+            </a:extLst>
+          </p:cNvPr>
+          <p:cNvSpPr/>
+          <p:nvPr/>
+        </p:nvSpPr>
+        <p:spPr>
+          <a:xfrm>
+            <a:off x="10781571" y="4085675"/>
+            <a:ext cx="346794" cy="346794"/>
+          </a:xfrm>
+          <a:prstGeom prst="ellipse">
+            <a:avLst/>
+          </a:prstGeom>
+          <a:solidFill>
+            <a:schemeClr val="tx1"/>
+          </a:solidFill>
+          <a:ln>
+            <a:noFill/>
+          </a:ln>
+        </p:spPr>
+        <p:style>
+          <a:lnRef idx="2">
+            <a:schemeClr val="accent1">
+              <a:shade val="15000"/>
+            </a:schemeClr>
+          </a:lnRef>
+          <a:fillRef idx="1">
+            <a:schemeClr val="accent1"/>
+          </a:fillRef>
+          <a:effectRef idx="0">
+            <a:schemeClr val="accent1"/>
+          </a:effectRef>
+          <a:fontRef idx="minor">
+            <a:schemeClr val="lt1"/>
+          </a:fontRef>
+        </p:style>
+        <p:txBody>
+          <a:bodyPr rtlCol="0" anchor="ctr"/>
+          <a:lstStyle/>
+          <a:p>
+            <a:pPr algn="ctr"/>
+            <a:r>
+              <a:rPr lang="en-US" dirty="0">
+                <a:solidFill>
+                  <a:schemeClr val="bg1"/>
+                </a:solidFill>
+              </a:rPr>
+              <a:t>3</a:t>
+            </a:r>
+          </a:p>
+        </p:txBody>
+      </p:sp>
+      <p:sp>
+        <p:nvSpPr>
+          <p:cNvPr id="5" name="Oval 4">
+            <a:extLst>
+              <a:ext uri="{FF2B5EF4-FFF2-40B4-BE49-F238E27FC236}">
+                <a16:creationId xmlns:a16="http://schemas.microsoft.com/office/drawing/2014/main" id="{F1846E38-7555-6EFB-EADE-E580F1C8185D}"/>
+              </a:ext>
+            </a:extLst>
+          </p:cNvPr>
+          <p:cNvSpPr/>
+          <p:nvPr/>
+        </p:nvSpPr>
+        <p:spPr>
+          <a:xfrm>
+            <a:off x="10781571" y="4773037"/>
+            <a:ext cx="346794" cy="346794"/>
+          </a:xfrm>
+          <a:prstGeom prst="ellipse">
+            <a:avLst/>
+          </a:prstGeom>
+          <a:solidFill>
+            <a:schemeClr val="tx1"/>
+          </a:solidFill>
+          <a:ln>
+            <a:noFill/>
+          </a:ln>
+        </p:spPr>
+        <p:style>
+          <a:lnRef idx="2">
+            <a:schemeClr val="accent1">
+              <a:shade val="15000"/>
+            </a:schemeClr>
+          </a:lnRef>
+          <a:fillRef idx="1">
+            <a:schemeClr val="accent1"/>
+          </a:fillRef>
+          <a:effectRef idx="0">
+            <a:schemeClr val="accent1"/>
+          </a:effectRef>
+          <a:fontRef idx="minor">
+            <a:schemeClr val="lt1"/>
+          </a:fontRef>
+        </p:style>
+        <p:txBody>
+          <a:bodyPr rtlCol="0" anchor="ctr"/>
+          <a:lstStyle/>
+          <a:p>
+            <a:pPr algn="ctr"/>
+            <a:r>
+              <a:rPr lang="en-US" dirty="0">
+                <a:solidFill>
+                  <a:schemeClr val="bg1"/>
+                </a:solidFill>
+              </a:rPr>
+              <a:t>4</a:t>
+            </a:r>
+          </a:p>
+        </p:txBody>
+      </p:sp>
+      <p:sp>
+        <p:nvSpPr>
+          <p:cNvPr id="7" name="Oval 6">
+            <a:extLst>
+              <a:ext uri="{FF2B5EF4-FFF2-40B4-BE49-F238E27FC236}">
+                <a16:creationId xmlns:a16="http://schemas.microsoft.com/office/drawing/2014/main" id="{E79BAC72-9A8F-A76A-0C60-2900991432F8}"/>
+              </a:ext>
+            </a:extLst>
+          </p:cNvPr>
+          <p:cNvSpPr/>
+          <p:nvPr/>
+        </p:nvSpPr>
+        <p:spPr>
+          <a:xfrm>
+            <a:off x="10781571" y="5455724"/>
+            <a:ext cx="346794" cy="346794"/>
+          </a:xfrm>
+          <a:prstGeom prst="ellipse">
+            <a:avLst/>
+          </a:prstGeom>
+          <a:solidFill>
+            <a:schemeClr val="tx1"/>
+          </a:solidFill>
+          <a:ln>
+            <a:noFill/>
+          </a:ln>
+        </p:spPr>
+        <p:style>
+          <a:lnRef idx="2">
+            <a:schemeClr val="accent1">
+              <a:shade val="15000"/>
+            </a:schemeClr>
+          </a:lnRef>
+          <a:fillRef idx="1">
+            <a:schemeClr val="accent1"/>
+          </a:fillRef>
+          <a:effectRef idx="0">
+            <a:schemeClr val="accent1"/>
+          </a:effectRef>
+          <a:fontRef idx="minor">
+            <a:schemeClr val="lt1"/>
+          </a:fontRef>
+        </p:style>
+        <p:txBody>
+          <a:bodyPr rtlCol="0" anchor="ctr"/>
+          <a:lstStyle/>
+          <a:p>
+            <a:pPr algn="ctr"/>
+            <a:r>
+              <a:rPr lang="en-US" dirty="0">
+                <a:solidFill>
+                  <a:schemeClr val="bg1"/>
+                </a:solidFill>
+              </a:rPr>
+              <a:t>5</a:t>
+            </a:r>
+          </a:p>
+        </p:txBody>
+      </p:sp>
     </p:spTree>
     <p:extLst>
       <p:ext uri="{BB962C8B-B14F-4D97-AF65-F5344CB8AC3E}">

</xml_diff>